<commit_message>
Evolve topic to Poison-Resilient On-Device Intrusion Detection for Drifting IoT
Reframe around the adversarial angle: an attacker who slowly poisons the
detector's own adaptation (boiling-frog attack), plus a lightweight on-device
defense. Adds the attack, the robust update guard, attack-resilience metrics,
and the Group G-04 authors (Rishit Kamboj and Farhan Naik).
</commit_message>
<xml_diff>
--- a/CSD457_First_Presentation.pptx
+++ b/CSD457_First_Presentation.pptx
@@ -126,7 +126,7 @@
           <a:lstStyle/>
           <a:p>
             <a:pPr algn="l">
-              <a:defRPr sz="1300" b="0" i="0" u="none" strike="noStrike">
+              <a:defRPr sz="1250" b="0" i="0" u="none" strike="noStrike">
                 <a:solidFill>
                   <a:srgbClr val="1D1D1F"/>
                 </a:solidFill>
@@ -134,13 +134,13 @@
               </a:defRPr>
             </a:pPr>
             <a:r>
-              <a:rPr sz="1300" b="0" i="0" u="none" strike="noStrike">
+              <a:rPr sz="1250" b="0" i="0" u="none" strike="noStrike">
                 <a:solidFill>
                   <a:srgbClr val="1D1D1F"/>
                 </a:solidFill>
                 <a:latin typeface="Calibri"/>
               </a:rPr>
-              <a:t>False alarms over time</a:t>
+              <a:t>The boiling frog: normal gets walked away</a:t>
             </a:r>
           </a:p>
         </c:rich>
@@ -162,7 +162,7 @@
               <c:strCache>
                 <c:ptCount val="1"/>
                 <c:pt idx="0">
-                  <c:v>Static detector</c:v>
+                  <c:v>Attacker's slow poison</c:v>
                 </c:pt>
               </c:strCache>
             </c:strRef>
@@ -229,25 +229,25 @@
                 <c:ptCount val="7"/>
                 <c:lvl>
                   <c:pt idx="0">
-                    <c:v>Day 1</c:v>
+                    <c:v>t1</c:v>
                   </c:pt>
                   <c:pt idx="1">
-                    <c:v>Day 5</c:v>
+                    <c:v>t2</c:v>
                   </c:pt>
                   <c:pt idx="2">
-                    <c:v>Day 10</c:v>
+                    <c:v>t3</c:v>
                   </c:pt>
                   <c:pt idx="3">
-                    <c:v>Day 15</c:v>
+                    <c:v>t4</c:v>
                   </c:pt>
                   <c:pt idx="4">
-                    <c:v>Day 20</c:v>
+                    <c:v>t5</c:v>
                   </c:pt>
                   <c:pt idx="5">
-                    <c:v>Day 25</c:v>
+                    <c:v>t6</c:v>
                   </c:pt>
                   <c:pt idx="6">
-                    <c:v>Day 30</c:v>
+                    <c:v>t7</c:v>
                   </c:pt>
                 </c:lvl>
               </c:multiLvlStrCache>
@@ -260,25 +260,157 @@
                 <c:formatCode>General</c:formatCode>
                 <c:ptCount val="7"/>
                 <c:pt idx="0">
-                  <c:v>2</c:v>
+                  <c:v>1</c:v>
                 </c:pt>
                 <c:pt idx="1">
-                  <c:v>3</c:v>
+                  <c:v>1.4</c:v>
                 </c:pt>
                 <c:pt idx="2">
-                  <c:v>5</c:v>
+                  <c:v>2.1</c:v>
                 </c:pt>
                 <c:pt idx="3">
-                  <c:v>9</c:v>
+                  <c:v>3.2</c:v>
                 </c:pt>
                 <c:pt idx="4">
-                  <c:v>14</c:v>
+                  <c:v>4.6</c:v>
                 </c:pt>
                 <c:pt idx="5">
-                  <c:v>21</c:v>
+                  <c:v>6.2</c:v>
                 </c:pt>
                 <c:pt idx="6">
-                  <c:v>29</c:v>
+                  <c:v>8</c:v>
+                </c:pt>
+              </c:numCache>
+            </c:numRef>
+          </c:val>
+          <c:smooth val="1"/>
+        </c:ser>
+        <c:ser>
+          <c:idx val="1"/>
+          <c:order val="1"/>
+          <c:tx>
+            <c:strRef>
+              <c:f>Sheet1!$C$1</c:f>
+              <c:strCache>
+                <c:ptCount val="1"/>
+                <c:pt idx="0">
+                  <c:v>Detector's idea of normal</c:v>
+                </c:pt>
+              </c:strCache>
+            </c:strRef>
+          </c:tx>
+          <c:spPr>
+            <a:solidFill>
+              <a:srgbClr val="86868B"/>
+            </a:solidFill>
+            <a:ln w="38100" cap="flat">
+              <a:solidFill>
+                <a:srgbClr val="86868B"/>
+              </a:solidFill>
+              <a:prstDash val="solid"/>
+              <a:round/>
+            </a:ln>
+            <a:effectLst/>
+          </c:spPr>
+          <c:invertIfNegative val="0"/>
+          <c:dLbls>
+            <c:numFmt formatCode="#,##0" sourceLinked="0"/>
+            <c:txPr>
+              <a:bodyPr/>
+              <a:lstStyle/>
+              <a:p>
+                <a:pPr>
+                  <a:defRPr b="0" i="0" strike="noStrike" sz="1200" u="none">
+                    <a:solidFill>
+                      <a:srgbClr val="000000"/>
+                    </a:solidFill>
+                    <a:latin typeface="Arial"/>
+                  </a:defRPr>
+                </a:pPr>
+              </a:p>
+            </c:txPr>
+            <c:showLegendKey val="0"/>
+            <c:showVal val="0"/>
+            <c:showCatName val="0"/>
+            <c:showSerName val="0"/>
+            <c:showPercent val="0"/>
+            <c:showBubbleSize val="0"/>
+            <c:showLeaderLines val="0"/>
+          </c:dLbls>
+          <c:marker>
+            <c:symbol val="circle"/>
+            <c:size val="6"/>
+            <c:spPr>
+              <a:solidFill>
+                <a:srgbClr val="86868B"/>
+              </a:solidFill>
+              <a:ln w="9525" cap="flat">
+                <a:solidFill>
+                  <a:srgbClr val="86868B"/>
+                </a:solidFill>
+                <a:prstDash val="solid"/>
+                <a:round/>
+              </a:ln>
+              <a:effectLst/>
+            </c:spPr>
+          </c:marker>
+          <c:cat>
+            <c:multiLvlStrRef>
+              <c:f>Sheet1!$A$2:$A$8</c:f>
+              <c:multiLvlStrCache>
+                <c:ptCount val="7"/>
+                <c:lvl>
+                  <c:pt idx="0">
+                    <c:v>t1</c:v>
+                  </c:pt>
+                  <c:pt idx="1">
+                    <c:v>t2</c:v>
+                  </c:pt>
+                  <c:pt idx="2">
+                    <c:v>t3</c:v>
+                  </c:pt>
+                  <c:pt idx="3">
+                    <c:v>t4</c:v>
+                  </c:pt>
+                  <c:pt idx="4">
+                    <c:v>t5</c:v>
+                  </c:pt>
+                  <c:pt idx="5">
+                    <c:v>t6</c:v>
+                  </c:pt>
+                  <c:pt idx="6">
+                    <c:v>t7</c:v>
+                  </c:pt>
+                </c:lvl>
+              </c:multiLvlStrCache>
+            </c:multiLvlStrRef>
+          </c:cat>
+          <c:val>
+            <c:numRef>
+              <c:f>Sheet1!$C$2:$C$8</c:f>
+              <c:numCache>
+                <c:formatCode>General</c:formatCode>
+                <c:ptCount val="7"/>
+                <c:pt idx="0">
+                  <c:v>1</c:v>
+                </c:pt>
+                <c:pt idx="1">
+                  <c:v>1.3</c:v>
+                </c:pt>
+                <c:pt idx="2">
+                  <c:v>1.9</c:v>
+                </c:pt>
+                <c:pt idx="3">
+                  <c:v>2.9</c:v>
+                </c:pt>
+                <c:pt idx="4">
+                  <c:v>4.2</c:v>
+                </c:pt>
+                <c:pt idx="5">
+                  <c:v>5.8</c:v>
+                </c:pt>
+                <c:pt idx="6">
+                  <c:v>7.6</c:v>
                 </c:pt>
               </c:numCache>
             </c:numRef>
@@ -359,7 +491,7 @@
         <c:axId val="2094734552"/>
         <c:scaling>
           <c:orientation val="minMax"/>
-          <c:max val="30"/>
+          <c:max val="8"/>
           <c:min val="0"/>
         </c:scaling>
         <c:delete val="0"/>
@@ -406,7 +538,7 @@
         <c:crossAx val="2094734554"/>
         <c:crosses val="autoZero"/>
         <c:crossBetween val="between"/>
-        <c:majorUnit val="10"/>
+        <c:majorUnit val="2"/>
       </c:valAx>
       <c:spPr>
         <a:noFill/>
@@ -416,6 +548,26 @@
         <a:effectLst/>
       </c:spPr>
     </c:plotArea>
+    <c:legend>
+      <c:legendPos val="b"/>
+      <c:overlay val="0"/>
+      <c:txPr>
+        <a:bodyPr/>
+        <a:lstStyle/>
+        <a:p>
+          <a:pPr>
+            <a:defRPr sz="900">
+              <a:solidFill>
+                <a:srgbClr val="86868B"/>
+              </a:solidFill>
+              <a:latin typeface="Calibri"/>
+              <a:cs typeface="Calibri"/>
+            </a:defRPr>
+          </a:pPr>
+          <a:endParaRPr lang="en-US"/>
+        </a:p>
+      </c:txPr>
+    </c:legend>
     <c:plotVisOnly val="1"/>
     <c:dispBlanksAs val="span"/>
   </c:chart>
@@ -827,7 +979,7 @@
           <a:p>
             <a:r>
               <a:rPr lang="en-US" dirty="0"/>
-              <a:t>This is my proposal for the IoT research project. The one line under the title is the whole idea: run intrusion detection on the device itself, and keep it from getting noisy as the device's behavior naturally changes over time.</a:t>
+              <a:t>Our project. In one line: on-device intrusion detection that stays fresh by adapting, but does not let an attacker abuse that adaptation. The detector adapts to honest change, and refuses to be slowly walked off course by a poisoning attack.</a:t>
             </a:r>
             <a:endParaRPr lang="en-US" dirty="0"/>
           </a:p>
@@ -915,7 +1067,7 @@
           <a:p>
             <a:r>
               <a:rPr lang="en-US" dirty="0"/>
-              <a:t>The core pain: on-device detection is the right instinct, but a static model decays. Every legitimate change in behavior looks suspicious, so the false-positive rate climbs and the alerts get ignored. Cloud retraining is not a real option on a microcontroller.</a:t>
+              <a:t>The tension is the whole project. A static detector is safe from this but goes stale. A naive adaptive detector stays fresh but can be led by the nose. The attacker never triggers an alarm, they just teach the detector that their behavior is normal.</a:t>
             </a:r>
             <a:endParaRPr lang="en-US" dirty="0"/>
           </a:p>
@@ -1003,7 +1155,7 @@
           <a:p>
             <a:r>
               <a:rPr lang="en-US" dirty="0"/>
-              <a:t>Two halves. On the left, what the literature gives me: static on-device detectors, and drift methods that are too heavy for a chip. On the right, the gap that falls between them, which is exactly what I want to close. I will back this with five recent papers.</a:t>
+              <a:t>Left, the two halves that exist but do not meet: static detectors and poisonable adaptive ones. Right, the gap, a detector that gets the good of adaptation without the risk, small enough for a chip, with the cost actually measured.</a:t>
             </a:r>
             <a:endParaRPr lang="en-US" dirty="0"/>
           </a:p>
@@ -1091,7 +1243,7 @@
           <a:p>
             <a:r>
               <a:rPr lang="en-US" dirty="0"/>
-              <a:t>This is the single question the whole project answers. I keep it tight: unsupervised, on the ESP32, low false positives under drift, no labels, no cloud. The line below is my hypothesis, which the experiments will confirm or reject.</a:t>
+              <a:t>One question the project answers. Two blue phrases are the tension: adapt to benign drift, resist adversarial drift, on the chip. The line below is the hypothesis the experiments confirm or reject.</a:t>
             </a:r>
             <a:endParaRPr lang="en-US" dirty="0"/>
           </a:p>
@@ -1179,7 +1331,7 @@
           <a:p>
             <a:r>
               <a:rPr lang="en-US" dirty="0"/>
-              <a:t>Four parts. Features and detector are standard and kept deliberately small. Part three is my contribution: a light layer that notices drift and adjusts, instead of raising an alarm. Part four is the honesty check, measuring the real cost on the board.</a:t>
+              <a:t>Four parts, and the shape reviewers like: an attack and a defense. Detector and drift tracking are standard and kept small. Part two is the boiling-frog attack we build. Part three is our contribution, the guard that refuses to be poisoned. Part four measures what it costs on the board.</a:t>
             </a:r>
             <a:endParaRPr lang="en-US" dirty="0"/>
           </a:p>
@@ -1267,7 +1419,7 @@
           <a:p>
             <a:r>
               <a:rPr lang="en-US" dirty="0"/>
-              <a:t>Everything here is standard and reachable. The hardware is a five dollar board. The datasets are public and modern. On the right are the baselines I have to beat or match, so my comparison is fair and not a straw man.</a:t>
+              <a:t>Everything is reachable: a five dollar board, public modern datasets, standard libraries. On the right, the baselines. The one that matters is the naive adaptive detector, because our whole claim is that we keep its freshness without its weakness.</a:t>
             </a:r>
             <a:endParaRPr lang="en-US" dirty="0"/>
           </a:p>
@@ -1355,7 +1507,7 @@
           <a:p>
             <a:r>
               <a:rPr lang="en-US" dirty="0"/>
-              <a:t>The claim lives or dies on one metric: false positives staying flat under drift. But I will not ignore the rest. Detection quality proves I did not just mute the alarm, and the on-chip numbers prove it actually runs on the board.</a:t>
+              <a:t>The headline number is the attack: how far it walks a naive detector, and how much detection ours keeps under the same attack. Then detection quality proves I did not just mute the alarm, benign-drift stability proves I did not break adaptation, and the chip numbers prove it runs for real.</a:t>
             </a:r>
             <a:endParaRPr lang="en-US" dirty="0"/>
           </a:p>
@@ -1443,7 +1595,7 @@
           <a:p>
             <a:r>
               <a:rPr lang="en-US" dirty="0"/>
-              <a:t>Where this lands: a detector that keeps working on a device without babysitting, and an honest account of what that costs in memory and energy. The timeline shows the path from today's proposal to the final system and report.</a:t>
+              <a:t>Where this lands: an attack that proves the risk, a defense that answers it on a real board, and an honest account of its cost. That attack-plus-defense form is what pushes the work toward paper level. The timeline shows the path from today to the final system.</a:t>
             </a:r>
             <a:endParaRPr lang="en-US" dirty="0"/>
           </a:p>
@@ -1845,7 +1997,7 @@
         <p:spPr>
           <a:xfrm>
             <a:off x="1024128" y="722376"/>
-            <a:ext cx="7315200" cy="292608"/>
+            <a:ext cx="8686800" cy="292608"/>
           </a:xfrm>
           <a:prstGeom prst="rect">
             <a:avLst/>
@@ -1869,7 +2021,7 @@
                 <a:ea typeface="Calibri" pitchFamily="34" charset="-122"/>
                 <a:cs typeface="Calibri" pitchFamily="34" charset="-120"/>
               </a:rPr>
-              <a:t>CSD457  ·  INTERNET OF THINGS</a:t>
+              <a:t>CSD457  ·  INTERNET OF THINGS  ·  GROUP G-04</a:t>
             </a:r>
             <a:endParaRPr lang="en-US" sz="1250" dirty="0"/>
           </a:p>
@@ -1883,8 +2035,8 @@
         </p:nvSpPr>
         <p:spPr>
           <a:xfrm>
-            <a:off x="822960" y="2148840"/>
-            <a:ext cx="10332720" cy="1828800"/>
+            <a:off x="822960" y="1965960"/>
+            <a:ext cx="10515600" cy="2011680"/>
           </a:xfrm>
           <a:prstGeom prst="rect">
             <a:avLst/>
@@ -1898,12 +2050,12 @@
           <a:p>
             <a:pPr indent="0" marL="0">
               <a:lnSpc>
-                <a:spcPct val="102000"/>
+                <a:spcPct val="103000"/>
               </a:lnSpc>
               <a:buNone/>
             </a:pPr>
             <a:r>
-              <a:rPr lang="en-US" sz="4600" b="1" dirty="0">
+              <a:rPr lang="en-US" sz="4400" b="1" dirty="0">
                 <a:solidFill>
                   <a:srgbClr val="0071E3"/>
                 </a:solidFill>
@@ -1911,16 +2063,16 @@
                 <a:ea typeface="Calibri" pitchFamily="34" charset="-122"/>
                 <a:cs typeface="Calibri" pitchFamily="34" charset="-120"/>
               </a:rPr>
-              <a:t>Drift-Aware </a:t>
+              <a:t>Poison-Resilient </a:t>
             </a:r>
             <a:pPr indent="0" marL="0">
               <a:lnSpc>
-                <a:spcPct val="102000"/>
+                <a:spcPct val="103000"/>
               </a:lnSpc>
               <a:buNone/>
             </a:pPr>
             <a:r>
-              <a:rPr lang="en-US" sz="4600" b="1" dirty="0">
+              <a:rPr lang="en-US" sz="4400" b="1" dirty="0">
                 <a:solidFill>
                   <a:srgbClr val="FFFFFF"/>
                 </a:solidFill>
@@ -1928,9 +2080,9 @@
                 <a:ea typeface="Calibri" pitchFamily="34" charset="-122"/>
                 <a:cs typeface="Calibri" pitchFamily="34" charset="-120"/>
               </a:rPr>
-              <a:t>On-Device Intrusion Detection for IoT</a:t>
-            </a:r>
-            <a:endParaRPr lang="en-US" sz="4600" dirty="0"/>
+              <a:t>On-Device Intrusion Detection for Drifting IoT</a:t>
+            </a:r>
+            <a:endParaRPr lang="en-US" sz="4400" dirty="0"/>
           </a:p>
         </p:txBody>
       </p:sp>
@@ -1942,8 +2094,8 @@
         </p:nvSpPr>
         <p:spPr>
           <a:xfrm>
-            <a:off x="822960" y="4069080"/>
-            <a:ext cx="9692640" cy="548640"/>
+            <a:off x="822960" y="4160520"/>
+            <a:ext cx="9966960" cy="822960"/>
           </a:xfrm>
           <a:prstGeom prst="rect">
             <a:avLst/>
@@ -1956,10 +2108,13 @@
           <a:lstStyle/>
           <a:p>
             <a:pPr indent="0" marL="0">
-              <a:buNone/>
-            </a:pPr>
-            <a:r>
-              <a:rPr lang="en-US" sz="1900" dirty="0">
+              <a:lnSpc>
+                <a:spcPct val="110000"/>
+              </a:lnSpc>
+              <a:buNone/>
+            </a:pPr>
+            <a:r>
+              <a:rPr lang="en-US" sz="1800" dirty="0">
                 <a:solidFill>
                   <a:srgbClr val="C7C7CC"/>
                 </a:solidFill>
@@ -1967,9 +2122,9 @@
                 <a:ea typeface="Calibri" pitchFamily="34" charset="-122"/>
                 <a:cs typeface="Calibri" pitchFamily="34" charset="-120"/>
               </a:rPr>
-              <a:t>Keeping false alarms low as a device's normal behavior changes, all on an ESP32.</a:t>
-            </a:r>
-            <a:endParaRPr lang="en-US" sz="1900" dirty="0"/>
+              <a:t>A drift-adaptive TinyML detector on an ESP32 that resists attackers who slowly poison its own adaptation.</a:t>
+            </a:r>
+            <a:endParaRPr lang="en-US" sz="1800" dirty="0"/>
           </a:p>
         </p:txBody>
       </p:sp>
@@ -1981,8 +2136,8 @@
         </p:nvSpPr>
         <p:spPr>
           <a:xfrm>
-            <a:off x="822960" y="5989320"/>
-            <a:ext cx="10332720" cy="365760"/>
+            <a:off x="822960" y="6035040"/>
+            <a:ext cx="10515600" cy="365760"/>
           </a:xfrm>
           <a:prstGeom prst="rect">
             <a:avLst/>
@@ -2020,7 +2175,7 @@
                 <a:ea typeface="Calibri" pitchFamily="34" charset="-122"/>
                 <a:cs typeface="Calibri" pitchFamily="34" charset="-120"/>
               </a:rPr>
-              <a:t>        Rishit Kamboj and [teammate]        24 September</a:t>
+              <a:t>        Rishit Kamboj and Farhan Naik        24 September</a:t>
             </a:r>
             <a:endParaRPr lang="en-US" sz="1300" dirty="0"/>
           </a:p>
@@ -2087,7 +2242,7 @@
         <p:spPr>
           <a:xfrm>
             <a:off x="1024128" y="676656"/>
-            <a:ext cx="7315200" cy="292608"/>
+            <a:ext cx="8686800" cy="292608"/>
           </a:xfrm>
           <a:prstGeom prst="rect">
             <a:avLst/>
@@ -2126,7 +2281,7 @@
         <p:spPr>
           <a:xfrm>
             <a:off x="822960" y="1234440"/>
-            <a:ext cx="5760720" cy="1280160"/>
+            <a:ext cx="5806440" cy="1554480"/>
           </a:xfrm>
           <a:prstGeom prst="rect">
             <a:avLst/>
@@ -2140,12 +2295,12 @@
           <a:p>
             <a:pPr indent="0" marL="0">
               <a:lnSpc>
-                <a:spcPct val="103000"/>
+                <a:spcPct val="104000"/>
               </a:lnSpc>
               <a:buNone/>
             </a:pPr>
             <a:r>
-              <a:rPr lang="en-US" sz="3200" b="1" dirty="0">
+              <a:rPr lang="en-US" sz="2900" b="1" dirty="0">
                 <a:solidFill>
                   <a:srgbClr val="1D1D1F"/>
                 </a:solidFill>
@@ -2153,9 +2308,9 @@
                 <a:ea typeface="Calibri" pitchFamily="34" charset="-122"/>
                 <a:cs typeface="Calibri" pitchFamily="34" charset="-120"/>
               </a:rPr>
-              <a:t>A detector I train once slowly turns into a nuisance.</a:t>
-            </a:r>
-            <a:endParaRPr lang="en-US" sz="3200" dirty="0"/>
+              <a:t>To stay accurate, the detector must adapt. Adapting is exactly what an attacker abuses.</a:t>
+            </a:r>
+            <a:endParaRPr lang="en-US" sz="2900" dirty="0"/>
           </a:p>
         </p:txBody>
       </p:sp>
@@ -2167,8 +2322,8 @@
         </p:nvSpPr>
         <p:spPr>
           <a:xfrm>
-            <a:off x="822960" y="2697480"/>
-            <a:ext cx="5760720" cy="2926080"/>
+            <a:off x="822960" y="2971800"/>
+            <a:ext cx="5806440" cy="2743200"/>
           </a:xfrm>
           <a:prstGeom prst="rect">
             <a:avLst/>
@@ -2190,7 +2345,7 @@
               <a:buNone/>
             </a:pPr>
             <a:r>
-              <a:rPr lang="en-US" sz="1650" dirty="0">
+              <a:rPr lang="en-US" sz="1600" dirty="0">
                 <a:solidFill>
                   <a:srgbClr val="424245"/>
                 </a:solidFill>
@@ -2198,9 +2353,9 @@
                 <a:ea typeface="Calibri" pitchFamily="34" charset="-122"/>
                 <a:cs typeface="Calibri" pitchFamily="34" charset="-120"/>
               </a:rPr>
-              <a:t>IoT devices get attacked, so detecting attacks on the device itself is appealing: it is fast, private, and needs no cloud.</a:t>
-            </a:r>
-            <a:endParaRPr lang="en-US" sz="1650" dirty="0"/>
+              <a:t>On-device detection is the right instinct: fast, private, no cloud.</a:t>
+            </a:r>
+            <a:endParaRPr lang="en-US" sz="1600" dirty="0"/>
           </a:p>
           <a:p>
             <a:pPr indent="0" marL="0">
@@ -2213,7 +2368,7 @@
               <a:buNone/>
             </a:pPr>
             <a:r>
-              <a:rPr lang="en-US" sz="1650" dirty="0">
+              <a:rPr lang="en-US" sz="1600" dirty="0">
                 <a:solidFill>
                   <a:srgbClr val="424245"/>
                 </a:solidFill>
@@ -2221,9 +2376,9 @@
                 <a:ea typeface="Calibri" pitchFamily="34" charset="-122"/>
                 <a:cs typeface="Calibri" pitchFamily="34" charset="-120"/>
               </a:rPr>
-              <a:t>But a device's normal behavior keeps shifting: new firmware, new apps, changing usage.</a:t>
-            </a:r>
-            <a:endParaRPr lang="en-US" sz="1650" dirty="0"/>
+              <a:t>But a device's normal behavior keeps drifting, so the detector has to update itself from live traffic.</a:t>
+            </a:r>
+            <a:endParaRPr lang="en-US" sz="1600" dirty="0"/>
           </a:p>
           <a:p>
             <a:pPr indent="0" marL="0">
@@ -2233,7 +2388,7 @@
               <a:buNone/>
             </a:pPr>
             <a:r>
-              <a:rPr lang="en-US" sz="1650" dirty="0">
+              <a:rPr lang="en-US" sz="1600" dirty="0">
                 <a:solidFill>
                   <a:srgbClr val="424245"/>
                 </a:solidFill>
@@ -2241,9 +2396,9 @@
                 <a:ea typeface="Calibri" pitchFamily="34" charset="-122"/>
                 <a:cs typeface="Calibri" pitchFamily="34" charset="-120"/>
               </a:rPr>
-              <a:t>A frozen detector reads that drift as an attack, so false alarms pile up until nobody trusts it. Retraining in the cloud is too heavy and too invasive for a tiny chip.</a:t>
-            </a:r>
-            <a:endParaRPr lang="en-US" sz="1650" dirty="0"/>
+              <a:t>An attacker can hide in that update: feed tiny, slow changes that look like ordinary drift, until a real attack no longer looks abnormal. A boiling-frog poisoning attack.</a:t>
+            </a:r>
+            <a:endParaRPr lang="en-US" sz="1600" dirty="0"/>
           </a:p>
         </p:txBody>
       </p:sp>
@@ -2254,8 +2409,8 @@
           <p:nvPr/>
         </p:nvGraphicFramePr>
         <p:xfrm>
-          <a:off x="7040880" y="1554480"/>
-          <a:ext cx="4480560" cy="3566160"/>
+          <a:off x="7086600" y="1554480"/>
+          <a:ext cx="4434840" cy="3566160"/>
         </p:xfrm>
         <a:graphic xmlns:a="http://schemas.openxmlformats.org/drawingml/2006/main">
           <a:graphicData uri="http://schemas.openxmlformats.org/drawingml/2006/chart">
@@ -2271,8 +2426,8 @@
         </p:nvSpPr>
         <p:spPr>
           <a:xfrm>
-            <a:off x="7040880" y="5166360"/>
-            <a:ext cx="4480560" cy="274320"/>
+            <a:off x="7086600" y="5138928"/>
+            <a:ext cx="4434840" cy="320040"/>
           </a:xfrm>
           <a:prstGeom prst="rect">
             <a:avLst/>
@@ -2288,7 +2443,7 @@
               <a:buNone/>
             </a:pPr>
             <a:r>
-              <a:rPr lang="en-US" sz="1050" i="1" dirty="0">
+              <a:rPr lang="en-US" sz="1000" i="1" dirty="0">
                 <a:solidFill>
                   <a:srgbClr val="86868B"/>
                 </a:solidFill>
@@ -2296,9 +2451,9 @@
                 <a:ea typeface="Calibri" pitchFamily="34" charset="-122"/>
                 <a:cs typeface="Calibri" pitchFamily="34" charset="-120"/>
               </a:rPr>
-              <a:t>Illustrative. A model that never adapts drifts out of calibration.</a:t>
-            </a:r>
-            <a:endParaRPr lang="en-US" sz="1050" dirty="0"/>
+              <a:t>Illustrative. The detector chases the poison, so the boundary drifts to where the attack is safe.</a:t>
+            </a:r>
+            <a:endParaRPr lang="en-US" sz="1000" dirty="0"/>
           </a:p>
         </p:txBody>
       </p:sp>
@@ -2363,7 +2518,7 @@
         <p:spPr>
           <a:xfrm>
             <a:off x="1024128" y="676656"/>
-            <a:ext cx="7315200" cy="292608"/>
+            <a:ext cx="8686800" cy="292608"/>
           </a:xfrm>
           <a:prstGeom prst="rect">
             <a:avLst/>
@@ -2421,7 +2576,7 @@
               <a:buNone/>
             </a:pPr>
             <a:r>
-              <a:rPr lang="en-US" sz="2700" b="1" dirty="0">
+              <a:rPr lang="en-US" sz="2600" b="1" dirty="0">
                 <a:solidFill>
                   <a:srgbClr val="1D1D1F"/>
                 </a:solidFill>
@@ -2429,9 +2584,9 @@
                 <a:ea typeface="Calibri" pitchFamily="34" charset="-122"/>
                 <a:cs typeface="Calibri" pitchFamily="34" charset="-120"/>
               </a:rPr>
-              <a:t>The pieces already exist. Nobody has put them together on a microcontroller.</a:t>
-            </a:r>
-            <a:endParaRPr lang="en-US" sz="2700" dirty="0"/>
+              <a:t>Detectors are either safe-but-stale or fresh-but-poisonable. Nobody has both on a chip.</a:t>
+            </a:r>
+            <a:endParaRPr lang="en-US" sz="2600" dirty="0"/>
           </a:p>
         </p:txBody>
       </p:sp>
@@ -2443,7 +2598,7 @@
         </p:nvSpPr>
         <p:spPr>
           <a:xfrm>
-            <a:off x="822960" y="2331720"/>
+            <a:off x="822960" y="2377440"/>
             <a:ext cx="5394960" cy="365760"/>
           </a:xfrm>
           <a:prstGeom prst="rect">
@@ -2482,7 +2637,7 @@
         </p:nvSpPr>
         <p:spPr>
           <a:xfrm>
-            <a:off x="822960" y="2788920"/>
+            <a:off x="822960" y="2834640"/>
             <a:ext cx="5394960" cy="2468880"/>
           </a:xfrm>
           <a:prstGeom prst="rect">
@@ -2506,7 +2661,7 @@
               <a:buChar char="•"/>
             </a:pPr>
             <a:r>
-              <a:rPr lang="en-US" sz="1550" dirty="0">
+              <a:rPr lang="en-US" sz="1500" dirty="0">
                 <a:solidFill>
                   <a:srgbClr val="424245"/>
                 </a:solidFill>
@@ -2514,9 +2669,9 @@
                 <a:ea typeface="Calibri" pitchFamily="34" charset="-122"/>
                 <a:cs typeface="Calibri" pitchFamily="34" charset="-120"/>
               </a:rPr>
-              <a:t>On-device anomaly detectors (Kitsune, N-BaIoT) are trained once and never adapt.</a:t>
-            </a:r>
-            <a:endParaRPr lang="en-US" sz="1550" dirty="0"/>
+              <a:t>On-device detectors (Kitsune, N-BaIoT) are trained once and go stale as behavior drifts.</a:t>
+            </a:r>
+            <a:endParaRPr lang="en-US" sz="1500" dirty="0"/>
           </a:p>
           <a:p>
             <a:pPr marL="228600" indent="-228600">
@@ -2530,7 +2685,7 @@
               <a:buChar char="•"/>
             </a:pPr>
             <a:r>
-              <a:rPr lang="en-US" sz="1550" dirty="0">
+              <a:rPr lang="en-US" sz="1500" dirty="0">
                 <a:solidFill>
                   <a:srgbClr val="424245"/>
                 </a:solidFill>
@@ -2538,9 +2693,9 @@
                 <a:ea typeface="Calibri" pitchFamily="34" charset="-122"/>
                 <a:cs typeface="Calibri" pitchFamily="34" charset="-120"/>
               </a:rPr>
-              <a:t>Drift-handling methods (ADWIN, Page-Hinkley) work well, but assume a server's memory and power.</a:t>
-            </a:r>
-            <a:endParaRPr lang="en-US" sz="1550" dirty="0"/>
+              <a:t>Drift methods (ADWIN, Page-Hinkley) adapt well, but trust their own updates, so they can be poisoned.</a:t>
+            </a:r>
+            <a:endParaRPr lang="en-US" sz="1500" dirty="0"/>
           </a:p>
           <a:p>
             <a:pPr marL="228600" indent="-228600">
@@ -2551,7 +2706,7 @@
               <a:buChar char="•"/>
             </a:pPr>
             <a:r>
-              <a:rPr lang="en-US" sz="1550" dirty="0">
+              <a:rPr lang="en-US" sz="1500" dirty="0">
                 <a:solidFill>
                   <a:srgbClr val="424245"/>
                 </a:solidFill>
@@ -2559,9 +2714,9 @@
                 <a:ea typeface="Calibri" pitchFamily="34" charset="-122"/>
                 <a:cs typeface="Calibri" pitchFamily="34" charset="-120"/>
               </a:rPr>
-              <a:t>Most IoT security papers chase detection accuracy, not false-alarm stability or real device cost.</a:t>
-            </a:r>
-            <a:endParaRPr lang="en-US" sz="1550" dirty="0"/>
+              <a:t>Robust-learning work targets big server models, not an unsupervised detector on a microcontroller.</a:t>
+            </a:r>
+            <a:endParaRPr lang="en-US" sz="1500" dirty="0"/>
           </a:p>
         </p:txBody>
       </p:sp>
@@ -2573,7 +2728,7 @@
         </p:nvSpPr>
         <p:spPr>
           <a:xfrm>
-            <a:off x="6537960" y="2286000"/>
+            <a:off x="6537960" y="2331720"/>
             <a:ext cx="4983480" cy="3063240"/>
           </a:xfrm>
           <a:prstGeom prst="roundRect">
@@ -2595,7 +2750,7 @@
         </p:nvSpPr>
         <p:spPr>
           <a:xfrm>
-            <a:off x="6858000" y="2560320"/>
+            <a:off x="6858000" y="2606040"/>
             <a:ext cx="4389120" cy="365760"/>
           </a:xfrm>
           <a:prstGeom prst="rect">
@@ -2634,8 +2789,8 @@
         </p:nvSpPr>
         <p:spPr>
           <a:xfrm>
-            <a:off x="6858000" y="3063240"/>
-            <a:ext cx="4389120" cy="1828800"/>
+            <a:off x="6858000" y="3108960"/>
+            <a:ext cx="4389120" cy="1920240"/>
           </a:xfrm>
           <a:prstGeom prst="rect">
             <a:avLst/>
@@ -2649,12 +2804,12 @@
           <a:p>
             <a:pPr indent="0" marL="0">
               <a:lnSpc>
-                <a:spcPct val="112000"/>
+                <a:spcPct val="114000"/>
               </a:lnSpc>
               <a:buNone/>
             </a:pPr>
             <a:r>
-              <a:rPr lang="en-US" sz="1800" dirty="0">
+              <a:rPr lang="en-US" sz="1750" dirty="0">
                 <a:solidFill>
                   <a:srgbClr val="1D1D1F"/>
                 </a:solidFill>
@@ -2662,9 +2817,9 @@
                 <a:ea typeface="Calibri" pitchFamily="34" charset="-122"/>
                 <a:cs typeface="Calibri" pitchFamily="34" charset="-120"/>
               </a:rPr>
-              <a:t>No lightweight, label-free detector keeps false alarms low as behavior drifts, while still fitting inside an ESP32's memory and energy budget.</a:t>
-            </a:r>
-            <a:endParaRPr lang="en-US" sz="1800" dirty="0"/>
+              <a:t>No lightweight detector adapts to benign drift while resisting adversarial drift, and none reports what that resilience costs on a real ESP32.</a:t>
+            </a:r>
+            <a:endParaRPr lang="en-US" sz="1750" dirty="0"/>
           </a:p>
         </p:txBody>
       </p:sp>
@@ -2701,7 +2856,7 @@
                 <a:ea typeface="Calibri" pitchFamily="34" charset="-122"/>
                 <a:cs typeface="Calibri" pitchFamily="34" charset="-120"/>
               </a:rPr>
-              <a:t>Grounded in 5 papers: Kitsune, N-BaIoT, a concept-drift survey, ADWIN, and the CIC-IoT-2023 dataset.</a:t>
+              <a:t>Grounded in 5 papers: Kitsune, N-BaIoT, a concept-drift survey, ADWIN, and CIC-IoT-2023.</a:t>
             </a:r>
             <a:endParaRPr lang="en-US" sz="1150" dirty="0"/>
           </a:p>
@@ -2768,7 +2923,7 @@
         <p:spPr>
           <a:xfrm>
             <a:off x="1024128" y="813816"/>
-            <a:ext cx="7315200" cy="292608"/>
+            <a:ext cx="8686800" cy="292608"/>
           </a:xfrm>
           <a:prstGeom prst="rect">
             <a:avLst/>
@@ -2834,7 +2989,7 @@
                 <a:ea typeface="Calibri" pitchFamily="34" charset="-122"/>
                 <a:cs typeface="Calibri" pitchFamily="34" charset="-120"/>
               </a:rPr>
-              <a:t>Can an unsupervised detector, running entirely on an ESP32, keep its </a:t>
+              <a:t>Can an unsupervised on-device detector </a:t>
             </a:r>
             <a:pPr indent="0" marL="0">
               <a:lnSpc>
@@ -2851,7 +3006,7 @@
                 <a:ea typeface="Calibri" pitchFamily="34" charset="-122"/>
                 <a:cs typeface="Calibri" pitchFamily="34" charset="-120"/>
               </a:rPr>
-              <a:t>false-positive rate low</a:t>
+              <a:t>adapt to benign drift</a:t>
             </a:r>
             <a:pPr indent="0" marL="0">
               <a:lnSpc>
@@ -2868,7 +3023,7 @@
                 <a:ea typeface="Calibri" pitchFamily="34" charset="-122"/>
                 <a:cs typeface="Calibri" pitchFamily="34" charset="-120"/>
               </a:rPr>
-              <a:t> as normal behavior </a:t>
+              <a:t> while </a:t>
             </a:r>
             <a:pPr indent="0" marL="0">
               <a:lnSpc>
@@ -2885,7 +3040,7 @@
                 <a:ea typeface="Calibri" pitchFamily="34" charset="-122"/>
                 <a:cs typeface="Calibri" pitchFamily="34" charset="-120"/>
               </a:rPr>
-              <a:t>drifts over time</a:t>
+              <a:t>resisting slow poisoning</a:t>
             </a:r>
             <a:pPr indent="0" marL="0">
               <a:lnSpc>
@@ -2902,7 +3057,7 @@
                 <a:ea typeface="Calibri" pitchFamily="34" charset="-122"/>
                 <a:cs typeface="Calibri" pitchFamily="34" charset="-120"/>
               </a:rPr>
-              <a:t>, without any labels or cloud retraining?</a:t>
+              <a:t> of its own updates, and still fit an ESP32's memory and energy budget?</a:t>
             </a:r>
             <a:endParaRPr lang="en-US" sz="3300" dirty="0"/>
           </a:p>
@@ -2916,8 +3071,8 @@
         </p:nvSpPr>
         <p:spPr>
           <a:xfrm>
-            <a:off x="822960" y="4937760"/>
-            <a:ext cx="9875520" cy="822960"/>
+            <a:off x="822960" y="4983480"/>
+            <a:ext cx="9966960" cy="822960"/>
           </a:xfrm>
           <a:prstGeom prst="rect">
             <a:avLst/>
@@ -2944,7 +3099,7 @@
                 <a:ea typeface="Calibri" pitchFamily="34" charset="-122"/>
                 <a:cs typeface="Calibri" pitchFamily="34" charset="-120"/>
               </a:rPr>
-              <a:t>My bet: a small drift-adaptation layer holds false alarms down at the same detection rate, and still fits the chip.</a:t>
+              <a:t>My bet: a small update guard tells honest change apart from an attack, keeping detection high at a tiny on-device cost.</a:t>
             </a:r>
             <a:endParaRPr lang="en-US" sz="1700" dirty="0"/>
           </a:p>
@@ -3011,7 +3166,7 @@
         <p:spPr>
           <a:xfrm>
             <a:off x="1024128" y="676656"/>
-            <a:ext cx="7315200" cy="292608"/>
+            <a:ext cx="8686800" cy="292608"/>
           </a:xfrm>
           <a:prstGeom prst="rect">
             <a:avLst/>
@@ -3074,7 +3229,7 @@
                 <a:ea typeface="Calibri" pitchFamily="34" charset="-122"/>
                 <a:cs typeface="Calibri" pitchFamily="34" charset="-120"/>
               </a:rPr>
-              <a:t>Four moving parts, all sized for the chip.</a:t>
+              <a:t>Build the detector, break it, then defend it.</a:t>
             </a:r>
             <a:endParaRPr lang="en-US" sz="2900" dirty="0"/>
           </a:p>
@@ -3154,7 +3309,7 @@
                 <a:ea typeface="Calibri" pitchFamily="34" charset="-122"/>
                 <a:cs typeface="Calibri" pitchFamily="34" charset="-120"/>
               </a:rPr>
-              <a:t>Features</a:t>
+              <a:t>Detector</a:t>
             </a:r>
             <a:endParaRPr lang="en-US" sz="1800" dirty="0"/>
           </a:p>
@@ -3193,7 +3348,7 @@
                 <a:ea typeface="Calibri" pitchFamily="34" charset="-122"/>
                 <a:cs typeface="Calibri" pitchFamily="34" charset="-120"/>
               </a:rPr>
-              <a:t>Cheap streaming stats from traffic: packet sizes, timing, protocol counts.</a:t>
+              <a:t>Tiny unsupervised TinyML model plus online drift tracking (ADWIN, Page-Hinkley).</a:t>
             </a:r>
             <a:endParaRPr lang="en-US" sz="1500" dirty="0"/>
           </a:p>
@@ -3273,7 +3428,7 @@
                 <a:ea typeface="Calibri" pitchFamily="34" charset="-122"/>
                 <a:cs typeface="Calibri" pitchFamily="34" charset="-120"/>
               </a:rPr>
-              <a:t>Detector</a:t>
+              <a:t>The attack</a:t>
             </a:r>
             <a:endParaRPr lang="en-US" sz="1800" dirty="0"/>
           </a:p>
@@ -3312,7 +3467,7 @@
                 <a:ea typeface="Calibri" pitchFamily="34" charset="-122"/>
                 <a:cs typeface="Calibri" pitchFamily="34" charset="-120"/>
               </a:rPr>
-              <a:t>A tiny unsupervised model: a small autoencoder or streaming trees.</a:t>
+              <a:t>A boiling-frog poisoning attack that slowly walks normal until an attack slips through.</a:t>
             </a:r>
             <a:endParaRPr lang="en-US" sz="1500" dirty="0"/>
           </a:p>
@@ -3392,7 +3547,7 @@
                 <a:ea typeface="Calibri" pitchFamily="34" charset="-122"/>
                 <a:cs typeface="Calibri" pitchFamily="34" charset="-120"/>
               </a:rPr>
-              <a:t>Drift layer</a:t>
+              <a:t>The defense</a:t>
             </a:r>
             <a:pPr indent="0" marL="0">
               <a:buNone/>
@@ -3445,7 +3600,7 @@
                 <a:ea typeface="Calibri" pitchFamily="34" charset="-122"/>
                 <a:cs typeface="Calibri" pitchFamily="34" charset="-120"/>
               </a:rPr>
-              <a:t>Watch the anomaly score, adapt the threshold, and update gently on traffic I trust.</a:t>
+              <a:t>A robust update guard: rate-limited updates, trimmed stats, and a trusted anchor.</a:t>
             </a:r>
             <a:endParaRPr lang="en-US" sz="1500" dirty="0"/>
           </a:p>
@@ -3564,7 +3719,7 @@
                 <a:ea typeface="Calibri" pitchFamily="34" charset="-122"/>
                 <a:cs typeface="Calibri" pitchFamily="34" charset="-120"/>
               </a:rPr>
-              <a:t>Run it on the ESP32 and measure memory, latency, and energy for real.</a:t>
+              <a:t>Run detector, attack, and defense on the ESP32, and measure the real cost.</a:t>
             </a:r>
             <a:endParaRPr lang="en-US" sz="1500" dirty="0"/>
           </a:p>
@@ -3631,7 +3786,7 @@
         <p:spPr>
           <a:xfrm>
             <a:off x="1024128" y="676656"/>
-            <a:ext cx="7315200" cy="292608"/>
+            <a:ext cx="8686800" cy="292608"/>
           </a:xfrm>
           <a:prstGeom prst="rect">
             <a:avLst/>
@@ -4002,7 +4157,7 @@
               <a:buChar char="•"/>
             </a:pPr>
             <a:r>
-              <a:rPr lang="en-US" sz="1550" dirty="0">
+              <a:rPr lang="en-US" sz="1500" dirty="0">
                 <a:solidFill>
                   <a:srgbClr val="424245"/>
                 </a:solidFill>
@@ -4010,9 +4165,9 @@
                 <a:ea typeface="Calibri" pitchFamily="34" charset="-122"/>
                 <a:cs typeface="Calibri" pitchFamily="34" charset="-120"/>
               </a:rPr>
-              <a:t>Static detector, no adaptation</a:t>
-            </a:r>
-            <a:endParaRPr lang="en-US" sz="1550" dirty="0"/>
+              <a:t>Static detector, safe but stale</a:t>
+            </a:r>
+            <a:endParaRPr lang="en-US" sz="1500" dirty="0"/>
           </a:p>
           <a:p>
             <a:pPr marL="203200" indent="-203200">
@@ -4026,7 +4181,7 @@
               <a:buChar char="•"/>
             </a:pPr>
             <a:r>
-              <a:rPr lang="en-US" sz="1550" dirty="0">
+              <a:rPr lang="en-US" sz="1500" dirty="0">
                 <a:solidFill>
                   <a:srgbClr val="424245"/>
                 </a:solidFill>
@@ -4034,9 +4189,9 @@
                 <a:ea typeface="Calibri" pitchFamily="34" charset="-122"/>
                 <a:cs typeface="Calibri" pitchFamily="34" charset="-120"/>
               </a:rPr>
-              <a:t>Periodic full retrain, the heavy cloud way</a:t>
-            </a:r>
-            <a:endParaRPr lang="en-US" sz="1550" dirty="0"/>
+              <a:t>Naive adaptive detector, fresh but poisonable (the key contrast)</a:t>
+            </a:r>
+            <a:endParaRPr lang="en-US" sz="1500" dirty="0"/>
           </a:p>
           <a:p>
             <a:pPr marL="203200" indent="-203200">
@@ -4050,7 +4205,7 @@
               <a:buChar char="•"/>
             </a:pPr>
             <a:r>
-              <a:rPr lang="en-US" sz="1550" dirty="0">
+              <a:rPr lang="en-US" sz="1500" dirty="0">
                 <a:solidFill>
                   <a:srgbClr val="424245"/>
                 </a:solidFill>
@@ -4058,9 +4213,9 @@
                 <a:ea typeface="Calibri" pitchFamily="34" charset="-122"/>
                 <a:cs typeface="Calibri" pitchFamily="34" charset="-120"/>
               </a:rPr>
-              <a:t>Fixed threshold</a:t>
-            </a:r>
-            <a:endParaRPr lang="en-US" sz="1550" dirty="0"/>
+              <a:t>Periodic full retrain, the heavy cloud way</a:t>
+            </a:r>
+            <a:endParaRPr lang="en-US" sz="1500" dirty="0"/>
           </a:p>
           <a:p>
             <a:pPr marL="203200" indent="-203200">
@@ -4071,7 +4226,7 @@
               <a:buChar char="•"/>
             </a:pPr>
             <a:r>
-              <a:rPr lang="en-US" sz="1550" dirty="0">
+              <a:rPr lang="en-US" sz="1500" dirty="0">
                 <a:solidFill>
                   <a:srgbClr val="424245"/>
                 </a:solidFill>
@@ -4081,7 +4236,7 @@
               </a:rPr>
               <a:t>Kitsune-style reference</a:t>
             </a:r>
-            <a:endParaRPr lang="en-US" sz="1550" dirty="0"/>
+            <a:endParaRPr lang="en-US" sz="1500" dirty="0"/>
           </a:p>
         </p:txBody>
       </p:sp>
@@ -4146,7 +4301,7 @@
         <p:spPr>
           <a:xfrm>
             <a:off x="1024128" y="676656"/>
-            <a:ext cx="7315200" cy="292608"/>
+            <a:ext cx="8686800" cy="292608"/>
           </a:xfrm>
           <a:prstGeom prst="rect">
             <a:avLst/>
@@ -4209,7 +4364,7 @@
                 <a:ea typeface="Calibri" pitchFamily="34" charset="-122"/>
                 <a:cs typeface="Calibri" pitchFamily="34" charset="-120"/>
               </a:rPr>
-              <a:t>One number decides it. The rest keep me honest.</a:t>
+              <a:t>The attack proves the risk. The rest keep me honest.</a:t>
             </a:r>
             <a:endParaRPr lang="en-US" sz="2800" dirty="0"/>
           </a:p>
@@ -4301,7 +4456,7 @@
               <a:buNone/>
             </a:pPr>
             <a:r>
-              <a:rPr lang="en-US" sz="2200" b="1" dirty="0">
+              <a:rPr lang="en-US" sz="2000" b="1" dirty="0">
                 <a:solidFill>
                   <a:srgbClr val="FFFFFF"/>
                 </a:solidFill>
@@ -4309,9 +4464,9 @@
                 <a:ea typeface="Calibri" pitchFamily="34" charset="-122"/>
                 <a:cs typeface="Calibri" pitchFamily="34" charset="-120"/>
               </a:rPr>
-              <a:t>A false-positive rate that stays low and steady as behavior drifts.</a:t>
-            </a:r>
-            <a:endParaRPr lang="en-US" sz="2200" dirty="0"/>
+              <a:t>Poisoning attack-success and detection retained under attack: naive adaptive falls, ours holds.</a:t>
+            </a:r>
+            <a:endParaRPr lang="en-US" sz="2000" dirty="0"/>
           </a:p>
         </p:txBody>
       </p:sp>
@@ -4473,7 +4628,7 @@
                 <a:ea typeface="Calibri" pitchFamily="34" charset="-122"/>
                 <a:cs typeface="Calibri" pitchFamily="34" charset="-120"/>
               </a:rPr>
-              <a:t>On the chip</a:t>
+              <a:t>Benign drift</a:t>
             </a:r>
             <a:endParaRPr lang="en-US" sz="1600" dirty="0"/>
           </a:p>
@@ -4515,7 +4670,7 @@
                 <a:ea typeface="Calibri" pitchFamily="34" charset="-122"/>
                 <a:cs typeface="Calibri" pitchFamily="34" charset="-120"/>
               </a:rPr>
-              <a:t>RAM, latency, energy per inference, model size.</a:t>
+              <a:t>False-positive rate stays low as normal shifts.</a:t>
             </a:r>
             <a:endParaRPr lang="en-US" sz="1400" dirty="0"/>
           </a:p>
@@ -4576,7 +4731,7 @@
                 <a:ea typeface="Calibri" pitchFamily="34" charset="-122"/>
                 <a:cs typeface="Calibri" pitchFamily="34" charset="-120"/>
               </a:rPr>
-              <a:t>Robustness</a:t>
+              <a:t>On the chip</a:t>
             </a:r>
             <a:endParaRPr lang="en-US" sz="1600" dirty="0"/>
           </a:p>
@@ -4618,7 +4773,7 @@
                 <a:ea typeface="Calibri" pitchFamily="34" charset="-122"/>
                 <a:cs typeface="Calibri" pitchFamily="34" charset="-120"/>
               </a:rPr>
-              <a:t>Across drift rates, and against poisoning.</a:t>
+              <a:t>RAM, latency, energy per inference, model size.</a:t>
             </a:r>
             <a:endParaRPr lang="en-US" sz="1400" dirty="0"/>
           </a:p>
@@ -4685,7 +4840,7 @@
         <p:spPr>
           <a:xfrm>
             <a:off x="1024128" y="768096"/>
-            <a:ext cx="7315200" cy="292608"/>
+            <a:ext cx="8686800" cy="292608"/>
           </a:xfrm>
           <a:prstGeom prst="rect">
             <a:avLst/>
@@ -4724,7 +4879,7 @@
         <p:spPr>
           <a:xfrm>
             <a:off x="822960" y="1554480"/>
-            <a:ext cx="10332720" cy="2194560"/>
+            <a:ext cx="10424160" cy="2286000"/>
           </a:xfrm>
           <a:prstGeom prst="rect">
             <a:avLst/>
@@ -4743,7 +4898,7 @@
               <a:buNone/>
             </a:pPr>
             <a:r>
-              <a:rPr lang="en-US" sz="3000" b="1" dirty="0">
+              <a:rPr lang="en-US" sz="2900" b="1" dirty="0">
                 <a:solidFill>
                   <a:srgbClr val="FFFFFF"/>
                 </a:solidFill>
@@ -4751,9 +4906,9 @@
                 <a:ea typeface="Calibri" pitchFamily="34" charset="-122"/>
                 <a:cs typeface="Calibri" pitchFamily="34" charset="-120"/>
               </a:rPr>
-              <a:t>A small, self-adjusting detector that stays trustworthy on a real device, plus a clear map of the accuracy, memory, and energy trade-offs behind it.</a:t>
-            </a:r>
-            <a:endParaRPr lang="en-US" sz="3000" dirty="0"/>
+              <a:t>Show that self-adapting detectors can be poisoned, build a lightweight guard that stops it on a real device, and measure exactly what that safety costs.</a:t>
+            </a:r>
+            <a:endParaRPr lang="en-US" sz="2900" dirty="0"/>
           </a:p>
         </p:txBody>
       </p:sp>
@@ -4765,7 +4920,7 @@
         </p:nvSpPr>
         <p:spPr>
           <a:xfrm>
-            <a:off x="822960" y="4892040"/>
+            <a:off x="822960" y="4983480"/>
             <a:ext cx="146304" cy="146304"/>
           </a:xfrm>
           <a:prstGeom prst="ellipse">
@@ -4785,7 +4940,7 @@
         </p:nvSpPr>
         <p:spPr>
           <a:xfrm>
-            <a:off x="1078992" y="4773168"/>
+            <a:off x="1078992" y="4864608"/>
             <a:ext cx="3291840" cy="365760"/>
           </a:xfrm>
           <a:prstGeom prst="rect">
@@ -4824,7 +4979,7 @@
         </p:nvSpPr>
         <p:spPr>
           <a:xfrm>
-            <a:off x="1078992" y="5138928"/>
+            <a:off x="1078992" y="5230368"/>
             <a:ext cx="3291840" cy="548640"/>
           </a:xfrm>
           <a:prstGeom prst="rect">
@@ -4863,7 +5018,7 @@
         </p:nvSpPr>
         <p:spPr>
           <a:xfrm>
-            <a:off x="4023360" y="4709160"/>
+            <a:off x="4023360" y="4800600"/>
             <a:ext cx="457200" cy="457200"/>
           </a:xfrm>
           <a:prstGeom prst="rect">
@@ -4902,7 +5057,7 @@
         </p:nvSpPr>
         <p:spPr>
           <a:xfrm>
-            <a:off x="4617720" y="4892040"/>
+            <a:off x="4617720" y="4983480"/>
             <a:ext cx="146304" cy="146304"/>
           </a:xfrm>
           <a:prstGeom prst="ellipse">
@@ -4922,7 +5077,7 @@
         </p:nvSpPr>
         <p:spPr>
           <a:xfrm>
-            <a:off x="4873752" y="4773168"/>
+            <a:off x="4873752" y="4864608"/>
             <a:ext cx="3291840" cy="365760"/>
           </a:xfrm>
           <a:prstGeom prst="rect">
@@ -4961,7 +5116,7 @@
         </p:nvSpPr>
         <p:spPr>
           <a:xfrm>
-            <a:off x="4873752" y="5138928"/>
+            <a:off x="4873752" y="5230368"/>
             <a:ext cx="3291840" cy="548640"/>
           </a:xfrm>
           <a:prstGeom prst="rect">
@@ -4986,7 +5141,7 @@
                 <a:ea typeface="Calibri" pitchFamily="34" charset="-122"/>
                 <a:cs typeface="Calibri" pitchFamily="34" charset="-120"/>
               </a:rPr>
-              <a:t>Baselines and first results</a:t>
+              <a:t>Attack, baselines, first results</a:t>
             </a:r>
             <a:endParaRPr lang="en-US" sz="1350" dirty="0"/>
           </a:p>
@@ -5000,7 +5155,7 @@
         </p:nvSpPr>
         <p:spPr>
           <a:xfrm>
-            <a:off x="7818120" y="4709160"/>
+            <a:off x="7818120" y="4800600"/>
             <a:ext cx="457200" cy="457200"/>
           </a:xfrm>
           <a:prstGeom prst="rect">
@@ -5039,7 +5194,7 @@
         </p:nvSpPr>
         <p:spPr>
           <a:xfrm>
-            <a:off x="8412480" y="4892040"/>
+            <a:off x="8412480" y="4983480"/>
             <a:ext cx="146304" cy="146304"/>
           </a:xfrm>
           <a:prstGeom prst="ellipse">
@@ -5059,7 +5214,7 @@
         </p:nvSpPr>
         <p:spPr>
           <a:xfrm>
-            <a:off x="8668512" y="4773168"/>
+            <a:off x="8668512" y="4864608"/>
             <a:ext cx="3291840" cy="365760"/>
           </a:xfrm>
           <a:prstGeom prst="rect">
@@ -5098,7 +5253,7 @@
         </p:nvSpPr>
         <p:spPr>
           <a:xfrm>
-            <a:off x="8668512" y="5138928"/>
+            <a:off x="8668512" y="5230368"/>
             <a:ext cx="3291840" cy="548640"/>
           </a:xfrm>
           <a:prstGeom prst="rect">

</xml_diff>

<commit_message>
Second research round: Threat-Orthogonal Adaptation with simulation evidence
Targeted searches found ANTIDOTE (IMC 2009), which already defends a single
anomaly detector against boiling-frog poisoning, so the earlier peer-free
novelty claim is withdrawn. Real ISP drift data (CESNET-TimeSeries24) shows
honest drift is directional too, and defenses that freeze can be turned
into a denial of service. The new method rations only the threat-aligned
part of each update and never freezes.

Adds a synthetic simulation (5 seeds): at a 40% attacker share, naive
adaptation is compromised in 24 cycles, freezing and consistency defenses
reach 85-87% false alarms, and TOA keeps 100% recall with 0.3% false alarms.
Deck slides 4-11 updated with the corrected claims and the real figure.
</commit_message>
<xml_diff>
--- a/CSD457_First_Presentation.pptx
+++ b/CSD457_First_Presentation.pptx
@@ -115,608 +115,6 @@
     </a:lvl9pPr>
   </p:defaultTextStyle>
 </p:presentation>
-</file>
-
-<file path=ppt/charts/chart1.xml><?xml version="1.0" encoding="utf-8"?>
-<c:chartSpace xmlns:c="http://schemas.openxmlformats.org/drawingml/2006/chart" xmlns:a="http://schemas.openxmlformats.org/drawingml/2006/main" xmlns:r="http://schemas.openxmlformats.org/officeDocument/2006/relationships">
-  <c:date1904 val="0"/>
-  <c:roundedCorners val="1"/>
-  <c:chart>
-    <c:title>
-      <c:tx>
-        <c:rich>
-          <a:bodyPr/>
-          <a:lstStyle/>
-          <a:p>
-            <a:pPr algn="l">
-              <a:defRPr sz="1300" b="0" i="0" u="none" strike="noStrike">
-                <a:solidFill>
-                  <a:srgbClr val="1D1D1F"/>
-                </a:solidFill>
-                <a:latin typeface="Calibri"/>
-              </a:defRPr>
-            </a:pPr>
-            <a:r>
-              <a:rPr sz="1300" b="0" i="0" u="none" strike="noStrike">
-                <a:solidFill>
-                  <a:srgbClr val="1D1D1F"/>
-                </a:solidFill>
-                <a:latin typeface="Calibri"/>
-              </a:rPr>
-              <a:t>Target-attack recall (%) vs. poisoning cycles</a:t>
-            </a:r>
-          </a:p>
-        </c:rich>
-      </c:tx>
-      <c:layout/>
-      <c:overlay val="0"/>
-    </c:title>
-    <c:autoTitleDeleted val="0"/>
-    <c:plotArea>
-      <c:layout/>
-      <c:lineChart>
-        <c:varyColors val="0"/>
-        <c:ser>
-          <c:idx val="0"/>
-          <c:order val="0"/>
-          <c:tx>
-            <c:strRef>
-              <c:f>Sheet1!$B$1</c:f>
-              <c:strCache>
-                <c:ptCount val="1"/>
-                <c:pt idx="0">
-                  <c:v>Naive adaptive</c:v>
-                </c:pt>
-              </c:strCache>
-            </c:strRef>
-          </c:tx>
-          <c:spPr>
-            <a:solidFill>
-              <a:srgbClr val="D70015"/>
-            </a:solidFill>
-            <a:ln w="38100" cap="flat">
-              <a:solidFill>
-                <a:srgbClr val="D70015"/>
-              </a:solidFill>
-              <a:prstDash val="solid"/>
-              <a:round/>
-            </a:ln>
-            <a:effectLst/>
-          </c:spPr>
-          <c:invertIfNegative val="0"/>
-          <c:dLbls>
-            <c:numFmt formatCode="#,##0" sourceLinked="0"/>
-            <c:txPr>
-              <a:bodyPr/>
-              <a:lstStyle/>
-              <a:p>
-                <a:pPr>
-                  <a:defRPr b="0" i="0" strike="noStrike" sz="1200" u="none">
-                    <a:solidFill>
-                      <a:srgbClr val="000000"/>
-                    </a:solidFill>
-                    <a:latin typeface="Arial"/>
-                  </a:defRPr>
-                </a:pPr>
-              </a:p>
-            </c:txPr>
-            <c:showLegendKey val="0"/>
-            <c:showVal val="0"/>
-            <c:showCatName val="0"/>
-            <c:showSerName val="0"/>
-            <c:showPercent val="0"/>
-            <c:showBubbleSize val="0"/>
-            <c:showLeaderLines val="0"/>
-          </c:dLbls>
-          <c:marker>
-            <c:symbol val="none"/>
-            <c:size val="6"/>
-            <c:spPr>
-              <a:solidFill>
-                <a:srgbClr val="D70015"/>
-              </a:solidFill>
-              <a:ln w="9525" cap="flat">
-                <a:solidFill>
-                  <a:srgbClr val="D70015"/>
-                </a:solidFill>
-                <a:prstDash val="solid"/>
-                <a:round/>
-              </a:ln>
-              <a:effectLst/>
-            </c:spPr>
-          </c:marker>
-          <c:cat>
-            <c:multiLvlStrRef>
-              <c:f>Sheet1!$A$2:$A$8</c:f>
-              <c:multiLvlStrCache>
-                <c:ptCount val="7"/>
-                <c:lvl>
-                  <c:pt idx="0">
-                    <c:v>0</c:v>
-                  </c:pt>
-                  <c:pt idx="1">
-                    <c:v>25</c:v>
-                  </c:pt>
-                  <c:pt idx="2">
-                    <c:v>50</c:v>
-                  </c:pt>
-                  <c:pt idx="3">
-                    <c:v>75</c:v>
-                  </c:pt>
-                  <c:pt idx="4">
-                    <c:v>100</c:v>
-                  </c:pt>
-                  <c:pt idx="5">
-                    <c:v>125</c:v>
-                  </c:pt>
-                  <c:pt idx="6">
-                    <c:v>150</c:v>
-                  </c:pt>
-                </c:lvl>
-              </c:multiLvlStrCache>
-            </c:multiLvlStrRef>
-          </c:cat>
-          <c:val>
-            <c:numRef>
-              <c:f>Sheet1!$B$2:$B$8</c:f>
-              <c:numCache>
-                <c:formatCode>General</c:formatCode>
-                <c:ptCount val="7"/>
-                <c:pt idx="0">
-                  <c:v>95</c:v>
-                </c:pt>
-                <c:pt idx="1">
-                  <c:v>90</c:v>
-                </c:pt>
-                <c:pt idx="2">
-                  <c:v>72</c:v>
-                </c:pt>
-                <c:pt idx="3">
-                  <c:v>45</c:v>
-                </c:pt>
-                <c:pt idx="4">
-                  <c:v>22</c:v>
-                </c:pt>
-                <c:pt idx="5">
-                  <c:v>10</c:v>
-                </c:pt>
-                <c:pt idx="6">
-                  <c:v>5</c:v>
-                </c:pt>
-              </c:numCache>
-            </c:numRef>
-          </c:val>
-          <c:smooth val="1"/>
-        </c:ser>
-        <c:ser>
-          <c:idx val="1"/>
-          <c:order val="1"/>
-          <c:tx>
-            <c:strRef>
-              <c:f>Sheet1!$C$1</c:f>
-              <c:strCache>
-                <c:ptCount val="1"/>
-                <c:pt idx="0">
-                  <c:v>Layer 1 only</c:v>
-                </c:pt>
-              </c:strCache>
-            </c:strRef>
-          </c:tx>
-          <c:spPr>
-            <a:solidFill>
-              <a:srgbClr val="FF9F0A"/>
-            </a:solidFill>
-            <a:ln w="38100" cap="flat">
-              <a:solidFill>
-                <a:srgbClr val="FF9F0A"/>
-              </a:solidFill>
-              <a:prstDash val="solid"/>
-              <a:round/>
-            </a:ln>
-            <a:effectLst/>
-          </c:spPr>
-          <c:invertIfNegative val="0"/>
-          <c:dLbls>
-            <c:numFmt formatCode="#,##0" sourceLinked="0"/>
-            <c:txPr>
-              <a:bodyPr/>
-              <a:lstStyle/>
-              <a:p>
-                <a:pPr>
-                  <a:defRPr b="0" i="0" strike="noStrike" sz="1200" u="none">
-                    <a:solidFill>
-                      <a:srgbClr val="000000"/>
-                    </a:solidFill>
-                    <a:latin typeface="Arial"/>
-                  </a:defRPr>
-                </a:pPr>
-              </a:p>
-            </c:txPr>
-            <c:showLegendKey val="0"/>
-            <c:showVal val="0"/>
-            <c:showCatName val="0"/>
-            <c:showSerName val="0"/>
-            <c:showPercent val="0"/>
-            <c:showBubbleSize val="0"/>
-            <c:showLeaderLines val="0"/>
-          </c:dLbls>
-          <c:marker>
-            <c:symbol val="none"/>
-            <c:size val="6"/>
-            <c:spPr>
-              <a:solidFill>
-                <a:srgbClr val="FF9F0A"/>
-              </a:solidFill>
-              <a:ln w="9525" cap="flat">
-                <a:solidFill>
-                  <a:srgbClr val="FF9F0A"/>
-                </a:solidFill>
-                <a:prstDash val="solid"/>
-                <a:round/>
-              </a:ln>
-              <a:effectLst/>
-            </c:spPr>
-          </c:marker>
-          <c:cat>
-            <c:multiLvlStrRef>
-              <c:f>Sheet1!$A$2:$A$8</c:f>
-              <c:multiLvlStrCache>
-                <c:ptCount val="7"/>
-                <c:lvl>
-                  <c:pt idx="0">
-                    <c:v>0</c:v>
-                  </c:pt>
-                  <c:pt idx="1">
-                    <c:v>25</c:v>
-                  </c:pt>
-                  <c:pt idx="2">
-                    <c:v>50</c:v>
-                  </c:pt>
-                  <c:pt idx="3">
-                    <c:v>75</c:v>
-                  </c:pt>
-                  <c:pt idx="4">
-                    <c:v>100</c:v>
-                  </c:pt>
-                  <c:pt idx="5">
-                    <c:v>125</c:v>
-                  </c:pt>
-                  <c:pt idx="6">
-                    <c:v>150</c:v>
-                  </c:pt>
-                </c:lvl>
-              </c:multiLvlStrCache>
-            </c:multiLvlStrRef>
-          </c:cat>
-          <c:val>
-            <c:numRef>
-              <c:f>Sheet1!$C$2:$C$8</c:f>
-              <c:numCache>
-                <c:formatCode>General</c:formatCode>
-                <c:ptCount val="7"/>
-                <c:pt idx="0">
-                  <c:v>95</c:v>
-                </c:pt>
-                <c:pt idx="1">
-                  <c:v>94</c:v>
-                </c:pt>
-                <c:pt idx="2">
-                  <c:v>90</c:v>
-                </c:pt>
-                <c:pt idx="3">
-                  <c:v>80</c:v>
-                </c:pt>
-                <c:pt idx="4">
-                  <c:v>62</c:v>
-                </c:pt>
-                <c:pt idx="5">
-                  <c:v>44</c:v>
-                </c:pt>
-                <c:pt idx="6">
-                  <c:v>30</c:v>
-                </c:pt>
-              </c:numCache>
-            </c:numRef>
-          </c:val>
-          <c:smooth val="1"/>
-        </c:ser>
-        <c:ser>
-          <c:idx val="2"/>
-          <c:order val="2"/>
-          <c:tx>
-            <c:strRef>
-              <c:f>Sheet1!$D$1</c:f>
-              <c:strCache>
-                <c:ptCount val="1"/>
-                <c:pt idx="0">
-                  <c:v>TimeGuard</c:v>
-                </c:pt>
-              </c:strCache>
-            </c:strRef>
-          </c:tx>
-          <c:spPr>
-            <a:solidFill>
-              <a:srgbClr val="0071E3"/>
-            </a:solidFill>
-            <a:ln w="38100" cap="flat">
-              <a:solidFill>
-                <a:srgbClr val="0071E3"/>
-              </a:solidFill>
-              <a:prstDash val="solid"/>
-              <a:round/>
-            </a:ln>
-            <a:effectLst/>
-          </c:spPr>
-          <c:invertIfNegative val="0"/>
-          <c:dLbls>
-            <c:numFmt formatCode="#,##0" sourceLinked="0"/>
-            <c:txPr>
-              <a:bodyPr/>
-              <a:lstStyle/>
-              <a:p>
-                <a:pPr>
-                  <a:defRPr b="0" i="0" strike="noStrike" sz="1200" u="none">
-                    <a:solidFill>
-                      <a:srgbClr val="000000"/>
-                    </a:solidFill>
-                    <a:latin typeface="Arial"/>
-                  </a:defRPr>
-                </a:pPr>
-              </a:p>
-            </c:txPr>
-            <c:showLegendKey val="0"/>
-            <c:showVal val="0"/>
-            <c:showCatName val="0"/>
-            <c:showSerName val="0"/>
-            <c:showPercent val="0"/>
-            <c:showBubbleSize val="0"/>
-            <c:showLeaderLines val="0"/>
-          </c:dLbls>
-          <c:marker>
-            <c:symbol val="none"/>
-            <c:size val="6"/>
-            <c:spPr>
-              <a:solidFill>
-                <a:srgbClr val="0071E3"/>
-              </a:solidFill>
-              <a:ln w="9525" cap="flat">
-                <a:solidFill>
-                  <a:srgbClr val="0071E3"/>
-                </a:solidFill>
-                <a:prstDash val="solid"/>
-                <a:round/>
-              </a:ln>
-              <a:effectLst/>
-            </c:spPr>
-          </c:marker>
-          <c:cat>
-            <c:multiLvlStrRef>
-              <c:f>Sheet1!$A$2:$A$8</c:f>
-              <c:multiLvlStrCache>
-                <c:ptCount val="7"/>
-                <c:lvl>
-                  <c:pt idx="0">
-                    <c:v>0</c:v>
-                  </c:pt>
-                  <c:pt idx="1">
-                    <c:v>25</c:v>
-                  </c:pt>
-                  <c:pt idx="2">
-                    <c:v>50</c:v>
-                  </c:pt>
-                  <c:pt idx="3">
-                    <c:v>75</c:v>
-                  </c:pt>
-                  <c:pt idx="4">
-                    <c:v>100</c:v>
-                  </c:pt>
-                  <c:pt idx="5">
-                    <c:v>125</c:v>
-                  </c:pt>
-                  <c:pt idx="6">
-                    <c:v>150</c:v>
-                  </c:pt>
-                </c:lvl>
-              </c:multiLvlStrCache>
-            </c:multiLvlStrRef>
-          </c:cat>
-          <c:val>
-            <c:numRef>
-              <c:f>Sheet1!$D$2:$D$8</c:f>
-              <c:numCache>
-                <c:formatCode>General</c:formatCode>
-                <c:ptCount val="7"/>
-                <c:pt idx="0">
-                  <c:v>95</c:v>
-                </c:pt>
-                <c:pt idx="1">
-                  <c:v>95</c:v>
-                </c:pt>
-                <c:pt idx="2">
-                  <c:v>94</c:v>
-                </c:pt>
-                <c:pt idx="3">
-                  <c:v>93</c:v>
-                </c:pt>
-                <c:pt idx="4">
-                  <c:v>93</c:v>
-                </c:pt>
-                <c:pt idx="5">
-                  <c:v>92</c:v>
-                </c:pt>
-                <c:pt idx="6">
-                  <c:v>92</c:v>
-                </c:pt>
-              </c:numCache>
-            </c:numRef>
-          </c:val>
-          <c:smooth val="1"/>
-        </c:ser>
-        <c:dLbls>
-          <c:numFmt formatCode="#,##0" sourceLinked="0"/>
-          <c:txPr>
-            <a:bodyPr/>
-            <a:lstStyle/>
-            <a:p>
-              <a:pPr>
-                <a:defRPr b="0" i="0" strike="noStrike" sz="1200" u="none">
-                  <a:solidFill>
-                    <a:srgbClr val="000000"/>
-                  </a:solidFill>
-                  <a:latin typeface="Arial"/>
-                </a:defRPr>
-              </a:pPr>
-            </a:p>
-          </c:txPr>
-          <c:showLegendKey val="0"/>
-          <c:showVal val="0"/>
-          <c:showCatName val="0"/>
-          <c:showSerName val="0"/>
-          <c:showPercent val="0"/>
-          <c:showBubbleSize val="0"/>
-          <c:showLeaderLines val="0"/>
-        </c:dLbls>
-        <c:marker val="1"/>
-        <c:axId val="2094734554"/>
-        <c:axId val="2094734552"/>
-        <c:axId val="2094734556"/>
-      </c:lineChart>
-      <c:catAx>
-        <c:axId val="2094734554"/>
-        <c:scaling>
-          <c:orientation val="minMax"/>
-        </c:scaling>
-        <c:delete val="0"/>
-        <c:axPos val="b"/>
-        <c:numFmt formatCode="General" sourceLinked="1"/>
-        <c:majorTickMark val="out"/>
-        <c:minorTickMark val="none"/>
-        <c:tickLblPos val="low"/>
-        <c:spPr>
-          <a:ln w="12700" cap="flat">
-            <a:solidFill>
-              <a:srgbClr val="888888"/>
-            </a:solidFill>
-            <a:prstDash val="solid"/>
-            <a:round/>
-          </a:ln>
-        </c:spPr>
-        <c:txPr>
-          <a:bodyPr/>
-          <a:lstStyle/>
-          <a:p>
-            <a:pPr>
-              <a:defRPr sz="1000" b="0" i="0" u="none" strike="noStrike">
-                <a:solidFill>
-                  <a:srgbClr val="86868B"/>
-                </a:solidFill>
-                <a:latin typeface="Arial"/>
-              </a:defRPr>
-            </a:pPr>
-            <a:endParaRPr lang="en-US"/>
-          </a:p>
-        </c:txPr>
-        <c:crossAx val="2094734552"/>
-        <c:crosses val="autoZero"/>
-        <c:auto val="1"/>
-        <c:lblAlgn val="ctr"/>
-        <c:noMultiLvlLbl val="1"/>
-      </c:catAx>
-      <c:valAx>
-        <c:axId val="2094734552"/>
-        <c:scaling>
-          <c:orientation val="minMax"/>
-          <c:max val="100"/>
-          <c:min val="0"/>
-        </c:scaling>
-        <c:delete val="0"/>
-        <c:axPos val="l"/>
-        <c:majorGridlines>
-          <c:spPr>
-            <a:ln w="12700" cap="flat">
-              <a:solidFill>
-                <a:srgbClr val="E8E8ED"/>
-              </a:solidFill>
-              <a:prstDash val="solid"/>
-              <a:round/>
-            </a:ln>
-          </c:spPr>
-        </c:majorGridlines>
-        <c:numFmt formatCode="General" sourceLinked="0"/>
-        <c:majorTickMark val="out"/>
-        <c:minorTickMark val="none"/>
-        <c:tickLblPos val="nextTo"/>
-        <c:spPr>
-          <a:ln w="12700" cap="flat">
-            <a:solidFill>
-              <a:srgbClr val="888888"/>
-            </a:solidFill>
-            <a:prstDash val="solid"/>
-            <a:round/>
-          </a:ln>
-        </c:spPr>
-        <c:txPr>
-          <a:bodyPr/>
-          <a:lstStyle/>
-          <a:p>
-            <a:pPr>
-              <a:defRPr sz="1000" b="0" i="0" u="none" strike="noStrike">
-                <a:solidFill>
-                  <a:srgbClr val="86868B"/>
-                </a:solidFill>
-                <a:latin typeface="Arial"/>
-              </a:defRPr>
-            </a:pPr>
-            <a:endParaRPr lang="en-US"/>
-          </a:p>
-        </c:txPr>
-        <c:crossAx val="2094734554"/>
-        <c:crosses val="autoZero"/>
-        <c:crossBetween val="between"/>
-        <c:majorUnit val="25"/>
-      </c:valAx>
-      <c:spPr>
-        <a:noFill/>
-        <a:ln>
-          <a:noFill/>
-        </a:ln>
-        <a:effectLst/>
-      </c:spPr>
-    </c:plotArea>
-    <c:legend>
-      <c:legendPos val="b"/>
-      <c:overlay val="0"/>
-      <c:txPr>
-        <a:bodyPr/>
-        <a:lstStyle/>
-        <a:p>
-          <a:pPr>
-            <a:defRPr sz="1000">
-              <a:solidFill>
-                <a:srgbClr val="86868B"/>
-              </a:solidFill>
-              <a:latin typeface="Calibri"/>
-              <a:cs typeface="Calibri"/>
-            </a:defRPr>
-          </a:pPr>
-          <a:endParaRPr lang="en-US"/>
-        </a:p>
-      </c:txPr>
-    </c:legend>
-    <c:plotVisOnly val="1"/>
-    <c:dispBlanksAs val="span"/>
-  </c:chart>
-  <c:spPr>
-    <a:noFill/>
-    <a:ln>
-      <a:noFill/>
-    </a:ln>
-    <a:effectLst/>
-  </c:spPr>
-  <c:externalData r:id="rId1">
-    <c:autoUpdate val="0"/>
-  </c:externalData>
-</c:chartSpace>
 </file>
 
 <file path=ppt/notesMasters/notesMaster1.xml><?xml version="1.0" encoding="utf-8"?>
@@ -1202,7 +600,7 @@
           <a:p>
             <a:r>
               <a:rPr lang="en-US" dirty="0"/>
-              <a:t>About 40 seconds, then open for questions. Likely questions: 1) Is the attack new? No, cite [6] and [12]; the defense is ours. 2) Why not federated learning? A single ESP32 has no peers, and FL defenses fail against slow attackers anyway [10]. 3) Can OS-ELM train on an ESP32? Its updates are cheap; if not, we run the guard on-device and replay features. 4) Is the budget blocking real drift? We sweep it and report that trade-off as a result.</a:t>
+              <a:t>About 40 seconds, then questions. Likely questions: 1) Is this just ANTIDOTE? No: ANTIDOTE retrains a PCA model on a server; ours adapts continuously on a microcontroller and never freezes. 2) What about attacks with no known signature? Honest limit: the rationed direction needs a signature; we will test using directions learned from our own alarms. 3) What if honest drift heads toward an attack? In simulation false alarms rose to about 7 percent, then recovered; we will measure it on real data. 4) Is the simulation real? No, synthetic; real data by mid-review.</a:t>
             </a:r>
             <a:endParaRPr lang="en-US" dirty="0"/>
           </a:p>
@@ -1290,7 +688,7 @@
           <a:p>
             <a:r>
               <a:rPr lang="en-US" dirty="0"/>
-              <a:t>Backup slide. Leave it up during questions if nothing else is needed.</a:t>
+              <a:t>Backup slide. Leave it up during questions.</a:t>
             </a:r>
             <a:endParaRPr lang="en-US" dirty="0"/>
           </a:p>
@@ -1554,7 +952,7 @@
           <a:p>
             <a:r>
               <a:rPr lang="en-US" dirty="0"/>
-              <a:t>About 50 seconds. Say the honest note out loud; it shows we checked. Anyone can claim novelty; we can say exactly where the prior work stops.</a:t>
+              <a:t>About 50 seconds. Say the credit line out loud, especially ANTIDOTE. It shows we read deeply and it narrows our claim to something we can defend: continuous learning on the device.</a:t>
             </a:r>
             <a:endParaRPr lang="en-US" dirty="0"/>
           </a:p>
@@ -1642,7 +1040,7 @@
           <a:p>
             <a:r>
               <a:rPr lang="en-US" dirty="0"/>
-              <a:t>About 40 seconds. RQ1 is the peer-free idea. RQ2 is the patient attacker. RQ3 keeps us honest about cost.</a:t>
+              <a:t>About 40 seconds. RQ1 is the method, RQ2 is a new attack we found on existing defenses, RQ3 is real-world exposure and cost.</a:t>
             </a:r>
             <a:endParaRPr lang="en-US" dirty="0"/>
           </a:p>
@@ -1730,7 +1128,7 @@
           <a:p>
             <a:r>
               <a:rPr lang="en-US" dirty="0"/>
-              <a:t>About 70 seconds. Walk the top row left to right; the red box is where the attacker gets in. Then the two layers. Key phrase: we take a defense that needs many devices and run it over time on one device.</a:t>
+              <a:t>About 70 seconds. The whole idea in one line: honest drift can go anywhere, poisoning has to go toward the attack. So we project each update onto the attack direction and ration only that part. Cost on an ESP32 is a few dot products per update.</a:t>
             </a:r>
             <a:endParaRPr lang="en-US" dirty="0"/>
           </a:p>
@@ -1818,7 +1216,7 @@
           <a:p>
             <a:r>
               <a:rPr lang="en-US" dirty="0"/>
-              <a:t>About 45 seconds. This slide is the research idea. Showing each layer fail alone and the pair hold is our headline experiment. Say clearly that the table is the hypothesis, not results yet.</a:t>
+              <a:t>About 60 seconds. This is the slide that shows real research. Finding 1 killed our first idea. Finding 2 is new and also broke our own earlier design. Finding 3 is why this matters for IoT specifically.</a:t>
             </a:r>
             <a:endParaRPr lang="en-US" dirty="0"/>
           </a:p>
@@ -1906,7 +1304,7 @@
           <a:p>
             <a:r>
               <a:rPr lang="en-US" dirty="0"/>
-              <a:t>About 45 seconds. Everything is public and cheap. The naive adaptive baseline matters most, because our claim is to keep its freshness without its weakness.</a:t>
+              <a:t>About 40 seconds. We compare against the naive detector and against every kind of defense, including the 2009 classic.</a:t>
             </a:r>
             <a:endParaRPr lang="en-US" dirty="0"/>
           </a:p>
@@ -1994,7 +1392,7 @@
           <a:p>
             <a:r>
               <a:rPr lang="en-US" dirty="0"/>
-              <a:t>About 50 seconds. Point at the chart and say sketch twice. If the final plot looks like this, the claim holds. The ESP32 numbers are what almost nobody else reports.</a:t>
+              <a:t>About 60 seconds. Be clear this is synthetic. Left: red line is the naive detector poisoned in 24 cycles. Middle: the two defenses that freeze or reject keep the attack visible but false alarms explode once honest drift starts. Right: the attacker leaves at cycle 45 and the frozen defense never recovers. That is the freeze attack. Blue is ours in every panel. Next step is the same experiment on N-BaIoT and the ESP32.</a:t>
             </a:r>
             <a:endParaRPr lang="en-US" dirty="0"/>
           </a:p>
@@ -2743,7 +2141,7 @@
                 <a:ea typeface="Calibri" pitchFamily="34" charset="-122"/>
                 <a:cs typeface="Calibri" pitchFamily="34" charset="-120"/>
               </a:rPr>
-              <a:t>TimeGuard</a:t>
+              <a:t>Threat-Orthogonal Adaptation</a:t>
             </a:r>
             <a:endParaRPr lang="en-US" sz="2000" dirty="0"/>
           </a:p>
@@ -2785,7 +2183,7 @@
                 <a:ea typeface="Calibri" pitchFamily="34" charset="-122"/>
                 <a:cs typeface="Calibri" pitchFamily="34" charset="-120"/>
               </a:rPr>
-              <a:t>A peer-free poisoning defense for a self-updating IDS, which we did not find in 78 papers. It takes robust aggregation, which normally compares many devices, and runs it over time on one device.</a:t>
+              <a:t>An on-device update rule that never freezes, rations only threat-aligned drift, and gives a provable minimum number of cycles before a known attack can be hidden.</a:t>
             </a:r>
             <a:endParaRPr lang="en-US" sz="1450" dirty="0"/>
           </a:p>
@@ -2863,7 +2261,7 @@
                 <a:ea typeface="Calibri" pitchFamily="34" charset="-122"/>
                 <a:cs typeface="Calibri" pitchFamily="34" charset="-120"/>
               </a:rPr>
-              <a:t>A negative result worth knowing</a:t>
+              <a:t>The freeze attack</a:t>
             </a:r>
             <a:endParaRPr lang="en-US" sz="2000" dirty="0"/>
           </a:p>
@@ -2905,7 +2303,7 @@
                 <a:ea typeface="Calibri" pitchFamily="34" charset="-122"/>
                 <a:cs typeface="Calibri" pitchFamily="34" charset="-120"/>
               </a:rPr>
-              <a:t>Evidence that a consistency check alone misses a patient attacker, and a bounded drift budget closes the hole.</a:t>
+              <a:t>A new attack on defenses that stop learning when drift looks suspicious, plus evidence that never-freezing adaptation is immune to it.</a:t>
             </a:r>
             <a:endParaRPr lang="en-US" sz="1450" dirty="0"/>
           </a:p>
@@ -2983,7 +2381,7 @@
                 <a:ea typeface="Calibri" pitchFamily="34" charset="-122"/>
                 <a:cs typeface="Calibri" pitchFamily="34" charset="-120"/>
               </a:rPr>
-              <a:t>Real cost on real hardware</a:t>
+              <a:t>Real exposure, real cost</a:t>
             </a:r>
             <a:endParaRPr lang="en-US" sz="2000" dirty="0"/>
           </a:p>
@@ -3025,7 +2423,7 @@
                 <a:ea typeface="Calibri" pitchFamily="34" charset="-122"/>
                 <a:cs typeface="Calibri" pitchFamily="34" charset="-120"/>
               </a:rPr>
-              <a:t>Measured ESP32 memory, latency and energy for securing on-device adaptation, a cost none of the 28 papers we read reports.</a:t>
+              <a:t>How poisonable real low-traffic IoT devices are on N-BaIoT, and what protection costs on an ESP32 in memory, latency and energy.</a:t>
             </a:r>
             <a:endParaRPr lang="en-US" sz="1450" dirty="0"/>
           </a:p>
@@ -3123,7 +2521,7 @@
                 <a:ea typeface="Calibri" pitchFamily="34" charset="-122"/>
                 <a:cs typeface="Calibri" pitchFamily="34" charset="-120"/>
               </a:rPr>
-              <a:t>Detector, naive baseline, attack</a:t>
+              <a:t>N-BaIoT pipeline, attack, baselines</a:t>
             </a:r>
             <a:endParaRPr lang="en-US" sz="1200" dirty="0"/>
           </a:p>
@@ -3221,7 +2619,7 @@
                 <a:ea typeface="Calibri" pitchFamily="34" charset="-122"/>
                 <a:cs typeface="Calibri" pitchFamily="34" charset="-120"/>
               </a:rPr>
-              <a:t>Layer 1 plus first results</a:t>
+              <a:t>Real-data version of slide 9</a:t>
             </a:r>
             <a:endParaRPr lang="en-US" sz="1200" dirty="0"/>
           </a:p>
@@ -3319,7 +2717,7 @@
                 <a:ea typeface="Calibri" pitchFamily="34" charset="-122"/>
                 <a:cs typeface="Calibri" pitchFamily="34" charset="-120"/>
               </a:rPr>
-              <a:t>Layer 2, ablation, ESP32 port</a:t>
+              <a:t>ESP32 port, freeze attack study</a:t>
             </a:r>
             <a:endParaRPr lang="en-US" sz="1200" dirty="0"/>
           </a:p>
@@ -3561,8 +2959,8 @@
         </p:nvSpPr>
         <p:spPr>
           <a:xfrm>
-            <a:off x="822960" y="1234440"/>
-            <a:ext cx="10561320" cy="4937760"/>
+            <a:off x="822960" y="1188720"/>
+            <a:ext cx="10561320" cy="5029200"/>
           </a:xfrm>
           <a:prstGeom prst="rect">
             <a:avLst/>
@@ -3579,12 +2977,12 @@
                 <a:spcPct val="100000"/>
               </a:lnSpc>
               <a:spcAft>
-                <a:spcPts val="500"/>
+                <a:spcPts val="400"/>
               </a:spcAft>
               <a:buNone/>
             </a:pPr>
             <a:r>
-              <a:rPr lang="en-US" sz="1150" dirty="0">
+              <a:rPr lang="en-US" sz="1050" dirty="0">
                 <a:solidFill>
                   <a:srgbClr val="424245"/>
                 </a:solidFill>
@@ -3594,7 +2992,7 @@
               </a:rPr>
               <a:t>[1] Y. Mirsky et al., Kitsune: An Ensemble of Autoencoders for Online Network Intrusion Detection, NDSS 2018.</a:t>
             </a:r>
-            <a:endParaRPr lang="en-US" sz="1150" dirty="0"/>
+            <a:endParaRPr lang="en-US" sz="1050" dirty="0"/>
           </a:p>
           <a:p>
             <a:pPr indent="0" marL="0">
@@ -3602,12 +3000,12 @@
                 <a:spcPct val="100000"/>
               </a:lnSpc>
               <a:spcAft>
-                <a:spcPts val="500"/>
+                <a:spcPts val="400"/>
               </a:spcAft>
               <a:buNone/>
             </a:pPr>
             <a:r>
-              <a:rPr lang="en-US" sz="1150" dirty="0">
+              <a:rPr lang="en-US" sz="1050" dirty="0">
                 <a:solidFill>
                   <a:srgbClr val="424245"/>
                 </a:solidFill>
@@ -3617,7 +3015,7 @@
               </a:rPr>
               <a:t>[2] Y. Meidan et al., N-BaIoT: Network-Based Detection of IoT Botnet Attacks Using Deep Autoencoders, IEEE Pervasive Computing, 2018.</a:t>
             </a:r>
-            <a:endParaRPr lang="en-US" sz="1150" dirty="0"/>
+            <a:endParaRPr lang="en-US" sz="1050" dirty="0"/>
           </a:p>
           <a:p>
             <a:pPr indent="0" marL="0">
@@ -3625,12 +3023,12 @@
                 <a:spcPct val="100000"/>
               </a:lnSpc>
               <a:spcAft>
-                <a:spcPts val="500"/>
+                <a:spcPts val="400"/>
               </a:spcAft>
               <a:buNone/>
             </a:pPr>
             <a:r>
-              <a:rPr lang="en-US" sz="1150" dirty="0">
+              <a:rPr lang="en-US" sz="1050" dirty="0">
                 <a:solidFill>
                   <a:srgbClr val="424245"/>
                 </a:solidFill>
@@ -3640,7 +3038,7 @@
               </a:rPr>
               <a:t>[3] Zhang et al., AOC-IDS: Autonomous Online Framework with Contrastive Learning for Intrusion Detection, IEEE INFOCOM 2024.</a:t>
             </a:r>
-            <a:endParaRPr lang="en-US" sz="1150" dirty="0"/>
+            <a:endParaRPr lang="en-US" sz="1050" dirty="0"/>
           </a:p>
           <a:p>
             <a:pPr indent="0" marL="0">
@@ -3648,12 +3046,12 @@
                 <a:spcPct val="100000"/>
               </a:lnSpc>
               <a:spcAft>
-                <a:spcPts val="500"/>
+                <a:spcPts val="400"/>
               </a:spcAft>
               <a:buNone/>
             </a:pPr>
             <a:r>
-              <a:rPr lang="en-US" sz="1150" dirty="0">
+              <a:rPr lang="en-US" sz="1050" dirty="0">
                 <a:solidFill>
                   <a:srgbClr val="424245"/>
                 </a:solidFill>
@@ -3663,7 +3061,7 @@
               </a:rPr>
               <a:t>[4] L. Yang and A. Shami, A Lightweight Concept Drift Detection and Adaptation Framework for IoT Data Streams, IEEE IoT Magazine, 2021.</a:t>
             </a:r>
-            <a:endParaRPr lang="en-US" sz="1150" dirty="0"/>
+            <a:endParaRPr lang="en-US" sz="1050" dirty="0"/>
           </a:p>
           <a:p>
             <a:pPr indent="0" marL="0">
@@ -3671,12 +3069,12 @@
                 <a:spcPct val="100000"/>
               </a:lnSpc>
               <a:spcAft>
-                <a:spcPts val="500"/>
+                <a:spcPts val="400"/>
               </a:spcAft>
               <a:buNone/>
             </a:pPr>
             <a:r>
-              <a:rPr lang="en-US" sz="1150" dirty="0">
+              <a:rPr lang="en-US" sz="1050" dirty="0">
                 <a:solidFill>
                   <a:srgbClr val="424245"/>
                 </a:solidFill>
@@ -3686,7 +3084,7 @@
               </a:rPr>
               <a:t>[5] A. Bifet and R. Gavaldà, Learning from Time-Changing Data with Adaptive Windowing, SIAM SDM 2007.</a:t>
             </a:r>
-            <a:endParaRPr lang="en-US" sz="1150" dirty="0"/>
+            <a:endParaRPr lang="en-US" sz="1050" dirty="0"/>
           </a:p>
           <a:p>
             <a:pPr indent="0" marL="0">
@@ -3694,12 +3092,12 @@
                 <a:spcPct val="100000"/>
               </a:lnSpc>
               <a:spcAft>
-                <a:spcPts val="500"/>
+                <a:spcPts val="400"/>
               </a:spcAft>
               <a:buNone/>
             </a:pPr>
             <a:r>
-              <a:rPr lang="en-US" sz="1150" dirty="0">
+              <a:rPr lang="en-US" sz="1050" dirty="0">
                 <a:solidFill>
                   <a:srgbClr val="424245"/>
                 </a:solidFill>
@@ -3709,7 +3107,7 @@
               </a:rPr>
               <a:t>[6] M. Kravchik, B. Biggio, A. Shabtai, Poisoning Attacks on Cyber Attack Detectors for Industrial Control Systems, ACM SAC 2021.</a:t>
             </a:r>
-            <a:endParaRPr lang="en-US" sz="1150" dirty="0"/>
+            <a:endParaRPr lang="en-US" sz="1050" dirty="0"/>
           </a:p>
           <a:p>
             <a:pPr indent="0" marL="0">
@@ -3717,12 +3115,12 @@
                 <a:spcPct val="100000"/>
               </a:lnSpc>
               <a:spcAft>
-                <a:spcPts val="500"/>
+                <a:spcPts val="400"/>
               </a:spcAft>
               <a:buNone/>
             </a:pPr>
             <a:r>
-              <a:rPr lang="en-US" sz="1150" dirty="0">
+              <a:rPr lang="en-US" sz="1050" dirty="0">
                 <a:solidFill>
                   <a:srgbClr val="424245"/>
                 </a:solidFill>
@@ -3730,9 +3128,9 @@
                 <a:ea typeface="Calibri" pitchFamily="34" charset="-122"/>
                 <a:cs typeface="Calibri" pitchFamily="34" charset="-120"/>
               </a:rPr>
-              <a:t>[7] Data Poisoning Attack against Neural Network-Based On-Device Learning Anomaly Detector by Physical Attacks on Sensors, MDPI Sensors 24(19), 2024.</a:t>
-            </a:r>
-            <a:endParaRPr lang="en-US" sz="1150" dirty="0"/>
+              <a:t>[7] Data Poisoning Attack against Neural Network-Based On-Device Learning Anomaly Detector by Physical Attacks on Sensors, MDPI Sensors, 2024.</a:t>
+            </a:r>
+            <a:endParaRPr lang="en-US" sz="1050" dirty="0"/>
           </a:p>
           <a:p>
             <a:pPr indent="0" marL="0">
@@ -3740,12 +3138,12 @@
                 <a:spcPct val="100000"/>
               </a:lnSpc>
               <a:spcAft>
-                <a:spcPts val="500"/>
+                <a:spcPts val="400"/>
               </a:spcAft>
               <a:buNone/>
             </a:pPr>
             <a:r>
-              <a:rPr lang="en-US" sz="1150" dirty="0">
+              <a:rPr lang="en-US" sz="1050" dirty="0">
                 <a:solidFill>
                   <a:srgbClr val="424245"/>
                 </a:solidFill>
@@ -3755,7 +3153,7 @@
               </a:rPr>
               <a:t>[8] P. Blanchard et al., Machine Learning with Adversaries: Byzantine Tolerant Gradient Descent, NeurIPS 2017.</a:t>
             </a:r>
-            <a:endParaRPr lang="en-US" sz="1150" dirty="0"/>
+            <a:endParaRPr lang="en-US" sz="1050" dirty="0"/>
           </a:p>
           <a:p>
             <a:pPr indent="0" marL="0">
@@ -3763,12 +3161,12 @@
                 <a:spcPct val="100000"/>
               </a:lnSpc>
               <a:spcAft>
-                <a:spcPts val="500"/>
+                <a:spcPts val="400"/>
               </a:spcAft>
               <a:buNone/>
             </a:pPr>
             <a:r>
-              <a:rPr lang="en-US" sz="1150" dirty="0">
+              <a:rPr lang="en-US" sz="1050" dirty="0">
                 <a:solidFill>
                   <a:srgbClr val="424245"/>
                 </a:solidFill>
@@ -3778,7 +3176,7 @@
               </a:rPr>
               <a:t>[9] D. Yin et al., Byzantine-Robust Distributed Learning: Towards Optimal Statistical Rates, ICML 2018.</a:t>
             </a:r>
-            <a:endParaRPr lang="en-US" sz="1150" dirty="0"/>
+            <a:endParaRPr lang="en-US" sz="1050" dirty="0"/>
           </a:p>
           <a:p>
             <a:pPr indent="0" marL="0">
@@ -3786,12 +3184,12 @@
                 <a:spcPct val="100000"/>
               </a:lnSpc>
               <a:spcAft>
-                <a:spcPts val="500"/>
+                <a:spcPts val="400"/>
               </a:spcAft>
               <a:buNone/>
             </a:pPr>
             <a:r>
-              <a:rPr lang="en-US" sz="1150" dirty="0">
+              <a:rPr lang="en-US" sz="1050" dirty="0">
                 <a:solidFill>
                   <a:srgbClr val="424245"/>
                 </a:solidFill>
@@ -3801,7 +3199,7 @@
               </a:rPr>
               <a:t>[10] T. D. Nguyen et al., Poisoning Attacks on Federated Learning-based IoT Intrusion Detection System, DISS Workshop at NDSS 2020.</a:t>
             </a:r>
-            <a:endParaRPr lang="en-US" sz="1150" dirty="0"/>
+            <a:endParaRPr lang="en-US" sz="1050" dirty="0"/>
           </a:p>
           <a:p>
             <a:pPr indent="0" marL="0">
@@ -3809,12 +3207,12 @@
                 <a:spcPct val="100000"/>
               </a:lnSpc>
               <a:spcAft>
-                <a:spcPts val="500"/>
+                <a:spcPts val="400"/>
               </a:spcAft>
               <a:buNone/>
             </a:pPr>
             <a:r>
-              <a:rPr lang="en-US" sz="1150" dirty="0">
+              <a:rPr lang="en-US" sz="1050" dirty="0">
                 <a:solidFill>
                   <a:srgbClr val="424245"/>
                 </a:solidFill>
@@ -3824,7 +3222,7 @@
               </a:rPr>
               <a:t>[11] E. C. P. Neto et al., CICIoT2023: A Real-Time Dataset and Benchmark for Large-Scale Attacks in IoT Environment, MDPI Sensors, 2023.</a:t>
             </a:r>
-            <a:endParaRPr lang="en-US" sz="1150" dirty="0"/>
+            <a:endParaRPr lang="en-US" sz="1050" dirty="0"/>
           </a:p>
           <a:p>
             <a:pPr indent="0" marL="0">
@@ -3832,12 +3230,12 @@
                 <a:spcPct val="100000"/>
               </a:lnSpc>
               <a:spcAft>
-                <a:spcPts val="500"/>
+                <a:spcPts val="400"/>
               </a:spcAft>
               <a:buNone/>
             </a:pPr>
             <a:r>
-              <a:rPr lang="en-US" sz="1150" dirty="0">
+              <a:rPr lang="en-US" sz="1050" dirty="0">
                 <a:solidFill>
                   <a:srgbClr val="424245"/>
                 </a:solidFill>
@@ -3845,9 +3243,9 @@
                 <a:ea typeface="Calibri" pitchFamily="34" charset="-122"/>
                 <a:cs typeface="Calibri" pitchFamily="34" charset="-120"/>
               </a:rPr>
-              <a:t>[12] Demonstrating and Characterizing Frog-Boiling Poisoning Against Drift-Aware Continual Learners, thesis talk, UMass Dartmouth, Aug 2026.</a:t>
-            </a:r>
-            <a:endParaRPr lang="en-US" sz="1150" dirty="0"/>
+              <a:t>[12] Demonstrating and Characterizing Frog-Boiling Poisoning Against Drift-Aware Continual Learners, thesis talk, UMass Dartmouth, 2026.</a:t>
+            </a:r>
+            <a:endParaRPr lang="en-US" sz="1050" dirty="0"/>
           </a:p>
           <a:p>
             <a:pPr indent="0" marL="0">
@@ -3855,12 +3253,12 @@
                 <a:spcPct val="100000"/>
               </a:lnSpc>
               <a:spcAft>
-                <a:spcPts val="500"/>
+                <a:spcPts val="400"/>
               </a:spcAft>
               <a:buNone/>
             </a:pPr>
             <a:r>
-              <a:rPr lang="en-US" sz="1150" dirty="0">
+              <a:rPr lang="en-US" sz="1050" dirty="0">
                 <a:solidFill>
                   <a:srgbClr val="424245"/>
                 </a:solidFill>
@@ -3868,9 +3266,9 @@
                 <a:ea typeface="Calibri" pitchFamily="34" charset="-122"/>
                 <a:cs typeface="Calibri" pitchFamily="34" charset="-120"/>
               </a:rPr>
-              <a:t>[13] B. Nelson et al., Exploiting Machine Learning to Subvert Your Spam Filter, USENIX LEET 2008.</a:t>
-            </a:r>
-            <a:endParaRPr lang="en-US" sz="1150" dirty="0"/>
+              <a:t>[13] B. Rubinstein et al., ANTIDOTE: Understanding and Defending against Poisoning of Anomaly Detectors, ACM IMC 2009.</a:t>
+            </a:r>
+            <a:endParaRPr lang="en-US" sz="1050" dirty="0"/>
           </a:p>
           <a:p>
             <a:pPr indent="0" marL="0">
@@ -3878,12 +3276,12 @@
                 <a:spcPct val="100000"/>
               </a:lnSpc>
               <a:spcAft>
-                <a:spcPts val="500"/>
+                <a:spcPts val="400"/>
               </a:spcAft>
               <a:buNone/>
             </a:pPr>
             <a:r>
-              <a:rPr lang="en-US" sz="1150" dirty="0">
+              <a:rPr lang="en-US" sz="1050" dirty="0">
                 <a:solidFill>
                   <a:srgbClr val="424245"/>
                 </a:solidFill>
@@ -3893,7 +3291,53 @@
               </a:rPr>
               <a:t>[14] Intrusion Detection on Resource-Constrained IoT Devices with Hardware-Aware ML and DL, IEEE ETECOM 2025 (arXiv 2512.02272).</a:t>
             </a:r>
-            <a:endParaRPr lang="en-US" sz="1150" dirty="0"/>
+            <a:endParaRPr lang="en-US" sz="1050" dirty="0"/>
+          </a:p>
+          <a:p>
+            <a:pPr indent="0" marL="0">
+              <a:lnSpc>
+                <a:spcPct val="100000"/>
+              </a:lnSpc>
+              <a:spcAft>
+                <a:spcPts val="400"/>
+              </a:spcAft>
+              <a:buNone/>
+            </a:pPr>
+            <a:r>
+              <a:rPr lang="en-US" sz="1050" dirty="0">
+                <a:solidFill>
+                  <a:srgbClr val="424245"/>
+                </a:solidFill>
+                <a:latin typeface="Calibri" pitchFamily="34" charset="0"/>
+                <a:ea typeface="Calibri" pitchFamily="34" charset="-122"/>
+                <a:cs typeface="Calibri" pitchFamily="34" charset="-120"/>
+              </a:rPr>
+              <a:t>[15] M. Kloft and P. Laskov, Security Analysis of Online Centroid Anomaly Detection, JMLR, 2012.</a:t>
+            </a:r>
+            <a:endParaRPr lang="en-US" sz="1050" dirty="0"/>
+          </a:p>
+          <a:p>
+            <a:pPr indent="0" marL="0">
+              <a:lnSpc>
+                <a:spcPct val="100000"/>
+              </a:lnSpc>
+              <a:spcAft>
+                <a:spcPts val="400"/>
+              </a:spcAft>
+              <a:buNone/>
+            </a:pPr>
+            <a:r>
+              <a:rPr lang="en-US" sz="1050" dirty="0">
+                <a:solidFill>
+                  <a:srgbClr val="424245"/>
+                </a:solidFill>
+                <a:latin typeface="Calibri" pitchFamily="34" charset="0"/>
+                <a:ea typeface="Calibri" pitchFamily="34" charset="-122"/>
+                <a:cs typeface="Calibri" pitchFamily="34" charset="-120"/>
+              </a:rPr>
+              <a:t>[16] J. Koumar et al., CESNET-TimeSeries24: Time Series Dataset for Network Traffic Anomaly Detection and Forecasting, Scientific Data, 2025.</a:t>
+            </a:r>
+            <a:endParaRPr lang="en-US" sz="1050" dirty="0"/>
           </a:p>
         </p:txBody>
       </p:sp>
@@ -3930,7 +3374,7 @@
                 <a:ea typeface="Calibri" pitchFamily="34" charset="-122"/>
                 <a:cs typeface="Calibri" pitchFamily="34" charset="-120"/>
               </a:rPr>
-              <a:t>Full review of 28 deep-read papers: literature-review.md in our repository.</a:t>
+              <a:t>Simulation code and full 28-paper review are in our repository: github.com/IOT-snu/brainstorming</a:t>
             </a:r>
             <a:endParaRPr lang="en-US" sz="1000" dirty="0"/>
           </a:p>
@@ -6074,7 +5518,7 @@
                 <a:ea typeface="Calibri" pitchFamily="34" charset="-122"/>
                 <a:cs typeface="Calibri" pitchFamily="34" charset="-120"/>
               </a:rPr>
-              <a:t>The attack is known. A defense for a single device is missing.</a:t>
+              <a:t>Defenses exist. None of them can keep learning safely on a device.</a:t>
             </a:r>
             <a:endParaRPr lang="en-US" sz="2800" dirty="0"/>
           </a:p>
@@ -6174,7 +5618,7 @@
                 <a:ea typeface="Calibri" pitchFamily="34" charset="-122"/>
                 <a:cs typeface="Calibri" pitchFamily="34" charset="-120"/>
               </a:rPr>
-              <a:t>Fits on an ESP32, but never adapts</a:t>
+              <a:t>Fits on an ESP32, but never adapts, so it goes stale</a:t>
             </a:r>
             <a:endParaRPr lang="en-US" sz="1400" dirty="0"/>
           </a:p>
@@ -6188,7 +5632,7 @@
         </p:nvSpPr>
         <p:spPr>
           <a:xfrm>
-            <a:off x="1097280" y="3456432"/>
+            <a:off x="1097280" y="3474720"/>
             <a:ext cx="2788920" cy="274320"/>
           </a:xfrm>
           <a:prstGeom prst="rect">
@@ -6274,7 +5718,7 @@
                 <a:ea typeface="Calibri" pitchFamily="34" charset="-122"/>
                 <a:cs typeface="Calibri" pitchFamily="34" charset="-120"/>
               </a:rPr>
-              <a:t>Drift adaptation</a:t>
+              <a:t>Adaptive IDS</a:t>
             </a:r>
             <a:endParaRPr lang="en-US" sz="1700" dirty="0"/>
           </a:p>
@@ -6313,7 +5757,7 @@
                 <a:ea typeface="Calibri" pitchFamily="34" charset="-122"/>
                 <a:cs typeface="Calibri" pitchFamily="34" charset="-120"/>
               </a:rPr>
-              <a:t>Adapts cheaply, but trusts every update</a:t>
+              <a:t>Keeps up with drift, but trusts every update it makes</a:t>
             </a:r>
             <a:endParaRPr lang="en-US" sz="1400" dirty="0"/>
           </a:p>
@@ -6327,7 +5771,7 @@
         </p:nvSpPr>
         <p:spPr>
           <a:xfrm>
-            <a:off x="4709160" y="3456432"/>
+            <a:off x="4709160" y="3474720"/>
             <a:ext cx="2788920" cy="274320"/>
           </a:xfrm>
           <a:prstGeom prst="rect">
@@ -6413,7 +5857,7 @@
                 <a:ea typeface="Calibri" pitchFamily="34" charset="-122"/>
                 <a:cs typeface="Calibri" pitchFamily="34" charset="-120"/>
               </a:rPr>
-              <a:t>Poisoning defenses</a:t>
+              <a:t>Existing defenses</a:t>
             </a:r>
             <a:endParaRPr lang="en-US" sz="1700" dirty="0"/>
           </a:p>
@@ -6452,7 +5896,7 @@
                 <a:ea typeface="Calibri" pitchFamily="34" charset="-122"/>
                 <a:cs typeface="Calibri" pitchFamily="34" charset="-120"/>
               </a:rPr>
-              <a:t>Robust, but only across many devices</a:t>
+              <a:t>Need many devices, run on servers, or simply stop learning</a:t>
             </a:r>
             <a:endParaRPr lang="en-US" sz="1400" dirty="0"/>
           </a:p>
@@ -6466,7 +5910,7 @@
         </p:nvSpPr>
         <p:spPr>
           <a:xfrm>
-            <a:off x="8321040" y="3456432"/>
+            <a:off x="8321040" y="3474720"/>
             <a:ext cx="2788920" cy="274320"/>
           </a:xfrm>
           <a:prstGeom prst="rect">
@@ -6491,7 +5935,7 @@
                 <a:ea typeface="Calibri" pitchFamily="34" charset="-122"/>
                 <a:cs typeface="Calibri" pitchFamily="34" charset="-120"/>
               </a:rPr>
-              <a:t>[8, 9, 10]</a:t>
+              <a:t>[8, 10, 13]</a:t>
             </a:r>
             <a:endParaRPr lang="en-US" sz="1100" dirty="0"/>
           </a:p>
@@ -6594,7 +6038,7 @@
                 <a:ea typeface="Calibri" pitchFamily="34" charset="-122"/>
                 <a:cs typeface="Calibri" pitchFamily="34" charset="-120"/>
               </a:rPr>
-              <a:t>A poisoning defense that needs no peer devices, runs inside a microcontroller's budget, and holds against a patient attacker over many update cycles.</a:t>
+              <a:t>A detector that keeps adapting on the device, never freezes, and still cannot be walked toward an attack.</a:t>
             </a:r>
             <a:endParaRPr lang="en-US" sz="1900" dirty="0"/>
           </a:p>
@@ -6608,8 +6052,8 @@
         </p:nvSpPr>
         <p:spPr>
           <a:xfrm>
-            <a:off x="1188720" y="5394960"/>
-            <a:ext cx="9875520" cy="502920"/>
+            <a:off x="1188720" y="5376672"/>
+            <a:ext cx="9875520" cy="548640"/>
           </a:xfrm>
           <a:prstGeom prst="rect">
             <a:avLst/>
@@ -6633,7 +6077,7 @@
                 <a:ea typeface="Calibri" pitchFamily="34" charset="-122"/>
                 <a:cs typeface="Calibri" pitchFamily="34" charset="-120"/>
               </a:rPr>
-              <a:t>Honest note: the boiling-frog attack on adaptive IDS was demonstrated in 2021 and again in a 2026 thesis [6, 12]. Our novelty is the defense, not the attack.</a:t>
+              <a:t>Credit where due: the attack is known [6, 12], and ANTIDOTE defended a server-side detector with robust PCA back in 2009 [13]. Our target is continuous, on-device adaptation.</a:t>
             </a:r>
             <a:endParaRPr lang="en-US" sz="1300" dirty="0"/>
           </a:p>
@@ -6672,7 +6116,7 @@
                 <a:ea typeface="Calibri" pitchFamily="34" charset="-122"/>
                 <a:cs typeface="Calibri" pitchFamily="34" charset="-120"/>
               </a:rPr>
-              <a:t>[2] IEEE Pervasive Computing 2018  ·  [5] SIAM SDM 2007  ·  [9] ICML 2018  ·  [10] DISS at NDSS 2020  ·  [12] UMass Dartmouth, 2026</a:t>
+              <a:t>[2] IEEE Pervasive Computing 2018  ·  [5] SIAM SDM 2007  ·  [10] DISS at NDSS 2020  ·  [12] UMass Dartmouth, 2026  ·  [13] ACM IMC 2009</a:t>
             </a:r>
             <a:endParaRPr lang="en-US" sz="1000" dirty="0"/>
           </a:p>
@@ -6947,7 +6391,7 @@
                 <a:ea typeface="Calibri" pitchFamily="34" charset="-122"/>
                 <a:cs typeface="Calibri" pitchFamily="34" charset="-120"/>
               </a:rPr>
-              <a:t>Can a single device vet its own updates with no peers, using robust statistics over its own update history?</a:t>
+              <a:t>Can a detector keep learning honest drift while refusing only the part of each update that moves it toward a known attack?</a:t>
             </a:r>
             <a:endParaRPr lang="en-US" sz="1700" dirty="0"/>
           </a:p>
@@ -7050,7 +6494,7 @@
                 <a:ea typeface="Calibri" pitchFamily="34" charset="-122"/>
                 <a:cs typeface="Calibri" pitchFamily="34" charset="-120"/>
               </a:rPr>
-              <a:t>Does a cumulative drift budget stop an attacker who keeps every single step small enough to look normal?</a:t>
+              <a:t>Can an attacker turn a defense that freezes into a denial of service, and does never-freezing adaptation prevent that?</a:t>
             </a:r>
             <a:endParaRPr lang="en-US" sz="1700" dirty="0"/>
           </a:p>
@@ -7153,7 +6597,7 @@
                 <a:ea typeface="Calibri" pitchFamily="34" charset="-122"/>
                 <a:cs typeface="Calibri" pitchFamily="34" charset="-120"/>
               </a:rPr>
-              <a:t>What does this protection cost on a real ESP32: memory, latency, energy, and slower adaptation to honest drift?</a:t>
+              <a:t>How exposed are real low-traffic IoT devices, and what does protection cost on an ESP32 in memory, latency and energy?</a:t>
             </a:r>
             <a:endParaRPr lang="en-US" sz="1700" dirty="0"/>
           </a:p>
@@ -7192,7 +6636,7 @@
                 <a:ea typeface="Calibri" pitchFamily="34" charset="-122"/>
                 <a:cs typeface="Calibri" pitchFamily="34" charset="-120"/>
               </a:rPr>
-              <a:t>Hypothesis: the two layers together keep the target attack detectable across many poisoning cycles, while naive adaptation collapses.</a:t>
+              <a:t>Hypothesis: budgeting only the threat-aligned part of each update keeps attacks visible without the false-alarm cost of freezing.</a:t>
             </a:r>
             <a:endParaRPr lang="en-US" sz="1400" dirty="0"/>
           </a:p>
@@ -7322,7 +6766,7 @@
                 <a:ea typeface="Calibri" pitchFamily="34" charset="-122"/>
                 <a:cs typeface="Calibri" pitchFamily="34" charset="-120"/>
               </a:rPr>
-              <a:t>PROPOSED APPROACH  ·  TIMEGUARD</a:t>
+              <a:t>PROPOSED APPROACH  ·  THREAT-ORTHOGONAL ADAPTATION</a:t>
             </a:r>
             <a:endParaRPr lang="en-US" sz="1250" dirty="0"/>
           </a:p>
@@ -7364,7 +6808,7 @@
                 <a:ea typeface="Calibri" pitchFamily="34" charset="-122"/>
                 <a:cs typeface="Calibri" pitchFamily="34" charset="-120"/>
               </a:rPr>
-              <a:t>Every update the detector proposes has to pass two checks.</a:t>
+              <a:t>Split every update. Only the dangerous part is rationed.</a:t>
             </a:r>
             <a:endParaRPr lang="en-US" sz="2800" dirty="0"/>
           </a:p>
@@ -7588,7 +7032,7 @@
                 <a:ea typeface="Calibri" pitchFamily="34" charset="-122"/>
                 <a:cs typeface="Calibri" pitchFamily="34" charset="-120"/>
               </a:rPr>
-              <a:t>OS-ELM model</a:t>
+              <a:t>centre + spread</a:t>
             </a:r>
             <a:endParaRPr lang="en-US" sz="1200" dirty="0"/>
           </a:p>
@@ -7921,7 +7365,7 @@
                 <a:ea typeface="Calibri" pitchFamily="34" charset="-122"/>
                 <a:cs typeface="Calibri" pitchFamily="34" charset="-120"/>
               </a:rPr>
-              <a:t>Commit, reject, or freeze</a:t>
+              <a:t>Split and apply</a:t>
             </a:r>
             <a:endParaRPr lang="en-US" sz="1300" dirty="0"/>
           </a:p>
@@ -7982,7 +7426,7 @@
                 <a:ea typeface="Calibri" pitchFamily="34" charset="-122"/>
                 <a:cs typeface="Calibri" pitchFamily="34" charset="-120"/>
               </a:rPr>
-              <a:t>Layer 1  ·  TimeKrum</a:t>
+              <a:t>Safe part  ·  applied at once</a:t>
             </a:r>
             <a:endParaRPr lang="en-US" sz="1700" dirty="0"/>
           </a:p>
@@ -8021,7 +7465,7 @@
                 <a:ea typeface="Calibri" pitchFamily="34" charset="-122"/>
                 <a:cs typeface="Calibri" pitchFamily="34" charset="-120"/>
               </a:rPr>
-              <a:t>Does it match my own recent history?</a:t>
+              <a:t>Sideways or away from known attacks</a:t>
             </a:r>
             <a:endParaRPr lang="en-US" sz="1500" dirty="0"/>
           </a:p>
@@ -8036,7 +7480,7 @@
         <p:spPr>
           <a:xfrm>
             <a:off x="1143000" y="4526280"/>
-            <a:ext cx="4526280" cy="1005840"/>
+            <a:ext cx="4526280" cy="1051560"/>
           </a:xfrm>
           <a:prstGeom prst="rect">
             <a:avLst/>
@@ -8063,7 +7507,7 @@
                 <a:ea typeface="Calibri" pitchFamily="34" charset="-122"/>
                 <a:cs typeface="Calibri" pitchFamily="34" charset="-120"/>
               </a:rPr>
-              <a:t>Krum [8] compares updates across many devices. We compare a new update with the device's last k accepted updates instead, so no peers are needed.</a:t>
+              <a:t>Most honest drift, like a 52% traffic drop at semester end [16], moves away from attacks. It is always applied, so the detector keeps up and never freezes.</a:t>
             </a:r>
             <a:endParaRPr lang="en-US" sz="1350" dirty="0"/>
           </a:p>
@@ -8077,7 +7521,7 @@
         </p:nvSpPr>
         <p:spPr>
           <a:xfrm>
-            <a:off x="1143000" y="5623560"/>
+            <a:off x="1143000" y="5650992"/>
             <a:ext cx="4526280" cy="320040"/>
           </a:xfrm>
           <a:prstGeom prst="rect">
@@ -8102,7 +7546,7 @@
                 <a:ea typeface="Calibri" pitchFamily="34" charset="-122"/>
                 <a:cs typeface="Calibri" pitchFamily="34" charset="-120"/>
               </a:rPr>
-              <a:t>Catches abrupt poison</a:t>
+              <a:t>No freeze, no false-alarm flood</a:t>
             </a:r>
             <a:endParaRPr lang="en-US" sz="1300" dirty="0"/>
           </a:p>
@@ -8163,7 +7607,7 @@
                 <a:ea typeface="Calibri" pitchFamily="34" charset="-122"/>
                 <a:cs typeface="Calibri" pitchFamily="34" charset="-120"/>
               </a:rPr>
-              <a:t>Layer 2  ·  Drift budget</a:t>
+              <a:t>Threat part  ·  rationed</a:t>
             </a:r>
             <a:endParaRPr lang="en-US" sz="1700" dirty="0"/>
           </a:p>
@@ -8202,7 +7646,7 @@
                 <a:ea typeface="Calibri" pitchFamily="34" charset="-122"/>
                 <a:cs typeface="Calibri" pitchFamily="34" charset="-120"/>
               </a:rPr>
-              <a:t>Have I moved too far, too fast, in total?</a:t>
+              <a:t>Toward a known attack signature</a:t>
             </a:r>
             <a:endParaRPr lang="en-US" sz="1500" dirty="0"/>
           </a:p>
@@ -8217,7 +7661,7 @@
         <p:spPr>
           <a:xfrm>
             <a:off x="6537960" y="4526280"/>
-            <a:ext cx="4526280" cy="1005840"/>
+            <a:ext cx="4526280" cy="1051560"/>
           </a:xfrm>
           <a:prstGeom prst="rect">
             <a:avLst/>
@@ -8244,7 +7688,7 @@
                 <a:ea typeface="Calibri" pitchFamily="34" charset="-122"/>
                 <a:cs typeface="Calibri" pitchFamily="34" charset="-120"/>
               </a:rPr>
-              <a:t>Caps how far the model may drift from a trusted anchor over time, with the rate learned from clean data. Tiny steps still add up and hit the cap.</a:t>
+              <a:t>Only the part that shrinks the gap between normal and an attack is capped, at a slow rate learned from clean data. Poisoning has to move this way, so it stalls.</a:t>
             </a:r>
             <a:endParaRPr lang="en-US" sz="1350" dirty="0"/>
           </a:p>
@@ -8258,7 +7702,7 @@
         </p:nvSpPr>
         <p:spPr>
           <a:xfrm>
-            <a:off x="6537960" y="5623560"/>
+            <a:off x="6537960" y="5650992"/>
             <a:ext cx="4526280" cy="320040"/>
           </a:xfrm>
           <a:prstGeom prst="rect">
@@ -8283,7 +7727,7 @@
                 <a:ea typeface="Calibri" pitchFamily="34" charset="-122"/>
                 <a:cs typeface="Calibri" pitchFamily="34" charset="-120"/>
               </a:rPr>
-              <a:t>Catches patient poison</a:t>
+              <a:t>Provable minimum time to compromise</a:t>
             </a:r>
             <a:endParaRPr lang="en-US" sz="1300" dirty="0"/>
           </a:p>
@@ -8292,6 +7736,45 @@
       <p:sp>
         <p:nvSpPr>
           <p:cNvPr id="33" name="Text 31"/>
+          <p:cNvSpPr txBox="1"/>
+          <p:nvPr/>
+        </p:nvSpPr>
+        <p:spPr>
+          <a:xfrm>
+            <a:off x="822960" y="6327648"/>
+            <a:ext cx="10515600" cy="274320"/>
+          </a:xfrm>
+          <a:prstGeom prst="rect">
+            <a:avLst/>
+          </a:prstGeom>
+          <a:noFill/>
+          <a:ln/>
+        </p:spPr>
+        <p:txBody>
+          <a:bodyPr wrap="square" lIns="0" tIns="0" rIns="0" bIns="0" rtlCol="0" anchor="ctr"/>
+          <a:lstStyle/>
+          <a:p>
+            <a:pPr indent="0" marL="0">
+              <a:buNone/>
+            </a:pPr>
+            <a:r>
+              <a:rPr lang="en-US" sz="1000" i="1" dirty="0">
+                <a:solidFill>
+                  <a:srgbClr val="86868B"/>
+                </a:solidFill>
+                <a:latin typeface="Calibri" pitchFamily="34" charset="0"/>
+                <a:ea typeface="Calibri" pitchFamily="34" charset="-122"/>
+                <a:cs typeface="Calibri" pitchFamily="34" charset="-120"/>
+              </a:rPr>
+              <a:t>[1] NDSS 2018  ·  [5] SIAM SDM 2007  ·  [16] CESNET-TimeSeries24, Scientific Data 2025</a:t>
+            </a:r>
+            <a:endParaRPr lang="en-US" sz="1000" dirty="0"/>
+          </a:p>
+        </p:txBody>
+      </p:sp>
+      <p:sp>
+        <p:nvSpPr>
+          <p:cNvPr id="34" name="Text 32"/>
           <p:cNvSpPr txBox="1"/>
           <p:nvPr/>
         </p:nvSpPr>
@@ -8413,7 +7896,7 @@
                 <a:ea typeface="Calibri" pitchFamily="34" charset="-122"/>
                 <a:cs typeface="Calibri" pitchFamily="34" charset="-120"/>
               </a:rPr>
-              <a:t>THE KEY INSIGHT</a:t>
+              <a:t>WHAT OUR RESEARCH TURNED UP</a:t>
             </a:r>
             <a:endParaRPr lang="en-US" sz="1250" dirty="0"/>
           </a:p>
@@ -8455,7 +7938,7 @@
                 <a:ea typeface="Calibri" pitchFamily="34" charset="-122"/>
                 <a:cs typeface="Calibri" pitchFamily="34" charset="-120"/>
               </a:rPr>
-              <a:t>A clever attacker stays consistent. So one check is not enough.</a:t>
+              <a:t>Three findings that shaped the design.</a:t>
             </a:r>
             <a:endParaRPr lang="en-US" sz="2800" dirty="0"/>
           </a:p>
@@ -8470,7 +7953,85 @@
         <p:spPr>
           <a:xfrm>
             <a:off x="822960" y="2148840"/>
-            <a:ext cx="4846320" cy="2377440"/>
+            <a:ext cx="731520" cy="457200"/>
+          </a:xfrm>
+          <a:prstGeom prst="rect">
+            <a:avLst/>
+          </a:prstGeom>
+          <a:noFill/>
+          <a:ln/>
+        </p:spPr>
+        <p:txBody>
+          <a:bodyPr wrap="square" lIns="0" tIns="0" rIns="0" bIns="0" rtlCol="0" anchor="ctr"/>
+          <a:lstStyle/>
+          <a:p>
+            <a:pPr indent="0" marL="0">
+              <a:buNone/>
+            </a:pPr>
+            <a:r>
+              <a:rPr lang="en-US" sz="2200" b="1" dirty="0">
+                <a:solidFill>
+                  <a:srgbClr val="0071E3"/>
+                </a:solidFill>
+                <a:latin typeface="Calibri" pitchFamily="34" charset="0"/>
+                <a:ea typeface="Calibri" pitchFamily="34" charset="-122"/>
+                <a:cs typeface="Calibri" pitchFamily="34" charset="-120"/>
+              </a:rPr>
+              <a:t>01</a:t>
+            </a:r>
+            <a:endParaRPr lang="en-US" sz="2200" dirty="0"/>
+          </a:p>
+        </p:txBody>
+      </p:sp>
+      <p:sp>
+        <p:nvSpPr>
+          <p:cNvPr id="6" name="Text 4"/>
+          <p:cNvSpPr txBox="1"/>
+          <p:nvPr/>
+        </p:nvSpPr>
+        <p:spPr>
+          <a:xfrm>
+            <a:off x="1645920" y="2148840"/>
+            <a:ext cx="9692640" cy="384048"/>
+          </a:xfrm>
+          <a:prstGeom prst="rect">
+            <a:avLst/>
+          </a:prstGeom>
+          <a:noFill/>
+          <a:ln/>
+        </p:spPr>
+        <p:txBody>
+          <a:bodyPr wrap="square" lIns="0" tIns="0" rIns="0" bIns="0" rtlCol="0" anchor="ctr"/>
+          <a:lstStyle/>
+          <a:p>
+            <a:pPr indent="0" marL="0">
+              <a:buNone/>
+            </a:pPr>
+            <a:r>
+              <a:rPr lang="en-US" sz="1800" b="1" dirty="0">
+                <a:solidFill>
+                  <a:srgbClr val="1D1D1F"/>
+                </a:solidFill>
+                <a:latin typeface="Calibri" pitchFamily="34" charset="0"/>
+                <a:ea typeface="Calibri" pitchFamily="34" charset="-122"/>
+                <a:cs typeface="Calibri" pitchFamily="34" charset="-120"/>
+              </a:rPr>
+              <a:t>Honest drift is directional too.</a:t>
+            </a:r>
+            <a:endParaRPr lang="en-US" sz="1800" dirty="0"/>
+          </a:p>
+        </p:txBody>
+      </p:sp>
+      <p:sp>
+        <p:nvSpPr>
+          <p:cNvPr id="7" name="Text 5"/>
+          <p:cNvSpPr txBox="1"/>
+          <p:nvPr/>
+        </p:nvSpPr>
+        <p:spPr>
+          <a:xfrm>
+            <a:off x="1645920" y="2551176"/>
+            <a:ext cx="9692640" cy="731520"/>
           </a:xfrm>
           <a:prstGeom prst="rect">
             <a:avLst/>
@@ -8484,12 +8045,12 @@
           <a:p>
             <a:pPr indent="0" marL="0">
               <a:lnSpc>
-                <a:spcPct val="115000"/>
+                <a:spcPct val="108000"/>
               </a:lnSpc>
               <a:buNone/>
             </a:pPr>
             <a:r>
-              <a:rPr lang="en-US" sz="1600" dirty="0">
+              <a:rPr lang="en-US" sz="1400" dirty="0">
                 <a:solidFill>
                   <a:srgbClr val="424245"/>
                 </a:solidFill>
@@ -8497,866 +8058,22 @@
                 <a:ea typeface="Calibri" pitchFamily="34" charset="-122"/>
                 <a:cs typeface="Calibri" pitchFamily="34" charset="-120"/>
               </a:rPr>
-              <a:t>Slow poisoning is built so that each step looks like the one before it. Prior work found that small, consistent deviations slip past robust filters, even when many peers are available [10]. So a consistency check alone will miss it.</a:t>
-            </a:r>
-            <a:endParaRPr lang="en-US" sz="1600" dirty="0"/>
-          </a:p>
-        </p:txBody>
-      </p:sp>
-      <p:graphicFrame>
-        <p:nvGraphicFramePr>
-          <p:cNvPr id="8" name="Table 0"/>
-          <p:cNvGraphicFramePr>
-            <a:graphicFrameLocks noGrp="1"/>
-          </p:cNvGraphicFramePr>
-          <p:nvPr>
-            <p:extLst>
-              <p:ext uri="{D42A27DB-BD31-4B8C-83A1-F6EECF244321}">
-                <p14:modId xmlns:p14="http://schemas.microsoft.com/office/powerpoint/2010/main" val="1579011935"/>
-              </p:ext>
-            </p:extLst>
-          </p:nvPr>
-        </p:nvGraphicFramePr>
-        <p:xfrm>
-          <a:off x="6035040" y="2194560"/>
-          <a:ext cx="5349240" cy="914400"/>
-        </p:xfrm>
-        <a:graphic>
-          <a:graphicData uri="http://schemas.openxmlformats.org/drawingml/2006/table">
-            <a:tbl>
-              <a:tblPr/>
-              <a:tblGrid>
-                <a:gridCol w="1783080"/>
-                <a:gridCol w="1737360"/>
-                <a:gridCol w="1828800"/>
-              </a:tblGrid>
-              <a:tr h="457200">
-                <a:tc>
-                  <a:txBody>
-                    <a:bodyPr/>
-                    <a:lstStyle/>
-                    <a:p>
-                      <a:pPr algn="ctr" indent="0" marL="0">
-                        <a:buNone/>
-                      </a:pPr>
-                      <a:endParaRPr lang="en-US" sz="1200" dirty="0">
-                        <a:latin typeface="Calibri" charset="0"/>
-                        <a:ea typeface="Calibri" charset="0"/>
-                        <a:cs typeface="Calibri" charset="0"/>
-                      </a:endParaRPr>
-                    </a:p>
-                  </a:txBody>
-                  <a:tcPr marL="91440" marR="91440" marT="45720" marB="45720" anchor="ctr">
-                    <a:lnL w="38100" cap="flat" cmpd="sng" algn="ctr">
-                      <a:solidFill>
-                        <a:srgbClr val="FFFFFF"/>
-                      </a:solidFill>
-                      <a:prstDash val="solid"/>
-                      <a:round/>
-                      <a:headEnd type="none" w="med" len="med"/>
-                      <a:tailEnd type="none" w="med" len="med"/>
-                    </a:lnL>
-                    <a:lnR w="38100" cap="flat" cmpd="sng" algn="ctr">
-                      <a:solidFill>
-                        <a:srgbClr val="FFFFFF"/>
-                      </a:solidFill>
-                      <a:prstDash val="solid"/>
-                      <a:round/>
-                      <a:headEnd type="none" w="med" len="med"/>
-                      <a:tailEnd type="none" w="med" len="med"/>
-                    </a:lnR>
-                    <a:lnT w="38100" cap="flat" cmpd="sng" algn="ctr">
-                      <a:solidFill>
-                        <a:srgbClr val="FFFFFF"/>
-                      </a:solidFill>
-                      <a:prstDash val="solid"/>
-                      <a:round/>
-                      <a:headEnd type="none" w="med" len="med"/>
-                      <a:tailEnd type="none" w="med" len="med"/>
-                    </a:lnT>
-                    <a:lnB w="38100" cap="flat" cmpd="sng" algn="ctr">
-                      <a:solidFill>
-                        <a:srgbClr val="FFFFFF"/>
-                      </a:solidFill>
-                      <a:prstDash val="solid"/>
-                      <a:round/>
-                      <a:headEnd type="none" w="med" len="med"/>
-                      <a:tailEnd type="none" w="med" len="med"/>
-                    </a:lnB>
-                    <a:solidFill>
-                      <a:srgbClr val="FFFFFF"/>
-                    </a:solidFill>
-                  </a:tcPr>
-                </a:tc>
-                <a:tc>
-                  <a:txBody>
-                    <a:bodyPr/>
-                    <a:lstStyle/>
-                    <a:p>
-                      <a:pPr algn="ctr" indent="0" marL="0">
-                        <a:buNone/>
-                      </a:pPr>
-                      <a:r>
-                        <a:rPr lang="en-US" sz="1200" b="1" dirty="0">
-                          <a:solidFill>
-                            <a:srgbClr val="86868B"/>
-                          </a:solidFill>
-                          <a:latin typeface="Calibri" pitchFamily="34" charset="0"/>
-                          <a:ea typeface="Calibri" pitchFamily="34" charset="-122"/>
-                          <a:cs typeface="Calibri" pitchFamily="34" charset="-120"/>
-                        </a:rPr>
-                        <a:t>ABRUPT POISON</a:t>
-                      </a:r>
-                      <a:endParaRPr lang="en-US" sz="1200" dirty="0">
-                        <a:latin typeface="Calibri" charset="0"/>
-                        <a:ea typeface="Calibri" charset="0"/>
-                        <a:cs typeface="Calibri" charset="0"/>
-                      </a:endParaRPr>
-                    </a:p>
-                  </a:txBody>
-                  <a:tcPr marL="91440" marR="91440" marT="45720" marB="45720" anchor="ctr">
-                    <a:lnL w="38100" cap="flat" cmpd="sng" algn="ctr">
-                      <a:solidFill>
-                        <a:srgbClr val="FFFFFF"/>
-                      </a:solidFill>
-                      <a:prstDash val="solid"/>
-                      <a:round/>
-                      <a:headEnd type="none" w="med" len="med"/>
-                      <a:tailEnd type="none" w="med" len="med"/>
-                    </a:lnL>
-                    <a:lnR w="38100" cap="flat" cmpd="sng" algn="ctr">
-                      <a:solidFill>
-                        <a:srgbClr val="FFFFFF"/>
-                      </a:solidFill>
-                      <a:prstDash val="solid"/>
-                      <a:round/>
-                      <a:headEnd type="none" w="med" len="med"/>
-                      <a:tailEnd type="none" w="med" len="med"/>
-                    </a:lnR>
-                    <a:lnT w="38100" cap="flat" cmpd="sng" algn="ctr">
-                      <a:solidFill>
-                        <a:srgbClr val="FFFFFF"/>
-                      </a:solidFill>
-                      <a:prstDash val="solid"/>
-                      <a:round/>
-                      <a:headEnd type="none" w="med" len="med"/>
-                      <a:tailEnd type="none" w="med" len="med"/>
-                    </a:lnT>
-                    <a:lnB w="38100" cap="flat" cmpd="sng" algn="ctr">
-                      <a:solidFill>
-                        <a:srgbClr val="FFFFFF"/>
-                      </a:solidFill>
-                      <a:prstDash val="solid"/>
-                      <a:round/>
-                      <a:headEnd type="none" w="med" len="med"/>
-                      <a:tailEnd type="none" w="med" len="med"/>
-                    </a:lnB>
-                    <a:solidFill>
-                      <a:srgbClr val="FFFFFF"/>
-                    </a:solidFill>
-                  </a:tcPr>
-                </a:tc>
-                <a:tc>
-                  <a:txBody>
-                    <a:bodyPr/>
-                    <a:lstStyle/>
-                    <a:p>
-                      <a:pPr algn="ctr" indent="0" marL="0">
-                        <a:buNone/>
-                      </a:pPr>
-                      <a:r>
-                        <a:rPr lang="en-US" sz="1200" b="1" dirty="0">
-                          <a:solidFill>
-                            <a:srgbClr val="86868B"/>
-                          </a:solidFill>
-                          <a:latin typeface="Calibri" pitchFamily="34" charset="0"/>
-                          <a:ea typeface="Calibri" pitchFamily="34" charset="-122"/>
-                          <a:cs typeface="Calibri" pitchFamily="34" charset="-120"/>
-                        </a:rPr>
-                        <a:t>PATIENT POISON</a:t>
-                      </a:r>
-                      <a:endParaRPr lang="en-US" sz="1200" dirty="0">
-                        <a:latin typeface="Calibri" charset="0"/>
-                        <a:ea typeface="Calibri" charset="0"/>
-                        <a:cs typeface="Calibri" charset="0"/>
-                      </a:endParaRPr>
-                    </a:p>
-                  </a:txBody>
-                  <a:tcPr marL="91440" marR="91440" marT="45720" marB="45720" anchor="ctr">
-                    <a:lnL w="38100" cap="flat" cmpd="sng" algn="ctr">
-                      <a:solidFill>
-                        <a:srgbClr val="FFFFFF"/>
-                      </a:solidFill>
-                      <a:prstDash val="solid"/>
-                      <a:round/>
-                      <a:headEnd type="none" w="med" len="med"/>
-                      <a:tailEnd type="none" w="med" len="med"/>
-                    </a:lnL>
-                    <a:lnR w="38100" cap="flat" cmpd="sng" algn="ctr">
-                      <a:solidFill>
-                        <a:srgbClr val="FFFFFF"/>
-                      </a:solidFill>
-                      <a:prstDash val="solid"/>
-                      <a:round/>
-                      <a:headEnd type="none" w="med" len="med"/>
-                      <a:tailEnd type="none" w="med" len="med"/>
-                    </a:lnR>
-                    <a:lnT w="38100" cap="flat" cmpd="sng" algn="ctr">
-                      <a:solidFill>
-                        <a:srgbClr val="FFFFFF"/>
-                      </a:solidFill>
-                      <a:prstDash val="solid"/>
-                      <a:round/>
-                      <a:headEnd type="none" w="med" len="med"/>
-                      <a:tailEnd type="none" w="med" len="med"/>
-                    </a:lnT>
-                    <a:lnB w="38100" cap="flat" cmpd="sng" algn="ctr">
-                      <a:solidFill>
-                        <a:srgbClr val="FFFFFF"/>
-                      </a:solidFill>
-                      <a:prstDash val="solid"/>
-                      <a:round/>
-                      <a:headEnd type="none" w="med" len="med"/>
-                      <a:tailEnd type="none" w="med" len="med"/>
-                    </a:lnB>
-                    <a:solidFill>
-                      <a:srgbClr val="FFFFFF"/>
-                    </a:solidFill>
-                  </a:tcPr>
-                </a:tc>
-              </a:tr>
-              <a:tr h="777240">
-                <a:tc>
-                  <a:txBody>
-                    <a:bodyPr/>
-                    <a:lstStyle/>
-                    <a:p>
-                      <a:pPr indent="0" marL="0">
-                        <a:buNone/>
-                      </a:pPr>
-                      <a:r>
-                        <a:rPr lang="en-US" sz="1400" b="1" dirty="0">
-                          <a:solidFill>
-                            <a:srgbClr val="1D1D1F"/>
-                          </a:solidFill>
-                          <a:latin typeface="Calibri" pitchFamily="34" charset="0"/>
-                          <a:ea typeface="Calibri" pitchFamily="34" charset="-122"/>
-                          <a:cs typeface="Calibri" pitchFamily="34" charset="-120"/>
-                        </a:rPr>
-                        <a:t>Layer 1 alone</a:t>
-                      </a:r>
-                      <a:endParaRPr lang="en-US" sz="1400" dirty="0">
-                        <a:latin typeface="Calibri" charset="0"/>
-                        <a:ea typeface="Calibri" charset="0"/>
-                        <a:cs typeface="Calibri" charset="0"/>
-                      </a:endParaRPr>
-                    </a:p>
-                  </a:txBody>
-                  <a:tcPr marL="91440" marR="91440" marT="45720" marB="45720" anchor="ctr">
-                    <a:lnL w="38100" cap="flat" cmpd="sng" algn="ctr">
-                      <a:solidFill>
-                        <a:srgbClr val="FFFFFF"/>
-                      </a:solidFill>
-                      <a:prstDash val="solid"/>
-                      <a:round/>
-                      <a:headEnd type="none" w="med" len="med"/>
-                      <a:tailEnd type="none" w="med" len="med"/>
-                    </a:lnL>
-                    <a:lnR w="38100" cap="flat" cmpd="sng" algn="ctr">
-                      <a:solidFill>
-                        <a:srgbClr val="FFFFFF"/>
-                      </a:solidFill>
-                      <a:prstDash val="solid"/>
-                      <a:round/>
-                      <a:headEnd type="none" w="med" len="med"/>
-                      <a:tailEnd type="none" w="med" len="med"/>
-                    </a:lnR>
-                    <a:lnT w="38100" cap="flat" cmpd="sng" algn="ctr">
-                      <a:solidFill>
-                        <a:srgbClr val="FFFFFF"/>
-                      </a:solidFill>
-                      <a:prstDash val="solid"/>
-                      <a:round/>
-                      <a:headEnd type="none" w="med" len="med"/>
-                      <a:tailEnd type="none" w="med" len="med"/>
-                    </a:lnT>
-                    <a:lnB w="38100" cap="flat" cmpd="sng" algn="ctr">
-                      <a:solidFill>
-                        <a:srgbClr val="FFFFFF"/>
-                      </a:solidFill>
-                      <a:prstDash val="solid"/>
-                      <a:round/>
-                      <a:headEnd type="none" w="med" len="med"/>
-                      <a:tailEnd type="none" w="med" len="med"/>
-                    </a:lnB>
-                    <a:solidFill>
-                      <a:srgbClr val="FFFFFF"/>
-                    </a:solidFill>
-                  </a:tcPr>
-                </a:tc>
-                <a:tc>
-                  <a:txBody>
-                    <a:bodyPr/>
-                    <a:lstStyle/>
-                    <a:p>
-                      <a:pPr algn="ctr" indent="0" marL="0">
-                        <a:buNone/>
-                      </a:pPr>
-                      <a:r>
-                        <a:rPr lang="en-US" sz="1500" b="1" dirty="0">
-                          <a:solidFill>
-                            <a:srgbClr val="248A3D"/>
-                          </a:solidFill>
-                          <a:latin typeface="Calibri" pitchFamily="34" charset="0"/>
-                          <a:ea typeface="Calibri" pitchFamily="34" charset="-122"/>
-                          <a:cs typeface="Calibri" pitchFamily="34" charset="-120"/>
-                        </a:rPr>
-                        <a:t>Caught</a:t>
-                      </a:r>
-                      <a:endParaRPr lang="en-US" sz="1500" dirty="0">
-                        <a:latin typeface="Calibri" charset="0"/>
-                        <a:ea typeface="Calibri" charset="0"/>
-                        <a:cs typeface="Calibri" charset="0"/>
-                      </a:endParaRPr>
-                    </a:p>
-                  </a:txBody>
-                  <a:tcPr marL="91440" marR="91440" marT="45720" marB="45720" anchor="ctr">
-                    <a:lnL w="38100" cap="flat" cmpd="sng" algn="ctr">
-                      <a:solidFill>
-                        <a:srgbClr val="FFFFFF"/>
-                      </a:solidFill>
-                      <a:prstDash val="solid"/>
-                      <a:round/>
-                      <a:headEnd type="none" w="med" len="med"/>
-                      <a:tailEnd type="none" w="med" len="med"/>
-                    </a:lnL>
-                    <a:lnR w="38100" cap="flat" cmpd="sng" algn="ctr">
-                      <a:solidFill>
-                        <a:srgbClr val="FFFFFF"/>
-                      </a:solidFill>
-                      <a:prstDash val="solid"/>
-                      <a:round/>
-                      <a:headEnd type="none" w="med" len="med"/>
-                      <a:tailEnd type="none" w="med" len="med"/>
-                    </a:lnR>
-                    <a:lnT w="38100" cap="flat" cmpd="sng" algn="ctr">
-                      <a:solidFill>
-                        <a:srgbClr val="FFFFFF"/>
-                      </a:solidFill>
-                      <a:prstDash val="solid"/>
-                      <a:round/>
-                      <a:headEnd type="none" w="med" len="med"/>
-                      <a:tailEnd type="none" w="med" len="med"/>
-                    </a:lnT>
-                    <a:lnB w="38100" cap="flat" cmpd="sng" algn="ctr">
-                      <a:solidFill>
-                        <a:srgbClr val="FFFFFF"/>
-                      </a:solidFill>
-                      <a:prstDash val="solid"/>
-                      <a:round/>
-                      <a:headEnd type="none" w="med" len="med"/>
-                      <a:tailEnd type="none" w="med" len="med"/>
-                    </a:lnB>
-                    <a:solidFill>
-                      <a:srgbClr val="F5F5F7"/>
-                    </a:solidFill>
-                  </a:tcPr>
-                </a:tc>
-                <a:tc>
-                  <a:txBody>
-                    <a:bodyPr/>
-                    <a:lstStyle/>
-                    <a:p>
-                      <a:pPr algn="ctr" indent="0" marL="0">
-                        <a:buNone/>
-                      </a:pPr>
-                      <a:r>
-                        <a:rPr lang="en-US" sz="1500" b="1" dirty="0">
-                          <a:solidFill>
-                            <a:srgbClr val="D70015"/>
-                          </a:solidFill>
-                          <a:latin typeface="Calibri" pitchFamily="34" charset="0"/>
-                          <a:ea typeface="Calibri" pitchFamily="34" charset="-122"/>
-                          <a:cs typeface="Calibri" pitchFamily="34" charset="-120"/>
-                        </a:rPr>
-                        <a:t>Missed</a:t>
-                      </a:r>
-                      <a:endParaRPr lang="en-US" sz="1500" dirty="0">
-                        <a:latin typeface="Calibri" charset="0"/>
-                        <a:ea typeface="Calibri" charset="0"/>
-                        <a:cs typeface="Calibri" charset="0"/>
-                      </a:endParaRPr>
-                    </a:p>
-                  </a:txBody>
-                  <a:tcPr marL="91440" marR="91440" marT="45720" marB="45720" anchor="ctr">
-                    <a:lnL w="38100" cap="flat" cmpd="sng" algn="ctr">
-                      <a:solidFill>
-                        <a:srgbClr val="FFFFFF"/>
-                      </a:solidFill>
-                      <a:prstDash val="solid"/>
-                      <a:round/>
-                      <a:headEnd type="none" w="med" len="med"/>
-                      <a:tailEnd type="none" w="med" len="med"/>
-                    </a:lnL>
-                    <a:lnR w="38100" cap="flat" cmpd="sng" algn="ctr">
-                      <a:solidFill>
-                        <a:srgbClr val="FFFFFF"/>
-                      </a:solidFill>
-                      <a:prstDash val="solid"/>
-                      <a:round/>
-                      <a:headEnd type="none" w="med" len="med"/>
-                      <a:tailEnd type="none" w="med" len="med"/>
-                    </a:lnR>
-                    <a:lnT w="38100" cap="flat" cmpd="sng" algn="ctr">
-                      <a:solidFill>
-                        <a:srgbClr val="FFFFFF"/>
-                      </a:solidFill>
-                      <a:prstDash val="solid"/>
-                      <a:round/>
-                      <a:headEnd type="none" w="med" len="med"/>
-                      <a:tailEnd type="none" w="med" len="med"/>
-                    </a:lnT>
-                    <a:lnB w="38100" cap="flat" cmpd="sng" algn="ctr">
-                      <a:solidFill>
-                        <a:srgbClr val="FFFFFF"/>
-                      </a:solidFill>
-                      <a:prstDash val="solid"/>
-                      <a:round/>
-                      <a:headEnd type="none" w="med" len="med"/>
-                      <a:tailEnd type="none" w="med" len="med"/>
-                    </a:lnB>
-                    <a:solidFill>
-                      <a:srgbClr val="F5F5F7"/>
-                    </a:solidFill>
-                  </a:tcPr>
-                </a:tc>
-              </a:tr>
-              <a:tr h="777240">
-                <a:tc>
-                  <a:txBody>
-                    <a:bodyPr/>
-                    <a:lstStyle/>
-                    <a:p>
-                      <a:pPr indent="0" marL="0">
-                        <a:buNone/>
-                      </a:pPr>
-                      <a:r>
-                        <a:rPr lang="en-US" sz="1400" b="1" dirty="0">
-                          <a:solidFill>
-                            <a:srgbClr val="1D1D1F"/>
-                          </a:solidFill>
-                          <a:latin typeface="Calibri" pitchFamily="34" charset="0"/>
-                          <a:ea typeface="Calibri" pitchFamily="34" charset="-122"/>
-                          <a:cs typeface="Calibri" pitchFamily="34" charset="-120"/>
-                        </a:rPr>
-                        <a:t>Layer 2 alone</a:t>
-                      </a:r>
-                      <a:endParaRPr lang="en-US" sz="1400" dirty="0">
-                        <a:latin typeface="Calibri" charset="0"/>
-                        <a:ea typeface="Calibri" charset="0"/>
-                        <a:cs typeface="Calibri" charset="0"/>
-                      </a:endParaRPr>
-                    </a:p>
-                  </a:txBody>
-                  <a:tcPr marL="91440" marR="91440" marT="45720" marB="45720" anchor="ctr">
-                    <a:lnL w="38100" cap="flat" cmpd="sng" algn="ctr">
-                      <a:solidFill>
-                        <a:srgbClr val="FFFFFF"/>
-                      </a:solidFill>
-                      <a:prstDash val="solid"/>
-                      <a:round/>
-                      <a:headEnd type="none" w="med" len="med"/>
-                      <a:tailEnd type="none" w="med" len="med"/>
-                    </a:lnL>
-                    <a:lnR w="38100" cap="flat" cmpd="sng" algn="ctr">
-                      <a:solidFill>
-                        <a:srgbClr val="FFFFFF"/>
-                      </a:solidFill>
-                      <a:prstDash val="solid"/>
-                      <a:round/>
-                      <a:headEnd type="none" w="med" len="med"/>
-                      <a:tailEnd type="none" w="med" len="med"/>
-                    </a:lnR>
-                    <a:lnT w="38100" cap="flat" cmpd="sng" algn="ctr">
-                      <a:solidFill>
-                        <a:srgbClr val="FFFFFF"/>
-                      </a:solidFill>
-                      <a:prstDash val="solid"/>
-                      <a:round/>
-                      <a:headEnd type="none" w="med" len="med"/>
-                      <a:tailEnd type="none" w="med" len="med"/>
-                    </a:lnT>
-                    <a:lnB w="38100" cap="flat" cmpd="sng" algn="ctr">
-                      <a:solidFill>
-                        <a:srgbClr val="FFFFFF"/>
-                      </a:solidFill>
-                      <a:prstDash val="solid"/>
-                      <a:round/>
-                      <a:headEnd type="none" w="med" len="med"/>
-                      <a:tailEnd type="none" w="med" len="med"/>
-                    </a:lnB>
-                    <a:solidFill>
-                      <a:srgbClr val="FFFFFF"/>
-                    </a:solidFill>
-                  </a:tcPr>
-                </a:tc>
-                <a:tc>
-                  <a:txBody>
-                    <a:bodyPr/>
-                    <a:lstStyle/>
-                    <a:p>
-                      <a:pPr algn="ctr" indent="0" marL="0">
-                        <a:buNone/>
-                      </a:pPr>
-                      <a:r>
-                        <a:rPr lang="en-US" sz="1500" b="1" dirty="0">
-                          <a:solidFill>
-                            <a:srgbClr val="248A3D"/>
-                          </a:solidFill>
-                          <a:latin typeface="Calibri" pitchFamily="34" charset="0"/>
-                          <a:ea typeface="Calibri" pitchFamily="34" charset="-122"/>
-                          <a:cs typeface="Calibri" pitchFamily="34" charset="-120"/>
-                        </a:rPr>
-                        <a:t>Caught</a:t>
-                      </a:r>
-                      <a:endParaRPr lang="en-US" sz="1500" dirty="0">
-                        <a:latin typeface="Calibri" charset="0"/>
-                        <a:ea typeface="Calibri" charset="0"/>
-                        <a:cs typeface="Calibri" charset="0"/>
-                      </a:endParaRPr>
-                    </a:p>
-                  </a:txBody>
-                  <a:tcPr marL="91440" marR="91440" marT="45720" marB="45720" anchor="ctr">
-                    <a:lnL w="38100" cap="flat" cmpd="sng" algn="ctr">
-                      <a:solidFill>
-                        <a:srgbClr val="FFFFFF"/>
-                      </a:solidFill>
-                      <a:prstDash val="solid"/>
-                      <a:round/>
-                      <a:headEnd type="none" w="med" len="med"/>
-                      <a:tailEnd type="none" w="med" len="med"/>
-                    </a:lnL>
-                    <a:lnR w="38100" cap="flat" cmpd="sng" algn="ctr">
-                      <a:solidFill>
-                        <a:srgbClr val="FFFFFF"/>
-                      </a:solidFill>
-                      <a:prstDash val="solid"/>
-                      <a:round/>
-                      <a:headEnd type="none" w="med" len="med"/>
-                      <a:tailEnd type="none" w="med" len="med"/>
-                    </a:lnR>
-                    <a:lnT w="38100" cap="flat" cmpd="sng" algn="ctr">
-                      <a:solidFill>
-                        <a:srgbClr val="FFFFFF"/>
-                      </a:solidFill>
-                      <a:prstDash val="solid"/>
-                      <a:round/>
-                      <a:headEnd type="none" w="med" len="med"/>
-                      <a:tailEnd type="none" w="med" len="med"/>
-                    </a:lnT>
-                    <a:lnB w="38100" cap="flat" cmpd="sng" algn="ctr">
-                      <a:solidFill>
-                        <a:srgbClr val="FFFFFF"/>
-                      </a:solidFill>
-                      <a:prstDash val="solid"/>
-                      <a:round/>
-                      <a:headEnd type="none" w="med" len="med"/>
-                      <a:tailEnd type="none" w="med" len="med"/>
-                    </a:lnB>
-                    <a:solidFill>
-                      <a:srgbClr val="F5F5F7"/>
-                    </a:solidFill>
-                  </a:tcPr>
-                </a:tc>
-                <a:tc>
-                  <a:txBody>
-                    <a:bodyPr/>
-                    <a:lstStyle/>
-                    <a:p>
-                      <a:pPr algn="ctr" indent="0" marL="0">
-                        <a:buNone/>
-                      </a:pPr>
-                      <a:r>
-                        <a:rPr lang="en-US" sz="1500" b="1" dirty="0">
-                          <a:solidFill>
-                            <a:srgbClr val="248A3D"/>
-                          </a:solidFill>
-                          <a:latin typeface="Calibri" pitchFamily="34" charset="0"/>
-                          <a:ea typeface="Calibri" pitchFamily="34" charset="-122"/>
-                          <a:cs typeface="Calibri" pitchFamily="34" charset="-120"/>
-                        </a:rPr>
-                        <a:t>Caught, but slow to adapt</a:t>
-                      </a:r>
-                      <a:endParaRPr lang="en-US" sz="1500" dirty="0">
-                        <a:latin typeface="Calibri" charset="0"/>
-                        <a:ea typeface="Calibri" charset="0"/>
-                        <a:cs typeface="Calibri" charset="0"/>
-                      </a:endParaRPr>
-                    </a:p>
-                  </a:txBody>
-                  <a:tcPr marL="91440" marR="91440" marT="45720" marB="45720" anchor="ctr">
-                    <a:lnL w="38100" cap="flat" cmpd="sng" algn="ctr">
-                      <a:solidFill>
-                        <a:srgbClr val="FFFFFF"/>
-                      </a:solidFill>
-                      <a:prstDash val="solid"/>
-                      <a:round/>
-                      <a:headEnd type="none" w="med" len="med"/>
-                      <a:tailEnd type="none" w="med" len="med"/>
-                    </a:lnL>
-                    <a:lnR w="38100" cap="flat" cmpd="sng" algn="ctr">
-                      <a:solidFill>
-                        <a:srgbClr val="FFFFFF"/>
-                      </a:solidFill>
-                      <a:prstDash val="solid"/>
-                      <a:round/>
-                      <a:headEnd type="none" w="med" len="med"/>
-                      <a:tailEnd type="none" w="med" len="med"/>
-                    </a:lnR>
-                    <a:lnT w="38100" cap="flat" cmpd="sng" algn="ctr">
-                      <a:solidFill>
-                        <a:srgbClr val="FFFFFF"/>
-                      </a:solidFill>
-                      <a:prstDash val="solid"/>
-                      <a:round/>
-                      <a:headEnd type="none" w="med" len="med"/>
-                      <a:tailEnd type="none" w="med" len="med"/>
-                    </a:lnT>
-                    <a:lnB w="38100" cap="flat" cmpd="sng" algn="ctr">
-                      <a:solidFill>
-                        <a:srgbClr val="FFFFFF"/>
-                      </a:solidFill>
-                      <a:prstDash val="solid"/>
-                      <a:round/>
-                      <a:headEnd type="none" w="med" len="med"/>
-                      <a:tailEnd type="none" w="med" len="med"/>
-                    </a:lnB>
-                    <a:solidFill>
-                      <a:srgbClr val="F5F5F7"/>
-                    </a:solidFill>
-                  </a:tcPr>
-                </a:tc>
-              </a:tr>
-              <a:tr h="777240">
-                <a:tc>
-                  <a:txBody>
-                    <a:bodyPr/>
-                    <a:lstStyle/>
-                    <a:p>
-                      <a:pPr indent="0" marL="0">
-                        <a:buNone/>
-                      </a:pPr>
-                      <a:r>
-                        <a:rPr lang="en-US" sz="1400" b="1" dirty="0">
-                          <a:solidFill>
-                            <a:srgbClr val="1D1D1F"/>
-                          </a:solidFill>
-                          <a:latin typeface="Calibri" pitchFamily="34" charset="0"/>
-                          <a:ea typeface="Calibri" pitchFamily="34" charset="-122"/>
-                          <a:cs typeface="Calibri" pitchFamily="34" charset="-120"/>
-                        </a:rPr>
-                        <a:t>TimeGuard (both)</a:t>
-                      </a:r>
-                      <a:endParaRPr lang="en-US" sz="1400" dirty="0">
-                        <a:latin typeface="Calibri" charset="0"/>
-                        <a:ea typeface="Calibri" charset="0"/>
-                        <a:cs typeface="Calibri" charset="0"/>
-                      </a:endParaRPr>
-                    </a:p>
-                  </a:txBody>
-                  <a:tcPr marL="91440" marR="91440" marT="45720" marB="45720" anchor="ctr">
-                    <a:lnL w="38100" cap="flat" cmpd="sng" algn="ctr">
-                      <a:solidFill>
-                        <a:srgbClr val="FFFFFF"/>
-                      </a:solidFill>
-                      <a:prstDash val="solid"/>
-                      <a:round/>
-                      <a:headEnd type="none" w="med" len="med"/>
-                      <a:tailEnd type="none" w="med" len="med"/>
-                    </a:lnL>
-                    <a:lnR w="38100" cap="flat" cmpd="sng" algn="ctr">
-                      <a:solidFill>
-                        <a:srgbClr val="FFFFFF"/>
-                      </a:solidFill>
-                      <a:prstDash val="solid"/>
-                      <a:round/>
-                      <a:headEnd type="none" w="med" len="med"/>
-                      <a:tailEnd type="none" w="med" len="med"/>
-                    </a:lnR>
-                    <a:lnT w="38100" cap="flat" cmpd="sng" algn="ctr">
-                      <a:solidFill>
-                        <a:srgbClr val="FFFFFF"/>
-                      </a:solidFill>
-                      <a:prstDash val="solid"/>
-                      <a:round/>
-                      <a:headEnd type="none" w="med" len="med"/>
-                      <a:tailEnd type="none" w="med" len="med"/>
-                    </a:lnT>
-                    <a:lnB w="38100" cap="flat" cmpd="sng" algn="ctr">
-                      <a:solidFill>
-                        <a:srgbClr val="FFFFFF"/>
-                      </a:solidFill>
-                      <a:prstDash val="solid"/>
-                      <a:round/>
-                      <a:headEnd type="none" w="med" len="med"/>
-                      <a:tailEnd type="none" w="med" len="med"/>
-                    </a:lnB>
-                    <a:solidFill>
-                      <a:srgbClr val="FFFFFF"/>
-                    </a:solidFill>
-                  </a:tcPr>
-                </a:tc>
-                <a:tc>
-                  <a:txBody>
-                    <a:bodyPr/>
-                    <a:lstStyle/>
-                    <a:p>
-                      <a:pPr algn="ctr" indent="0" marL="0">
-                        <a:buNone/>
-                      </a:pPr>
-                      <a:r>
-                        <a:rPr lang="en-US" sz="1500" b="1" dirty="0">
-                          <a:solidFill>
-                            <a:srgbClr val="248A3D"/>
-                          </a:solidFill>
-                          <a:latin typeface="Calibri" pitchFamily="34" charset="0"/>
-                          <a:ea typeface="Calibri" pitchFamily="34" charset="-122"/>
-                          <a:cs typeface="Calibri" pitchFamily="34" charset="-120"/>
-                        </a:rPr>
-                        <a:t>Caught</a:t>
-                      </a:r>
-                      <a:endParaRPr lang="en-US" sz="1500" dirty="0">
-                        <a:latin typeface="Calibri" charset="0"/>
-                        <a:ea typeface="Calibri" charset="0"/>
-                        <a:cs typeface="Calibri" charset="0"/>
-                      </a:endParaRPr>
-                    </a:p>
-                  </a:txBody>
-                  <a:tcPr marL="91440" marR="91440" marT="45720" marB="45720" anchor="ctr">
-                    <a:lnL w="38100" cap="flat" cmpd="sng" algn="ctr">
-                      <a:solidFill>
-                        <a:srgbClr val="FFFFFF"/>
-                      </a:solidFill>
-                      <a:prstDash val="solid"/>
-                      <a:round/>
-                      <a:headEnd type="none" w="med" len="med"/>
-                      <a:tailEnd type="none" w="med" len="med"/>
-                    </a:lnL>
-                    <a:lnR w="38100" cap="flat" cmpd="sng" algn="ctr">
-                      <a:solidFill>
-                        <a:srgbClr val="FFFFFF"/>
-                      </a:solidFill>
-                      <a:prstDash val="solid"/>
-                      <a:round/>
-                      <a:headEnd type="none" w="med" len="med"/>
-                      <a:tailEnd type="none" w="med" len="med"/>
-                    </a:lnR>
-                    <a:lnT w="38100" cap="flat" cmpd="sng" algn="ctr">
-                      <a:solidFill>
-                        <a:srgbClr val="FFFFFF"/>
-                      </a:solidFill>
-                      <a:prstDash val="solid"/>
-                      <a:round/>
-                      <a:headEnd type="none" w="med" len="med"/>
-                      <a:tailEnd type="none" w="med" len="med"/>
-                    </a:lnT>
-                    <a:lnB w="38100" cap="flat" cmpd="sng" algn="ctr">
-                      <a:solidFill>
-                        <a:srgbClr val="FFFFFF"/>
-                      </a:solidFill>
-                      <a:prstDash val="solid"/>
-                      <a:round/>
-                      <a:headEnd type="none" w="med" len="med"/>
-                      <a:tailEnd type="none" w="med" len="med"/>
-                    </a:lnB>
-                    <a:solidFill>
-                      <a:srgbClr val="F5F5F7"/>
-                    </a:solidFill>
-                  </a:tcPr>
-                </a:tc>
-                <a:tc>
-                  <a:txBody>
-                    <a:bodyPr/>
-                    <a:lstStyle/>
-                    <a:p>
-                      <a:pPr algn="ctr" indent="0" marL="0">
-                        <a:buNone/>
-                      </a:pPr>
-                      <a:r>
-                        <a:rPr lang="en-US" sz="1500" b="1" dirty="0">
-                          <a:solidFill>
-                            <a:srgbClr val="248A3D"/>
-                          </a:solidFill>
-                          <a:latin typeface="Calibri" pitchFamily="34" charset="0"/>
-                          <a:ea typeface="Calibri" pitchFamily="34" charset="-122"/>
-                          <a:cs typeface="Calibri" pitchFamily="34" charset="-120"/>
-                        </a:rPr>
-                        <a:t>Caught</a:t>
-                      </a:r>
-                      <a:endParaRPr lang="en-US" sz="1500" dirty="0">
-                        <a:latin typeface="Calibri" charset="0"/>
-                        <a:ea typeface="Calibri" charset="0"/>
-                        <a:cs typeface="Calibri" charset="0"/>
-                      </a:endParaRPr>
-                    </a:p>
-                  </a:txBody>
-                  <a:tcPr marL="91440" marR="91440" marT="45720" marB="45720" anchor="ctr">
-                    <a:lnL w="38100" cap="flat" cmpd="sng" algn="ctr">
-                      <a:solidFill>
-                        <a:srgbClr val="FFFFFF"/>
-                      </a:solidFill>
-                      <a:prstDash val="solid"/>
-                      <a:round/>
-                      <a:headEnd type="none" w="med" len="med"/>
-                      <a:tailEnd type="none" w="med" len="med"/>
-                    </a:lnL>
-                    <a:lnR w="38100" cap="flat" cmpd="sng" algn="ctr">
-                      <a:solidFill>
-                        <a:srgbClr val="FFFFFF"/>
-                      </a:solidFill>
-                      <a:prstDash val="solid"/>
-                      <a:round/>
-                      <a:headEnd type="none" w="med" len="med"/>
-                      <a:tailEnd type="none" w="med" len="med"/>
-                    </a:lnR>
-                    <a:lnT w="38100" cap="flat" cmpd="sng" algn="ctr">
-                      <a:solidFill>
-                        <a:srgbClr val="FFFFFF"/>
-                      </a:solidFill>
-                      <a:prstDash val="solid"/>
-                      <a:round/>
-                      <a:headEnd type="none" w="med" len="med"/>
-                      <a:tailEnd type="none" w="med" len="med"/>
-                    </a:lnT>
-                    <a:lnB w="38100" cap="flat" cmpd="sng" algn="ctr">
-                      <a:solidFill>
-                        <a:srgbClr val="FFFFFF"/>
-                      </a:solidFill>
-                      <a:prstDash val="solid"/>
-                      <a:round/>
-                      <a:headEnd type="none" w="med" len="med"/>
-                      <a:tailEnd type="none" w="med" len="med"/>
-                    </a:lnB>
-                    <a:solidFill>
-                      <a:srgbClr val="F5F5F7"/>
-                    </a:solidFill>
-                  </a:tcPr>
-                </a:tc>
-              </a:tr>
-            </a:tbl>
-          </a:graphicData>
-        </a:graphic>
-      </p:graphicFrame>
-      <p:sp>
-        <p:nvSpPr>
-          <p:cNvPr id="7" name="Text 4"/>
-          <p:cNvSpPr txBox="1"/>
-          <p:nvPr/>
-        </p:nvSpPr>
-        <p:spPr>
-          <a:xfrm>
-            <a:off x="6035040" y="5120640"/>
-            <a:ext cx="5349240" cy="274320"/>
+              <a:t>Real ISP traffic drifts steadily for weeks, with volume down 52% at semester end [16]. So 'steady drift means attack' would raise false alarms. What matters is drift toward an attack.</a:t>
+            </a:r>
+            <a:endParaRPr lang="en-US" sz="1400" dirty="0"/>
+          </a:p>
+        </p:txBody>
+      </p:sp>
+      <p:sp>
+        <p:nvSpPr>
+          <p:cNvPr id="8" name="Text 6"/>
+          <p:cNvSpPr txBox="1"/>
+          <p:nvPr/>
+        </p:nvSpPr>
+        <p:spPr>
+          <a:xfrm>
+            <a:off x="822960" y="3474720"/>
+            <a:ext cx="731520" cy="457200"/>
           </a:xfrm>
           <a:prstGeom prst="rect">
             <a:avLst/>
@@ -9372,23 +8089,224 @@
               <a:buNone/>
             </a:pPr>
             <a:r>
-              <a:rPr lang="en-US" sz="1150" i="1" dirty="0">
-                <a:solidFill>
-                  <a:srgbClr val="86868B"/>
-                </a:solidFill>
-                <a:latin typeface="Calibri" pitchFamily="34" charset="0"/>
-                <a:ea typeface="Calibri" pitchFamily="34" charset="-122"/>
-                <a:cs typeface="Calibri" pitchFamily="34" charset="-120"/>
-              </a:rPr>
-              <a:t>Expected pattern. Our ablation will test each cell.</a:t>
-            </a:r>
-            <a:endParaRPr lang="en-US" sz="1150" dirty="0"/>
-          </a:p>
-        </p:txBody>
-      </p:sp>
-      <p:sp>
-        <p:nvSpPr>
-          <p:cNvPr id="8" name="Text 5"/>
+              <a:rPr lang="en-US" sz="2200" b="1" dirty="0">
+                <a:solidFill>
+                  <a:srgbClr val="0071E3"/>
+                </a:solidFill>
+                <a:latin typeface="Calibri" pitchFamily="34" charset="0"/>
+                <a:ea typeface="Calibri" pitchFamily="34" charset="-122"/>
+                <a:cs typeface="Calibri" pitchFamily="34" charset="-120"/>
+              </a:rPr>
+              <a:t>02</a:t>
+            </a:r>
+            <a:endParaRPr lang="en-US" sz="2200" dirty="0"/>
+          </a:p>
+        </p:txBody>
+      </p:sp>
+      <p:sp>
+        <p:nvSpPr>
+          <p:cNvPr id="9" name="Text 7"/>
+          <p:cNvSpPr txBox="1"/>
+          <p:nvPr/>
+        </p:nvSpPr>
+        <p:spPr>
+          <a:xfrm>
+            <a:off x="1645920" y="3474720"/>
+            <a:ext cx="9692640" cy="384048"/>
+          </a:xfrm>
+          <a:prstGeom prst="rect">
+            <a:avLst/>
+          </a:prstGeom>
+          <a:noFill/>
+          <a:ln/>
+        </p:spPr>
+        <p:txBody>
+          <a:bodyPr wrap="square" lIns="0" tIns="0" rIns="0" bIns="0" rtlCol="0" anchor="ctr"/>
+          <a:lstStyle/>
+          <a:p>
+            <a:pPr indent="0" marL="0">
+              <a:buNone/>
+            </a:pPr>
+            <a:r>
+              <a:rPr lang="en-US" sz="1800" b="1" dirty="0">
+                <a:solidFill>
+                  <a:srgbClr val="1D1D1F"/>
+                </a:solidFill>
+                <a:latin typeface="Calibri" pitchFamily="34" charset="0"/>
+                <a:ea typeface="Calibri" pitchFamily="34" charset="-122"/>
+                <a:cs typeface="Calibri" pitchFamily="34" charset="-120"/>
+              </a:rPr>
+              <a:t>Defenses that freeze can be weaponized.</a:t>
+            </a:r>
+            <a:endParaRPr lang="en-US" sz="1800" dirty="0"/>
+          </a:p>
+        </p:txBody>
+      </p:sp>
+      <p:sp>
+        <p:nvSpPr>
+          <p:cNvPr id="10" name="Text 8"/>
+          <p:cNvSpPr txBox="1"/>
+          <p:nvPr/>
+        </p:nvSpPr>
+        <p:spPr>
+          <a:xfrm>
+            <a:off x="1645920" y="3877056"/>
+            <a:ext cx="9692640" cy="731520"/>
+          </a:xfrm>
+          <a:prstGeom prst="rect">
+            <a:avLst/>
+          </a:prstGeom>
+          <a:noFill/>
+          <a:ln/>
+        </p:spPr>
+        <p:txBody>
+          <a:bodyPr wrap="square" lIns="0" tIns="0" rIns="0" bIns="0" rtlCol="0" anchor="t"/>
+          <a:lstStyle/>
+          <a:p>
+            <a:pPr indent="0" marL="0">
+              <a:lnSpc>
+                <a:spcPct val="108000"/>
+              </a:lnSpc>
+              <a:buNone/>
+            </a:pPr>
+            <a:r>
+              <a:rPr lang="en-US" sz="1400" dirty="0">
+                <a:solidFill>
+                  <a:srgbClr val="424245"/>
+                </a:solidFill>
+                <a:latin typeface="Calibri" pitchFamily="34" charset="0"/>
+                <a:ea typeface="Calibri" pitchFamily="34" charset="-122"/>
+                <a:cs typeface="Calibri" pitchFamily="34" charset="-120"/>
+              </a:rPr>
+              <a:t>An attacker trips the freeze, then leaves. Honest drift continues and the frozen detector drowns in false alarms until someone turns it off. We found no prior work naming this.</a:t>
+            </a:r>
+            <a:endParaRPr lang="en-US" sz="1400" dirty="0"/>
+          </a:p>
+        </p:txBody>
+      </p:sp>
+      <p:sp>
+        <p:nvSpPr>
+          <p:cNvPr id="11" name="Text 9"/>
+          <p:cNvSpPr txBox="1"/>
+          <p:nvPr/>
+        </p:nvSpPr>
+        <p:spPr>
+          <a:xfrm>
+            <a:off x="822960" y="4800600"/>
+            <a:ext cx="731520" cy="457200"/>
+          </a:xfrm>
+          <a:prstGeom prst="rect">
+            <a:avLst/>
+          </a:prstGeom>
+          <a:noFill/>
+          <a:ln/>
+        </p:spPr>
+        <p:txBody>
+          <a:bodyPr wrap="square" lIns="0" tIns="0" rIns="0" bIns="0" rtlCol="0" anchor="ctr"/>
+          <a:lstStyle/>
+          <a:p>
+            <a:pPr indent="0" marL="0">
+              <a:buNone/>
+            </a:pPr>
+            <a:r>
+              <a:rPr lang="en-US" sz="2200" b="1" dirty="0">
+                <a:solidFill>
+                  <a:srgbClr val="0071E3"/>
+                </a:solidFill>
+                <a:latin typeface="Calibri" pitchFamily="34" charset="0"/>
+                <a:ea typeface="Calibri" pitchFamily="34" charset="-122"/>
+                <a:cs typeface="Calibri" pitchFamily="34" charset="-120"/>
+              </a:rPr>
+              <a:t>03</a:t>
+            </a:r>
+            <a:endParaRPr lang="en-US" sz="2200" dirty="0"/>
+          </a:p>
+        </p:txBody>
+      </p:sp>
+      <p:sp>
+        <p:nvSpPr>
+          <p:cNvPr id="12" name="Text 10"/>
+          <p:cNvSpPr txBox="1"/>
+          <p:nvPr/>
+        </p:nvSpPr>
+        <p:spPr>
+          <a:xfrm>
+            <a:off x="1645920" y="4800600"/>
+            <a:ext cx="9692640" cy="384048"/>
+          </a:xfrm>
+          <a:prstGeom prst="rect">
+            <a:avLst/>
+          </a:prstGeom>
+          <a:noFill/>
+          <a:ln/>
+        </p:spPr>
+        <p:txBody>
+          <a:bodyPr wrap="square" lIns="0" tIns="0" rIns="0" bIns="0" rtlCol="0" anchor="ctr"/>
+          <a:lstStyle/>
+          <a:p>
+            <a:pPr indent="0" marL="0">
+              <a:buNone/>
+            </a:pPr>
+            <a:r>
+              <a:rPr lang="en-US" sz="1800" b="1" dirty="0">
+                <a:solidFill>
+                  <a:srgbClr val="1D1D1F"/>
+                </a:solidFill>
+                <a:latin typeface="Calibri" pitchFamily="34" charset="0"/>
+                <a:ea typeface="Calibri" pitchFamily="34" charset="-122"/>
+                <a:cs typeface="Calibri" pitchFamily="34" charset="-120"/>
+              </a:rPr>
+              <a:t>Small IoT devices are easier to poison.</a:t>
+            </a:r>
+            <a:endParaRPr lang="en-US" sz="1800" dirty="0"/>
+          </a:p>
+        </p:txBody>
+      </p:sp>
+      <p:sp>
+        <p:nvSpPr>
+          <p:cNvPr id="13" name="Text 11"/>
+          <p:cNvSpPr txBox="1"/>
+          <p:nvPr/>
+        </p:nvSpPr>
+        <p:spPr>
+          <a:xfrm>
+            <a:off x="1645920" y="5202936"/>
+            <a:ext cx="9692640" cy="731520"/>
+          </a:xfrm>
+          <a:prstGeom prst="rect">
+            <a:avLst/>
+          </a:prstGeom>
+          <a:noFill/>
+          <a:ln/>
+        </p:spPr>
+        <p:txBody>
+          <a:bodyPr wrap="square" lIns="0" tIns="0" rIns="0" bIns="0" rtlCol="0" anchor="t"/>
+          <a:lstStyle/>
+          <a:p>
+            <a:pPr indent="0" marL="0">
+              <a:lnSpc>
+                <a:spcPct val="108000"/>
+              </a:lnSpc>
+              <a:buNone/>
+            </a:pPr>
+            <a:r>
+              <a:rPr lang="en-US" sz="1400" dirty="0">
+                <a:solidFill>
+                  <a:srgbClr val="424245"/>
+                </a:solidFill>
+                <a:latin typeface="Calibri" pitchFamily="34" charset="0"/>
+                <a:ea typeface="Calibri" pitchFamily="34" charset="-122"/>
+                <a:cs typeface="Calibri" pitchFamily="34" charset="-120"/>
+              </a:rPr>
+              <a:t>Poisoning only succeeds when the attacker is a large share of what the detector learns from [15]. A smart plug sends little traffic, so matching it is easy. Open-source ESP32 detectors relearn a rolling baseline with no protection.</a:t>
+            </a:r>
+            <a:endParaRPr lang="en-US" sz="1400" dirty="0"/>
+          </a:p>
+        </p:txBody>
+      </p:sp>
+      <p:sp>
+        <p:nvSpPr>
+          <p:cNvPr id="14" name="Text 12"/>
           <p:cNvSpPr txBox="1"/>
           <p:nvPr/>
         </p:nvSpPr>
@@ -9419,7 +8337,7 @@
                 <a:ea typeface="Calibri" pitchFamily="34" charset="-122"/>
                 <a:cs typeface="Calibri" pitchFamily="34" charset="-120"/>
               </a:rPr>
-              <a:t>[10] Nguyen et al., DISS Workshop at NDSS 2020</a:t>
+              <a:t>[15] Kloft and Laskov, JMLR 2012  ·  [16] Koumar et al., CESNET-TimeSeries24, Scientific Data 2025  ·  ESP32 WIDS: github.com/MashhudFarah/WIDS</a:t>
             </a:r>
             <a:endParaRPr lang="en-US" sz="1000" dirty="0"/>
           </a:p>
@@ -9427,7 +8345,7 @@
       </p:sp>
       <p:sp>
         <p:nvSpPr>
-          <p:cNvPr id="9" name="Text 6"/>
+          <p:cNvPr id="15" name="Text 13"/>
           <p:cNvSpPr txBox="1"/>
           <p:nvPr/>
         </p:nvSpPr>
@@ -9717,7 +8635,7 @@
                 <a:ea typeface="Calibri" pitchFamily="34" charset="-122"/>
                 <a:cs typeface="Calibri" pitchFamily="34" charset="-120"/>
               </a:rPr>
-              <a:t>ESP32 for inference, guard, and cost measurement</a:t>
+              <a:t>ESP32 for the detector, the guard, and cost measurement</a:t>
             </a:r>
             <a:endParaRPr lang="en-US" sz="1450" dirty="0"/>
           </a:p>
@@ -9760,7 +8678,7 @@
                 <a:ea typeface="Calibri" pitchFamily="34" charset="-122"/>
                 <a:cs typeface="Calibri" pitchFamily="34" charset="-120"/>
               </a:rPr>
-              <a:t>Python, NumPy, river (ADWIN), TensorFlow Lite Micro</a:t>
+              <a:t>Python, NumPy, river (ADWIN), ESP-IDF</a:t>
             </a:r>
             <a:endParaRPr lang="en-US" sz="1450" dirty="0"/>
           </a:p>
@@ -9800,7 +8718,7 @@
                 <a:ea typeface="Calibri" pitchFamily="34" charset="-122"/>
                 <a:cs typeface="Calibri" pitchFamily="34" charset="-120"/>
               </a:rPr>
-              <a:t>N-BaIoT [2]: 9 real devices, so new devices create natural drift. CICIoT2023 [11] as a second check.</a:t>
+              <a:t>N-BaIoT [2] with real per-device rates, CICIoT2023 [11], and CESNET-TimeSeries24 [16] for real benign drift</a:t>
             </a:r>
             <a:endParaRPr lang="en-US" sz="1450" dirty="0"/>
           </a:p>
@@ -9973,7 +8891,7 @@
                 <a:ea typeface="Calibri" pitchFamily="34" charset="-122"/>
                 <a:cs typeface="Calibri" pitchFamily="34" charset="-120"/>
               </a:rPr>
-              <a:t>commits every update (key contrast)</a:t>
+              <a:t>commits every update</a:t>
             </a:r>
             <a:endParaRPr lang="en-US" sz="1450" dirty="0"/>
           </a:p>
@@ -10012,7 +8930,7 @@
                 <a:ea typeface="Calibri" pitchFamily="34" charset="-122"/>
                 <a:cs typeface="Calibri" pitchFamily="34" charset="-120"/>
               </a:rPr>
-              <a:t>Frozen anchor [3]</a:t>
+              <a:t>Freeze budget</a:t>
             </a:r>
             <a:endParaRPr lang="en-US" sz="1450" dirty="0"/>
           </a:p>
@@ -10029,7 +8947,7 @@
                 <a:ea typeface="Calibri" pitchFamily="34" charset="-122"/>
                 <a:cs typeface="Calibri" pitchFamily="34" charset="-120"/>
               </a:rPr>
-              <a:t>AOC-IDS style trusted anchor</a:t>
+              <a:t>stops learning once drift looks too large</a:t>
             </a:r>
             <a:endParaRPr lang="en-US" sz="1450" dirty="0"/>
           </a:p>
@@ -10068,7 +8986,7 @@
                 <a:ea typeface="Calibri" pitchFamily="34" charset="-122"/>
                 <a:cs typeface="Calibri" pitchFamily="34" charset="-120"/>
               </a:rPr>
-              <a:t>RONI-lite [13]</a:t>
+              <a:t>Consistency gate [8]</a:t>
             </a:r>
             <a:endParaRPr lang="en-US" sz="1450" dirty="0"/>
           </a:p>
@@ -10085,7 +9003,7 @@
                 <a:ea typeface="Calibri" pitchFamily="34" charset="-122"/>
                 <a:cs typeface="Calibri" pitchFamily="34" charset="-120"/>
               </a:rPr>
-              <a:t>classic retrain-and-compare defense</a:t>
+              <a:t>Krum-style check over its own history</a:t>
             </a:r>
             <a:endParaRPr lang="en-US" sz="1450" dirty="0"/>
           </a:p>
@@ -10124,7 +9042,7 @@
                 <a:ea typeface="Calibri" pitchFamily="34" charset="-122"/>
                 <a:cs typeface="Calibri" pitchFamily="34" charset="-120"/>
               </a:rPr>
-              <a:t>Layer 1 only, Layer 2 only</a:t>
+              <a:t>ANTIDOTE robust PCA [13]</a:t>
             </a:r>
             <a:endParaRPr lang="en-US" sz="1450" dirty="0"/>
           </a:p>
@@ -10141,7 +9059,7 @@
                 <a:ea typeface="Calibri" pitchFamily="34" charset="-122"/>
                 <a:cs typeface="Calibri" pitchFamily="34" charset="-120"/>
               </a:rPr>
-              <a:t>our own ablation</a:t>
+              <a:t>the classic server-side defense</a:t>
             </a:r>
             <a:endParaRPr lang="en-US" sz="1450" dirty="0"/>
           </a:p>
@@ -10180,7 +9098,7 @@
                 <a:ea typeface="Calibri" pitchFamily="34" charset="-122"/>
                 <a:cs typeface="Calibri" pitchFamily="34" charset="-120"/>
               </a:rPr>
-              <a:t>[2] IEEE Pervasive Computing 2018  ·  [11] MDPI Sensors 2023  ·  [13] USENIX LEET 2008</a:t>
+              <a:t>[2] IEEE Pervasive Computing 2018  ·  [8] NeurIPS 2017  ·  [11] MDPI Sensors 2023  ·  [13] ACM IMC 2009  ·  [16] Scientific Data 2025</a:t>
             </a:r>
             <a:endParaRPr lang="en-US" sz="1000" dirty="0"/>
           </a:p>
@@ -10310,7 +9228,7 @@
                 <a:ea typeface="Calibri" pitchFamily="34" charset="-122"/>
                 <a:cs typeface="Calibri" pitchFamily="34" charset="-120"/>
               </a:rPr>
-              <a:t>EVALUATION METRICS</a:t>
+              <a:t>EVALUATION METRICS  ·  PRELIMINARY RESULT</a:t>
             </a:r>
             <a:endParaRPr lang="en-US" sz="1250" dirty="0"/>
           </a:p>
@@ -10352,28 +9270,36 @@
                 <a:ea typeface="Calibri" pitchFamily="34" charset="-122"/>
                 <a:cs typeface="Calibri" pitchFamily="34" charset="-120"/>
               </a:rPr>
-              <a:t>One figure decides it. The rest keep us honest.</a:t>
+              <a:t>We already tested the idea in simulation.</a:t>
             </a:r>
             <a:endParaRPr lang="en-US" sz="2800" dirty="0"/>
           </a:p>
         </p:txBody>
       </p:sp>
-      <p:graphicFrame>
-        <p:nvGraphicFramePr>
-          <p:cNvPr id="5" name="Chart 0" descr=""/>
-          <p:cNvGraphicFramePr/>
-          <p:nvPr/>
-        </p:nvGraphicFramePr>
-        <p:xfrm>
-          <a:off x="822960" y="2103120"/>
-          <a:ext cx="5760720" cy="3749040"/>
-        </p:xfrm>
-        <a:graphic xmlns:a="http://schemas.openxmlformats.org/drawingml/2006/main">
-          <a:graphicData uri="http://schemas.openxmlformats.org/drawingml/2006/chart">
-            <c:chart xmlns:c="http://schemas.openxmlformats.org/drawingml/2006/chart" r:id="rId1"/>
-          </a:graphicData>
-        </a:graphic>
-      </p:graphicFrame>
+      <p:pic>
+        <p:nvPicPr>
+          <p:cNvPr id="5" name="Image 0" descr="/Users/rishitkamboj/Collegeactual/Study/SEM5/iot/research project/brainstorming/experiments/fig_slide.png">    </p:cNvPr>
+          <p:cNvPicPr>
+            <a:picLocks noChangeAspect="1"/>
+          </p:cNvPicPr>
+          <p:nvPr/>
+        </p:nvPicPr>
+        <p:blipFill>
+          <a:blip r:embed="rId1"/>
+          <a:stretch>
+            <a:fillRect/>
+          </a:stretch>
+        </p:blipFill>
+        <p:spPr>
+          <a:xfrm>
+            <a:off x="822960" y="2011680"/>
+            <a:ext cx="10561320" cy="3236976"/>
+          </a:xfrm>
+          <a:prstGeom prst="rect">
+            <a:avLst/>
+          </a:prstGeom>
+        </p:spPr>
+      </p:pic>
       <p:sp>
         <p:nvSpPr>
           <p:cNvPr id="6" name="Text 3"/>
@@ -10382,8 +9308,47 @@
         </p:nvSpPr>
         <p:spPr>
           <a:xfrm>
-            <a:off x="822960" y="5897880"/>
-            <a:ext cx="5760720" cy="274320"/>
+            <a:off x="822960" y="5303520"/>
+            <a:ext cx="10561320" cy="502920"/>
+          </a:xfrm>
+          <a:prstGeom prst="rect">
+            <a:avLst/>
+          </a:prstGeom>
+          <a:noFill/>
+          <a:ln/>
+        </p:spPr>
+        <p:txBody>
+          <a:bodyPr wrap="square" lIns="0" tIns="0" rIns="0" bIns="0" rtlCol="0" anchor="t"/>
+          <a:lstStyle/>
+          <a:p>
+            <a:pPr indent="0" marL="0">
+              <a:buNone/>
+            </a:pPr>
+            <a:r>
+              <a:rPr lang="en-US" sz="1250" dirty="0">
+                <a:solidFill>
+                  <a:srgbClr val="424245"/>
+                </a:solidFill>
+                <a:latin typeface="Calibri" pitchFamily="34" charset="0"/>
+                <a:ea typeface="Calibri" pitchFamily="34" charset="-122"/>
+                <a:cs typeface="Calibri" pitchFamily="34" charset="-120"/>
+              </a:rPr>
+              <a:t>Synthetic data, 5 seeds, attacker at 40% of traffic. Grey band = honest drift, dashed line = poisoning starts. Naive adaptation loses the attack in 24 cycles; freezing defenses keep it but drown in false alarms; ours keeps both.</a:t>
+            </a:r>
+            <a:endParaRPr lang="en-US" sz="1250" dirty="0"/>
+          </a:p>
+        </p:txBody>
+      </p:sp>
+      <p:sp>
+        <p:nvSpPr>
+          <p:cNvPr id="7" name="Text 4"/>
+          <p:cNvSpPr txBox="1"/>
+          <p:nvPr/>
+        </p:nvSpPr>
+        <p:spPr>
+          <a:xfrm>
+            <a:off x="822960" y="5870448"/>
+            <a:ext cx="10561320" cy="365760"/>
           </a:xfrm>
           <a:prstGeom prst="rect">
             <a:avLst/>
@@ -10399,7 +9364,21 @@
               <a:buNone/>
             </a:pPr>
             <a:r>
-              <a:rPr lang="en-US" sz="1100" i="1" dirty="0">
+              <a:rPr lang="en-US" sz="1300" b="1" dirty="0">
+                <a:solidFill>
+                  <a:srgbClr val="1D1D1F"/>
+                </a:solidFill>
+                <a:latin typeface="Calibri" pitchFamily="34" charset="0"/>
+                <a:ea typeface="Calibri" pitchFamily="34" charset="-122"/>
+                <a:cs typeface="Calibri" pitchFamily="34" charset="-120"/>
+              </a:rPr>
+              <a:t>Metrics:  </a:t>
+            </a:r>
+            <a:pPr indent="0" marL="0">
+              <a:buNone/>
+            </a:pPr>
+            <a:r>
+              <a:rPr lang="en-US" sz="1300" dirty="0">
                 <a:solidFill>
                   <a:srgbClr val="86868B"/>
                 </a:solidFill>
@@ -10407,415 +9386,15 @@
                 <a:ea typeface="Calibri" pitchFamily="34" charset="-122"/>
                 <a:cs typeface="Calibri" pitchFamily="34" charset="-120"/>
               </a:rPr>
-              <a:t>Sketch of the expected result, not data yet.</a:t>
-            </a:r>
-            <a:endParaRPr lang="en-US" sz="1100" dirty="0"/>
-          </a:p>
-        </p:txBody>
-      </p:sp>
-      <p:sp>
-        <p:nvSpPr>
-          <p:cNvPr id="7" name="Shape 4"/>
-          <p:cNvSpPr/>
-          <p:nvPr/>
-        </p:nvSpPr>
-        <p:spPr>
-          <a:xfrm>
-            <a:off x="6903720" y="2148840"/>
-            <a:ext cx="4480560" cy="868680"/>
-          </a:xfrm>
-          <a:prstGeom prst="roundRect">
-            <a:avLst>
-              <a:gd name="adj" fmla="val 12632"/>
-            </a:avLst>
-          </a:prstGeom>
-          <a:solidFill>
-            <a:srgbClr val="1D1D1F"/>
-          </a:solidFill>
-          <a:ln/>
-        </p:spPr>
+              <a:t>attack recall and cycles to compromise  ·  false-positive rate under drift  ·  F1, AUROC  ·  ESP32 RAM, latency, energy</a:t>
+            </a:r>
+            <a:endParaRPr lang="en-US" sz="1300" dirty="0"/>
+          </a:p>
+        </p:txBody>
       </p:sp>
       <p:sp>
         <p:nvSpPr>
           <p:cNvPr id="8" name="Text 5"/>
-          <p:cNvSpPr txBox="1"/>
-          <p:nvPr/>
-        </p:nvSpPr>
-        <p:spPr>
-          <a:xfrm>
-            <a:off x="7178040" y="2240280"/>
-            <a:ext cx="3931920" cy="292608"/>
-          </a:xfrm>
-          <a:prstGeom prst="rect">
-            <a:avLst/>
-          </a:prstGeom>
-          <a:noFill/>
-          <a:ln/>
-        </p:spPr>
-        <p:txBody>
-          <a:bodyPr wrap="square" lIns="0" tIns="0" rIns="0" bIns="0" rtlCol="0" anchor="ctr"/>
-          <a:lstStyle/>
-          <a:p>
-            <a:pPr indent="0" marL="0">
-              <a:buNone/>
-            </a:pPr>
-            <a:r>
-              <a:rPr lang="en-US" sz="1400" b="1" dirty="0">
-                <a:solidFill>
-                  <a:srgbClr val="0071E3"/>
-                </a:solidFill>
-                <a:latin typeface="Calibri" pitchFamily="34" charset="0"/>
-                <a:ea typeface="Calibri" pitchFamily="34" charset="-122"/>
-                <a:cs typeface="Calibri" pitchFamily="34" charset="-120"/>
-              </a:rPr>
-              <a:t>Headline</a:t>
-            </a:r>
-            <a:endParaRPr lang="en-US" sz="1400" dirty="0"/>
-          </a:p>
-        </p:txBody>
-      </p:sp>
-      <p:sp>
-        <p:nvSpPr>
-          <p:cNvPr id="9" name="Text 6"/>
-          <p:cNvSpPr txBox="1"/>
-          <p:nvPr/>
-        </p:nvSpPr>
-        <p:spPr>
-          <a:xfrm>
-            <a:off x="7178040" y="2532888"/>
-            <a:ext cx="3931920" cy="411480"/>
-          </a:xfrm>
-          <a:prstGeom prst="rect">
-            <a:avLst/>
-          </a:prstGeom>
-          <a:noFill/>
-          <a:ln/>
-        </p:spPr>
-        <p:txBody>
-          <a:bodyPr wrap="square" lIns="0" tIns="0" rIns="0" bIns="0" rtlCol="0" anchor="t"/>
-          <a:lstStyle/>
-          <a:p>
-            <a:pPr indent="0" marL="0">
-              <a:buNone/>
-            </a:pPr>
-            <a:r>
-              <a:rPr lang="en-US" sz="1250" dirty="0">
-                <a:solidFill>
-                  <a:srgbClr val="FFFFFF"/>
-                </a:solidFill>
-                <a:latin typeface="Calibri" pitchFamily="34" charset="0"/>
-                <a:ea typeface="Calibri" pitchFamily="34" charset="-122"/>
-                <a:cs typeface="Calibri" pitchFamily="34" charset="-120"/>
-              </a:rPr>
-              <a:t>Attack success rate and cycles-to-compromise</a:t>
-            </a:r>
-            <a:endParaRPr lang="en-US" sz="1250" dirty="0"/>
-          </a:p>
-        </p:txBody>
-      </p:sp>
-      <p:sp>
-        <p:nvSpPr>
-          <p:cNvPr id="10" name="Shape 7"/>
-          <p:cNvSpPr/>
-          <p:nvPr/>
-        </p:nvSpPr>
-        <p:spPr>
-          <a:xfrm>
-            <a:off x="6903720" y="3108960"/>
-            <a:ext cx="4480560" cy="868680"/>
-          </a:xfrm>
-          <a:prstGeom prst="roundRect">
-            <a:avLst>
-              <a:gd name="adj" fmla="val 12632"/>
-            </a:avLst>
-          </a:prstGeom>
-          <a:solidFill>
-            <a:srgbClr val="F5F5F7"/>
-          </a:solidFill>
-          <a:ln/>
-        </p:spPr>
-      </p:sp>
-      <p:sp>
-        <p:nvSpPr>
-          <p:cNvPr id="11" name="Text 8"/>
-          <p:cNvSpPr txBox="1"/>
-          <p:nvPr/>
-        </p:nvSpPr>
-        <p:spPr>
-          <a:xfrm>
-            <a:off x="7178040" y="3200400"/>
-            <a:ext cx="3931920" cy="292608"/>
-          </a:xfrm>
-          <a:prstGeom prst="rect">
-            <a:avLst/>
-          </a:prstGeom>
-          <a:noFill/>
-          <a:ln/>
-        </p:spPr>
-        <p:txBody>
-          <a:bodyPr wrap="square" lIns="0" tIns="0" rIns="0" bIns="0" rtlCol="0" anchor="ctr"/>
-          <a:lstStyle/>
-          <a:p>
-            <a:pPr indent="0" marL="0">
-              <a:buNone/>
-            </a:pPr>
-            <a:r>
-              <a:rPr lang="en-US" sz="1400" b="1" dirty="0">
-                <a:solidFill>
-                  <a:srgbClr val="1D1D1F"/>
-                </a:solidFill>
-                <a:latin typeface="Calibri" pitchFamily="34" charset="0"/>
-                <a:ea typeface="Calibri" pitchFamily="34" charset="-122"/>
-                <a:cs typeface="Calibri" pitchFamily="34" charset="-120"/>
-              </a:rPr>
-              <a:t>Honest drift</a:t>
-            </a:r>
-            <a:endParaRPr lang="en-US" sz="1400" dirty="0"/>
-          </a:p>
-        </p:txBody>
-      </p:sp>
-      <p:sp>
-        <p:nvSpPr>
-          <p:cNvPr id="12" name="Text 9"/>
-          <p:cNvSpPr txBox="1"/>
-          <p:nvPr/>
-        </p:nvSpPr>
-        <p:spPr>
-          <a:xfrm>
-            <a:off x="7178040" y="3493008"/>
-            <a:ext cx="3931920" cy="411480"/>
-          </a:xfrm>
-          <a:prstGeom prst="rect">
-            <a:avLst/>
-          </a:prstGeom>
-          <a:noFill/>
-          <a:ln/>
-        </p:spPr>
-        <p:txBody>
-          <a:bodyPr wrap="square" lIns="0" tIns="0" rIns="0" bIns="0" rtlCol="0" anchor="t"/>
-          <a:lstStyle/>
-          <a:p>
-            <a:pPr indent="0" marL="0">
-              <a:buNone/>
-            </a:pPr>
-            <a:r>
-              <a:rPr lang="en-US" sz="1250" dirty="0">
-                <a:solidFill>
-                  <a:srgbClr val="424245"/>
-                </a:solidFill>
-                <a:latin typeface="Calibri" pitchFamily="34" charset="0"/>
-                <a:ea typeface="Calibri" pitchFamily="34" charset="-122"/>
-                <a:cs typeface="Calibri" pitchFamily="34" charset="-120"/>
-              </a:rPr>
-              <a:t>False-positive rate and recovery lag when a new device joins</a:t>
-            </a:r>
-            <a:endParaRPr lang="en-US" sz="1250" dirty="0"/>
-          </a:p>
-        </p:txBody>
-      </p:sp>
-      <p:sp>
-        <p:nvSpPr>
-          <p:cNvPr id="13" name="Shape 10"/>
-          <p:cNvSpPr/>
-          <p:nvPr/>
-        </p:nvSpPr>
-        <p:spPr>
-          <a:xfrm>
-            <a:off x="6903720" y="4069080"/>
-            <a:ext cx="4480560" cy="868680"/>
-          </a:xfrm>
-          <a:prstGeom prst="roundRect">
-            <a:avLst>
-              <a:gd name="adj" fmla="val 12632"/>
-            </a:avLst>
-          </a:prstGeom>
-          <a:solidFill>
-            <a:srgbClr val="F5F5F7"/>
-          </a:solidFill>
-          <a:ln/>
-        </p:spPr>
-      </p:sp>
-      <p:sp>
-        <p:nvSpPr>
-          <p:cNvPr id="14" name="Text 11"/>
-          <p:cNvSpPr txBox="1"/>
-          <p:nvPr/>
-        </p:nvSpPr>
-        <p:spPr>
-          <a:xfrm>
-            <a:off x="7178040" y="4160520"/>
-            <a:ext cx="3931920" cy="292608"/>
-          </a:xfrm>
-          <a:prstGeom prst="rect">
-            <a:avLst/>
-          </a:prstGeom>
-          <a:noFill/>
-          <a:ln/>
-        </p:spPr>
-        <p:txBody>
-          <a:bodyPr wrap="square" lIns="0" tIns="0" rIns="0" bIns="0" rtlCol="0" anchor="ctr"/>
-          <a:lstStyle/>
-          <a:p>
-            <a:pPr indent="0" marL="0">
-              <a:buNone/>
-            </a:pPr>
-            <a:r>
-              <a:rPr lang="en-US" sz="1400" b="1" dirty="0">
-                <a:solidFill>
-                  <a:srgbClr val="1D1D1F"/>
-                </a:solidFill>
-                <a:latin typeface="Calibri" pitchFamily="34" charset="0"/>
-                <a:ea typeface="Calibri" pitchFamily="34" charset="-122"/>
-                <a:cs typeface="Calibri" pitchFamily="34" charset="-120"/>
-              </a:rPr>
-              <a:t>Detection</a:t>
-            </a:r>
-            <a:endParaRPr lang="en-US" sz="1400" dirty="0"/>
-          </a:p>
-        </p:txBody>
-      </p:sp>
-      <p:sp>
-        <p:nvSpPr>
-          <p:cNvPr id="15" name="Text 12"/>
-          <p:cNvSpPr txBox="1"/>
-          <p:nvPr/>
-        </p:nvSpPr>
-        <p:spPr>
-          <a:xfrm>
-            <a:off x="7178040" y="4453128"/>
-            <a:ext cx="3931920" cy="411480"/>
-          </a:xfrm>
-          <a:prstGeom prst="rect">
-            <a:avLst/>
-          </a:prstGeom>
-          <a:noFill/>
-          <a:ln/>
-        </p:spPr>
-        <p:txBody>
-          <a:bodyPr wrap="square" lIns="0" tIns="0" rIns="0" bIns="0" rtlCol="0" anchor="t"/>
-          <a:lstStyle/>
-          <a:p>
-            <a:pPr indent="0" marL="0">
-              <a:buNone/>
-            </a:pPr>
-            <a:r>
-              <a:rPr lang="en-US" sz="1250" dirty="0">
-                <a:solidFill>
-                  <a:srgbClr val="424245"/>
-                </a:solidFill>
-                <a:latin typeface="Calibri" pitchFamily="34" charset="0"/>
-                <a:ea typeface="Calibri" pitchFamily="34" charset="-122"/>
-                <a:cs typeface="Calibri" pitchFamily="34" charset="-120"/>
-              </a:rPr>
-              <a:t>F1, AUROC, TPR at 1% FPR</a:t>
-            </a:r>
-            <a:endParaRPr lang="en-US" sz="1250" dirty="0"/>
-          </a:p>
-        </p:txBody>
-      </p:sp>
-      <p:sp>
-        <p:nvSpPr>
-          <p:cNvPr id="16" name="Shape 13"/>
-          <p:cNvSpPr/>
-          <p:nvPr/>
-        </p:nvSpPr>
-        <p:spPr>
-          <a:xfrm>
-            <a:off x="6903720" y="5029200"/>
-            <a:ext cx="4480560" cy="868680"/>
-          </a:xfrm>
-          <a:prstGeom prst="roundRect">
-            <a:avLst>
-              <a:gd name="adj" fmla="val 12632"/>
-            </a:avLst>
-          </a:prstGeom>
-          <a:solidFill>
-            <a:srgbClr val="F5F5F7"/>
-          </a:solidFill>
-          <a:ln/>
-        </p:spPr>
-      </p:sp>
-      <p:sp>
-        <p:nvSpPr>
-          <p:cNvPr id="17" name="Text 14"/>
-          <p:cNvSpPr txBox="1"/>
-          <p:nvPr/>
-        </p:nvSpPr>
-        <p:spPr>
-          <a:xfrm>
-            <a:off x="7178040" y="5120640"/>
-            <a:ext cx="3931920" cy="292608"/>
-          </a:xfrm>
-          <a:prstGeom prst="rect">
-            <a:avLst/>
-          </a:prstGeom>
-          <a:noFill/>
-          <a:ln/>
-        </p:spPr>
-        <p:txBody>
-          <a:bodyPr wrap="square" lIns="0" tIns="0" rIns="0" bIns="0" rtlCol="0" anchor="ctr"/>
-          <a:lstStyle/>
-          <a:p>
-            <a:pPr indent="0" marL="0">
-              <a:buNone/>
-            </a:pPr>
-            <a:r>
-              <a:rPr lang="en-US" sz="1400" b="1" dirty="0">
-                <a:solidFill>
-                  <a:srgbClr val="1D1D1F"/>
-                </a:solidFill>
-                <a:latin typeface="Calibri" pitchFamily="34" charset="0"/>
-                <a:ea typeface="Calibri" pitchFamily="34" charset="-122"/>
-                <a:cs typeface="Calibri" pitchFamily="34" charset="-120"/>
-              </a:rPr>
-              <a:t>On the ESP32</a:t>
-            </a:r>
-            <a:endParaRPr lang="en-US" sz="1400" dirty="0"/>
-          </a:p>
-        </p:txBody>
-      </p:sp>
-      <p:sp>
-        <p:nvSpPr>
-          <p:cNvPr id="18" name="Text 15"/>
-          <p:cNvSpPr txBox="1"/>
-          <p:nvPr/>
-        </p:nvSpPr>
-        <p:spPr>
-          <a:xfrm>
-            <a:off x="7178040" y="5413248"/>
-            <a:ext cx="3931920" cy="411480"/>
-          </a:xfrm>
-          <a:prstGeom prst="rect">
-            <a:avLst/>
-          </a:prstGeom>
-          <a:noFill/>
-          <a:ln/>
-        </p:spPr>
-        <p:txBody>
-          <a:bodyPr wrap="square" lIns="0" tIns="0" rIns="0" bIns="0" rtlCol="0" anchor="t"/>
-          <a:lstStyle/>
-          <a:p>
-            <a:pPr indent="0" marL="0">
-              <a:buNone/>
-            </a:pPr>
-            <a:r>
-              <a:rPr lang="en-US" sz="1250" dirty="0">
-                <a:solidFill>
-                  <a:srgbClr val="424245"/>
-                </a:solidFill>
-                <a:latin typeface="Calibri" pitchFamily="34" charset="0"/>
-                <a:ea typeface="Calibri" pitchFamily="34" charset="-122"/>
-                <a:cs typeface="Calibri" pitchFamily="34" charset="-120"/>
-              </a:rPr>
-              <a:t>RAM, flash, microseconds per packet, milliseconds and millijoules per update</a:t>
-            </a:r>
-            <a:endParaRPr lang="en-US" sz="1250" dirty="0"/>
-          </a:p>
-        </p:txBody>
-      </p:sp>
-      <p:sp>
-        <p:nvSpPr>
-          <p:cNvPr id="19" name="Text 16"/>
           <p:cNvSpPr txBox="1"/>
           <p:nvPr/>
         </p:nvSpPr>

</xml_diff>

<commit_message>
Real-data check on N-BaIoT and a from-zero read-up
Runs the detectors on real Danmini doorbell traffic and real Mirai attacks
from N-BaIoT, with a modelled boiling-frog poisoner. Naive adaptation is
poisoned at a 10% attacker share; Threat-Orthogonal Adaptation keeps 100%
detection with about 0.8% false alarms across the scan, ack and syn attacks.
A second device joining shows a single self-learning detector cannot absorb
a new device, which points to per-device detectors.

Adds a 13-chapter beginner read-up with explanatory diagrams, and updates the
deck and presentation notes with the real-data result.
</commit_message>
<xml_diff>
--- a/CSD457_First_Presentation.pptx
+++ b/CSD457_First_Presentation.pptx
@@ -601,7 +601,7 @@
           <a:p>
             <a:r>
               <a:rPr lang="en-US" dirty="0"/>
-              <a:t>About 60 seconds. Say clearly this is synthetic. Left: red is naive learning, poisoned in 24 cycles. Middle: freezing defenses keep the attack visible but false alarms explode once drift starts. Right: the attacker leaves at cycle 45 and the frozen defense never recovers. Blue is ours everywhere. Next: the same experiment on N-BaIoT and the ESP32.</a:t>
+              <a:t>About 60 seconds. Say the chart is synthetic, then give the real N-BaIoT numbers in the caption: poisoned at only 10 percent share, ours 100 percent detection. Left: red is naive learning, poisoned in 24 cycles. Middle: freezing defenses keep the attack visible but false alarms explode once drift starts. Right: the attacker leaves at cycle 45 and the frozen defense never recovers. Blue is ours everywhere. Next: the same experiment on N-BaIoT and the ESP32.</a:t>
             </a:r>
             <a:endParaRPr lang="en-US" dirty="0"/>
           </a:p>
@@ -2194,7 +2194,7 @@
                 <a:ea typeface="Calibri" pitchFamily="34" charset="-122"/>
                 <a:cs typeface="Calibri" pitchFamily="34" charset="-120"/>
               </a:rPr>
-              <a:t>We already tested the idea in simulation.</a:t>
+              <a:t>We already tested it, in simulation and on real IoT traffic.</a:t>
             </a:r>
             <a:endParaRPr lang="en-US" sz="2800" dirty="0"/>
           </a:p>
@@ -2257,7 +2257,7 @@
                 <a:ea typeface="Calibri" pitchFamily="34" charset="-122"/>
                 <a:cs typeface="Calibri" pitchFamily="34" charset="-120"/>
               </a:rPr>
-              <a:t>Our own synthetic simulation, 5 seeds, attacker at 40% of traffic [2]. Grey band = honest drift, dashed line = poisoning starts. Naive learning loses the attack in 24 cycles; freezing defenses keep it but drown in false alarms; ours keeps both.</a:t>
+              <a:t>Above: synthetic simulation, 5 seeds, attacker at 40% [2]. Real check on N-BaIoT doorbell traffic [4]: naive learning was poisoned with the attacker at just 10% of traffic, while ours kept 100% detection with 0.8% false alarms.</a:t>
             </a:r>
             <a:endParaRPr lang="en-US" sz="1250" dirty="0"/>
           </a:p>

</xml_diff>

<commit_message>
Update notes with the signature-free defense results
Deck speaker notes, the presentation Q&A and the read-up now explain the
signature-free version, its real-data results against both attackers, and
the open problem of attacks hidden inside strong genuine drift.
</commit_message>
<xml_diff>
--- a/CSD457_First_Presentation.pptx
+++ b/CSD457_First_Presentation.pptx
@@ -689,7 +689,7 @@
           <a:p>
             <a:r>
               <a:rPr lang="en-US" dirty="0"/>
-              <a:t>About 40 seconds, then questions. Is this just ANTIDOTE? No: ANTIDOTE retrains a PCA model on a server in batches; ours learns continuously on a microcontroller and never freezes. Attacks with no known signature? Honest limit: we need a signature; we will try directions learned from our own alarms. Honest drift toward an attack? In simulation false alarms peaked near 7 percent, then recovered. Is the simulation real data? No, real data by mid-review.</a:t>
+              <a:t>About 40 seconds, then questions. Is this just ANTIDOTE? No: ANTIDOTE retrains a PCA model on a server in batches; ours learns continuously on a microcontroller and never freezes. Does it need attack signatures? No: a signature-free version already beats both a normal and a smart attacker on real N-BaIoT traffic; signatures are an optional extra floor for key attacks. Its open weakness is an attack hidden inside strong genuine drift. Honest drift toward an attack? In simulation false alarms peaked near 7 percent, then recovered. Is the simulation real data? No, real data by mid-review.</a:t>
             </a:r>
             <a:endParaRPr lang="en-US" dirty="0"/>
           </a:p>
@@ -1305,7 +1305,7 @@
           <a:p>
             <a:r>
               <a:rPr lang="en-US" dirty="0"/>
-              <a:t>About 60 seconds. One line: honest drift can go anywhere, poisoning has to go toward the attack. So we ration only that direction. On an ESP32 it is a few dot products per update.</a:t>
+              <a:t>About 60 seconds. One line: honest drift can go anywhere, poisoning has to go toward the attack. So we ration only that direction. On an ESP32 it is a few dot products per update. If asked whether it needs attack signatures: this slide shows the version that uses them for known attacks like Mirai. We also built a signature-free version: it learns only from the dense core of traffic and accepts a change only if the whole traffic cloud moves with it, because honest drift moves everything while poison moves one part. On real N-BaIoT doorbell traffic it kept 100 percent detection of Mirai scan, ack and syn against both a normal attacker and a smart attacker who knows the defense, with 0.2 to 1.5 percent false alarms. Its open weakness is an attack hidden inside strong genuine drift, so our plan combines both: signature-free by default, signatures as a guaranteed floor for the most important attacks.</a:t>
             </a:r>
             <a:endParaRPr lang="en-US" dirty="0"/>
           </a:p>

</xml_diff>

<commit_message>
Add progress report; correct the attacker-share wording
New 8-page progress report: what changed since the proposal deck, results so
far, the peer-witnessed (FOA) direction, ESP32 parts list with system and INA219
wiring diagrams, tests, plan, mid-review checklist and risks.

Correction: naive learning fails at a 10% attacker share only for the Mirai
scan attack; for ack and syn it takes 20%. Deck slide 10, presentation notes
and the read-up now say 10 to 20%. Also states that the strong-drift test
defeats the signature-free version in three of four settings, not all four.
</commit_message>
<xml_diff>
--- a/CSD457_First_Presentation.pptx
+++ b/CSD457_First_Presentation.pptx
@@ -601,7 +601,7 @@
           <a:p>
             <a:r>
               <a:rPr lang="en-US" dirty="0"/>
-              <a:t>About 60 seconds. Say the chart is synthetic, then give the real N-BaIoT numbers in the caption: poisoned at only 10 percent share, ours 100 percent detection. Left: red is naive learning, poisoned in 24 cycles. Middle: freezing defenses keep the attack visible but false alarms explode once drift starts. Right: the attacker leaves at cycle 45 and the frozen defense never recovers. Blue is ours everywhere. Next: the same experiment on N-BaIoT and the ESP32.</a:t>
+              <a:t>About 60 seconds. Say the chart is synthetic, then give the real N-BaIoT numbers in the caption: poisoned at only 10 to 20 percent share (10 for scan, 20 for ack and syn), ours 100 percent detection. Left: red is naive learning, poisoned in 24 cycles. Middle: freezing defenses keep the attack visible but false alarms explode once drift starts. Right: the attacker leaves at cycle 45 and the frozen defense never recovers. Blue is ours everywhere. Next: the same experiment on N-BaIoT and the ESP32.</a:t>
             </a:r>
             <a:endParaRPr lang="en-US" dirty="0"/>
           </a:p>
@@ -2118,6 +2118,10 @@
           </a:solidFill>
           <a:ln/>
         </p:spPr>
+        <p:txBody>
+          <a:bodyPr/>
+          <a:p/>
+        </p:txBody>
       </p:sp>
       <p:sp>
         <p:nvSpPr>
@@ -2257,7 +2261,7 @@
                 <a:ea typeface="Calibri" pitchFamily="34" charset="-122"/>
                 <a:cs typeface="Calibri" pitchFamily="34" charset="-120"/>
               </a:rPr>
-              <a:t>Above: synthetic simulation, 5 seeds, attacker at 40% [2]. Real check on N-BaIoT doorbell traffic [4]: naive learning was poisoned with the attacker at just 10% of traffic, while ours kept 100% detection with 0.8% false alarms.</a:t>
+              <a:t>Above: synthetic simulation, 5 seeds, attacker at 40% [2]. Real check on N-BaIoT doorbell traffic [4]: naive learning was poisoned with the attacker at only 10 to 20% of traffic, while ours kept 100% detection with 0.8% false alarms.</a:t>
             </a:r>
             <a:endParaRPr lang="en-US" sz="1250" dirty="0"/>
           </a:p>

</xml_diff>